<commit_message>
Phase 2 document and deck: audit corrections, comparison split by protocol
- Table 11.4 / 15.1 / Template 17.2: parameter counts from braindecode 1.8.1 at 875 and
  1,125 samples. EEGNet 3,188 / 3,700; 2,548 corresponds to a ~2.2 s window. The old
  4,096 (EEG-TCNet) and 553,654 (DeepConvNet) are replaced.
- New Table 15.2: CTNet paper's LOSO table as the cross-subject reference, method stated.
- New Table 15.3: within-subject figures with source and protocol; 71.50% removed.
- Deck: new slide 10 "Published results, split by protocol" (13 slides).
- HANDOFF.md: 68-70% LOSO claim and SATrans-Net 72.33% withdrawn, tables updated.
- Builders write output next to the script (__dirname), not /home/sandbox/review2.
</commit_message>
<xml_diff>
--- a/Neural Decoder using EEG & Motor Imagery/Phase2_Presentation.pptx
+++ b/Neural Decoder using EEG & Motor Imagery/Phase2_Presentation.pptx
@@ -17,9 +17,10 @@
     <p:sldId id="265" r:id="rId11"/>
     <p:sldId id="266" r:id="rId12"/>
     <p:sldId id="267" r:id="rId13"/>
+    <p:sldId id="268" r:id="rId14"/>
   </p:sldIdLst>
   <p:notesMasterIdLst>
-    <p:notesMasterId r:id="rId14"/>
+    <p:notesMasterId r:id="rId15"/>
   </p:notesMasterIdLst>
   <p:sldSz cx="12192000" cy="6858000"/>
   <p:notesSz cx="6858000" cy="12192000"/>
@@ -601,7 +602,7 @@
           <a:p>
             <a:r>
               <a:rPr lang="en-US" dirty="0"/>
-              <a:t>Nine folds. Seven training subjects, one validation subject, one test subject. The validation subject is held out too, which matters for honest hyperparameter selection.</a:t>
+              <a:t>The left table is the only published comparison of these architectures under one cross-subject protocol that we could verify, so it is our reference. The right-hand figures are all within-subject and come from different evaluations: the same EEGNet scores 68.67 per cent in one and 77.39 per cent in another. An EEGNet figure of 71.50 per cent and a claim that EEGNet and Conformer reach 68 to 70 per cent under leave-one-subject-out appeared in earlier material; neither has a verifiable source, and the second was the within-subject 68.67 per cent mislabelled.</a:t>
             </a:r>
             <a:endParaRPr lang="en-US" dirty="0"/>
           </a:p>
@@ -689,7 +690,7 @@
           <a:p>
             <a:r>
               <a:rPr lang="en-US" dirty="0"/>
-              <a:t>Say this explicitly: nothing on the left has been measured. The novelty claim is modest and deliberate — a careful comparative study plus a concrete lightweight design.</a:t>
+              <a:t>Nine folds. Seven training subjects, one validation subject, one test subject. The validation subject is held out too, which matters for honest hyperparameter selection.</a:t>
             </a:r>
             <a:endParaRPr lang="en-US" dirty="0"/>
           </a:p>
@@ -777,7 +778,7 @@
           <a:p>
             <a:r>
               <a:rPr lang="en-US" dirty="0"/>
-              <a:t>Close here. The point of Phase 2 is that the survey has become a concrete plan that fits the remaining time.</a:t>
+              <a:t>Say this explicitly: nothing on the left has been measured. The novelty claim is modest and deliberate — a careful comparative study plus a concrete lightweight design.</a:t>
             </a:r>
             <a:endParaRPr lang="en-US" dirty="0"/>
           </a:p>
@@ -801,6 +802,94 @@
             <a:fld id="{F7021451-1387-4CA6-816F-3879F97B5CBC}" type="slidenum">
               <a:rPr lang="en-US"/>
               <a:t>12</a:t>
+            </a:fld>
+            <a:endParaRPr lang="en-US"/>
+          </a:p>
+        </p:txBody>
+      </p:sp>
+    </p:spTree>
+    <p:extLst>
+      <p:ext uri="{BB962C8B-B14F-4D97-AF65-F5344CB8AC3E}">
+        <p14:creationId xmlns:p14="http://schemas.microsoft.com/office/powerpoint/2010/main" val="1024086991"/>
+      </p:ext>
+    </p:extLst>
+  </p:cSld>
+  <p:clrMapOvr>
+    <a:masterClrMapping/>
+  </p:clrMapOvr>
+</p:notes>
+</file>
+
+<file path=ppt/notesSlides/notesSlide13.xml><?xml version="1.0" encoding="utf-8"?>
+<p:notes xmlns:a="http://schemas.openxmlformats.org/drawingml/2006/main" xmlns:r="http://schemas.openxmlformats.org/officeDocument/2006/relationships" xmlns:p="http://schemas.openxmlformats.org/presentationml/2006/main">
+  <p:cSld>
+    <p:spTree>
+      <p:nvGrpSpPr>
+        <p:cNvPr id="1" name=""/>
+        <p:cNvGrpSpPr/>
+        <p:nvPr/>
+      </p:nvGrpSpPr>
+      <p:grpSpPr>
+        <a:xfrm>
+          <a:off x="0" y="0"/>
+          <a:ext cx="0" cy="0"/>
+          <a:chOff x="0" y="0"/>
+          <a:chExt cx="0" cy="0"/>
+        </a:xfrm>
+      </p:grpSpPr>
+      <p:sp>
+        <p:nvSpPr>
+          <p:cNvPr id="2" name="Slide Image Placeholder 1"/>
+          <p:cNvSpPr>
+            <a:spLocks noGrp="1" noRot="1" noChangeAspect="1"/>
+          </p:cNvSpPr>
+          <p:nvPr>
+            <p:ph type="sldImg"/>
+          </p:nvPr>
+        </p:nvSpPr>
+        <p:spPr/>
+      </p:sp>
+      <p:sp>
+        <p:nvSpPr>
+          <p:cNvPr id="3" name="Notes Placeholder 2"/>
+          <p:cNvSpPr>
+            <a:spLocks noGrp="1"/>
+          </p:cNvSpPr>
+          <p:nvPr>
+            <p:ph type="body" idx="1"/>
+          </p:nvPr>
+        </p:nvSpPr>
+        <p:spPr/>
+        <p:txBody>
+          <a:bodyPr/>
+          <a:lstStyle/>
+          <a:p>
+            <a:r>
+              <a:rPr lang="en-US" dirty="0"/>
+              <a:t>Close here. The point of Phase 2 is that the survey has become a concrete plan that fits the remaining time.</a:t>
+            </a:r>
+            <a:endParaRPr lang="en-US" dirty="0"/>
+          </a:p>
+        </p:txBody>
+      </p:sp>
+      <p:sp>
+        <p:nvSpPr>
+          <p:cNvPr id="4" name="Slide Number Placeholder 3"/>
+          <p:cNvSpPr>
+            <a:spLocks noGrp="1"/>
+          </p:cNvSpPr>
+          <p:nvPr>
+            <p:ph type="sldNum" sz="quarter" idx="10"/>
+          </p:nvPr>
+        </p:nvSpPr>
+        <p:spPr/>
+        <p:txBody>
+          <a:bodyPr/>
+          <a:lstStyle/>
+          <a:p>
+            <a:fld id="{F7021451-1387-4CA6-816F-3879F97B5CBC}" type="slidenum">
+              <a:rPr lang="en-US"/>
+              <a:t>13</a:t>
             </a:fld>
             <a:endParaRPr lang="en-US"/>
           </a:p>
@@ -1481,7 +1570,7 @@
           <a:p>
             <a:r>
               <a:rPr lang="en-US" dirty="0"/>
-              <a:t>Important point to make aloud: the published numbers use different protocols. EEGNet is quoted at 68.67 per cent by one paper and 71.50 by another, for the same model on the same dataset.</a:t>
+              <a:t>Important point to make aloud: the published numbers use different protocols. EEGNet is 68.67 per cent in the ATCNet repository's evaluation and 77.39 per cent in the CTNet paper's re-implementation, for the same model on the same dataset.</a:t>
             </a:r>
             <a:endParaRPr lang="en-US" dirty="0"/>
           </a:p>
@@ -2476,7 +2565,7 @@
                 <a:ea typeface="Calibri" pitchFamily="34" charset="-122"/>
                 <a:cs typeface="Calibri" pitchFamily="34" charset="-120"/>
               </a:rPr>
-              <a:t>EVALUATION STRATEGY</a:t>
+              <a:t>PUBLISHED RESULTS</a:t>
             </a:r>
             <a:endParaRPr lang="en-US" sz="1050" dirty="0"/>
           </a:p>
@@ -2515,7 +2604,7 @@
                 <a:ea typeface="Cambria" pitchFamily="34" charset="-122"/>
                 <a:cs typeface="Cambria" pitchFamily="34" charset="-120"/>
               </a:rPr>
-              <a:t>Leave-one-subject-out evaluation</a:t>
+              <a:t>Published results, split by protocol</a:t>
             </a:r>
             <a:endParaRPr lang="en-US" sz="2700" dirty="0"/>
           </a:p>
@@ -2560,67 +2649,16 @@
           </a:p>
         </p:txBody>
       </p:sp>
-      <p:pic>
-        <p:nvPicPr>
-          <p:cNvPr id="5" name="Image 0" descr="fig/f_loso_concept.png">    </p:cNvPr>
-          <p:cNvPicPr>
-            <a:picLocks noChangeAspect="1"/>
-          </p:cNvPicPr>
-          <p:nvPr/>
-        </p:nvPicPr>
-        <p:blipFill>
-          <a:blip r:embed="rId1"/>
-          <a:stretch>
-            <a:fillRect/>
-          </a:stretch>
-        </p:blipFill>
-        <p:spPr>
-          <a:xfrm>
-            <a:off x="896112" y="1261872"/>
-            <a:ext cx="10378440" cy="3312268"/>
-          </a:xfrm>
-          <a:prstGeom prst="rect">
-            <a:avLst/>
-          </a:prstGeom>
-        </p:spPr>
-      </p:pic>
-      <p:sp>
-        <p:nvSpPr>
-          <p:cNvPr id="6" name="Shape 3"/>
-          <p:cNvSpPr/>
-          <p:nvPr/>
-        </p:nvSpPr>
-        <p:spPr>
-          <a:xfrm>
-            <a:off x="566928" y="4830172"/>
-            <a:ext cx="2670048" cy="1024128"/>
-          </a:xfrm>
-          <a:prstGeom prst="roundRect">
-            <a:avLst>
-              <a:gd name="adj" fmla="val 6250"/>
-            </a:avLst>
-          </a:prstGeom>
-          <a:solidFill>
-            <a:srgbClr val="EFF3F9"/>
-          </a:solidFill>
-          <a:ln w="12700">
-            <a:solidFill>
-              <a:srgbClr val="EFF3F9"/>
-            </a:solidFill>
-            <a:prstDash val="solid"/>
-          </a:ln>
-        </p:spPr>
-      </p:sp>
-      <p:sp>
-        <p:nvSpPr>
-          <p:cNvPr id="7" name="Text 4"/>
+      <p:sp>
+        <p:nvSpPr>
+          <p:cNvPr id="5" name="Text 3"/>
           <p:cNvSpPr txBox="1"/>
           <p:nvPr/>
         </p:nvSpPr>
         <p:spPr>
           <a:xfrm>
-            <a:off x="749808" y="4958188"/>
-            <a:ext cx="2304288" cy="274320"/>
+            <a:off x="566928" y="1280160"/>
+            <a:ext cx="5074920" cy="329184"/>
           </a:xfrm>
           <a:prstGeom prst="rect">
             <a:avLst/>
@@ -2636,30 +2674,2809 @@
               <a:buNone/>
             </a:pPr>
             <a:r>
-              <a:rPr lang="en-US" sz="1200" b="1" dirty="0">
+              <a:rPr lang="en-US" sz="1250" b="1" dirty="0">
                 <a:solidFill>
-                  <a:srgbClr val="1B3A6B"/>
+                  <a:srgbClr val="5B3E96"/>
                 </a:solidFill>
                 <a:latin typeface="Calibri" pitchFamily="34" charset="0"/>
                 <a:ea typeface="Calibri" pitchFamily="34" charset="-122"/>
                 <a:cs typeface="Calibri" pitchFamily="34" charset="-120"/>
               </a:rPr>
-              <a:t>Accuracy</a:t>
+              <a:t>Cross-subject: one protocol for all (Zhao et al., 2024)</a:t>
             </a:r>
-            <a:endParaRPr lang="en-US" sz="1200" dirty="0"/>
+            <a:endParaRPr lang="en-US" sz="1250" dirty="0"/>
           </a:p>
         </p:txBody>
       </p:sp>
       <p:sp>
         <p:nvSpPr>
-          <p:cNvPr id="8" name="Text 5"/>
+          <p:cNvPr id="6" name="Text 4"/>
           <p:cNvSpPr txBox="1"/>
           <p:nvPr/>
         </p:nvSpPr>
         <p:spPr>
           <a:xfrm>
-            <a:off x="749808" y="5241652"/>
-            <a:ext cx="2304288" cy="548640"/>
+            <a:off x="6053328" y="1280160"/>
+            <a:ext cx="5541264" cy="329184"/>
+          </a:xfrm>
+          <a:prstGeom prst="rect">
+            <a:avLst/>
+          </a:prstGeom>
+          <a:noFill/>
+          <a:ln/>
+        </p:spPr>
+        <p:txBody>
+          <a:bodyPr wrap="square" lIns="0" tIns="0" rIns="0" bIns="0" rtlCol="0" anchor="ctr"/>
+          <a:lstStyle/>
+          <a:p>
+            <a:pPr indent="0" marL="0">
+              <a:buNone/>
+            </a:pPr>
+            <a:r>
+              <a:rPr lang="en-US" sz="1250" b="1" dirty="0">
+                <a:solidFill>
+                  <a:srgbClr val="5B3E96"/>
+                </a:solidFill>
+                <a:latin typeface="Calibri" pitchFamily="34" charset="0"/>
+                <a:ea typeface="Calibri" pitchFamily="34" charset="-122"/>
+                <a:cs typeface="Calibri" pitchFamily="34" charset="-120"/>
+              </a:rPr>
+              <a:t>Within-subject: different protocols, not comparable</a:t>
+            </a:r>
+            <a:endParaRPr lang="en-US" sz="1250" dirty="0"/>
+          </a:p>
+        </p:txBody>
+      </p:sp>
+      <p:graphicFrame>
+        <p:nvGraphicFramePr>
+          <p:cNvPr id="11" name="Table 0"/>
+          <p:cNvGraphicFramePr>
+            <a:graphicFrameLocks noGrp="1"/>
+          </p:cNvGraphicFramePr>
+          <p:nvPr>
+            <p:extLst>
+              <p:ext uri="{D42A27DB-BD31-4B8C-83A1-F6EECF244321}">
+                <p14:modId xmlns:p14="http://schemas.microsoft.com/office/powerpoint/2010/main" val="1579011935"/>
+              </p:ext>
+            </p:extLst>
+          </p:nvPr>
+        </p:nvGraphicFramePr>
+        <p:xfrm>
+          <a:off x="566928" y="1691640"/>
+          <a:ext cx="5074920" cy="914400"/>
+        </p:xfrm>
+        <a:graphic>
+          <a:graphicData uri="http://schemas.openxmlformats.org/drawingml/2006/table">
+            <a:tbl>
+              <a:tblPr/>
+              <a:tblGrid>
+                <a:gridCol w="1874520"/>
+                <a:gridCol w="2148840"/>
+                <a:gridCol w="1051560"/>
+              </a:tblGrid>
+              <a:tr h="365760">
+                <a:tc>
+                  <a:txBody>
+                    <a:bodyPr/>
+                    <a:lstStyle/>
+                    <a:p>
+                      <a:pPr algn="l" indent="0" marL="0">
+                        <a:buNone/>
+                      </a:pPr>
+                      <a:r>
+                        <a:rPr lang="en-US" sz="1050" b="1" dirty="0">
+                          <a:solidFill>
+                            <a:srgbClr val="FFFFFF"/>
+                          </a:solidFill>
+                          <a:latin typeface="Calibri" pitchFamily="34" charset="0"/>
+                          <a:ea typeface="Calibri" pitchFamily="34" charset="-122"/>
+                          <a:cs typeface="Calibri" pitchFamily="34" charset="-120"/>
+                        </a:rPr>
+                        <a:t>Model</a:t>
+                      </a:r>
+                      <a:endParaRPr lang="en-US" sz="1050" dirty="0">
+                        <a:latin typeface="Calibri" charset="0"/>
+                        <a:ea typeface="Calibri" charset="0"/>
+                        <a:cs typeface="Calibri" charset="0"/>
+                      </a:endParaRPr>
+                    </a:p>
+                  </a:txBody>
+                  <a:tcPr marL="101600" marR="101600" marT="38100" marB="38100" anchor="ctr">
+                    <a:lnL w="6350" cap="flat" cmpd="sng" algn="ctr">
+                      <a:solidFill>
+                        <a:srgbClr val="D5DDEA"/>
+                      </a:solidFill>
+                      <a:prstDash val="solid"/>
+                      <a:round/>
+                      <a:headEnd type="none" w="med" len="med"/>
+                      <a:tailEnd type="none" w="med" len="med"/>
+                    </a:lnL>
+                    <a:lnR w="6350" cap="flat" cmpd="sng" algn="ctr">
+                      <a:solidFill>
+                        <a:srgbClr val="D5DDEA"/>
+                      </a:solidFill>
+                      <a:prstDash val="solid"/>
+                      <a:round/>
+                      <a:headEnd type="none" w="med" len="med"/>
+                      <a:tailEnd type="none" w="med" len="med"/>
+                    </a:lnR>
+                    <a:lnT w="6350" cap="flat" cmpd="sng" algn="ctr">
+                      <a:solidFill>
+                        <a:srgbClr val="D5DDEA"/>
+                      </a:solidFill>
+                      <a:prstDash val="solid"/>
+                      <a:round/>
+                      <a:headEnd type="none" w="med" len="med"/>
+                      <a:tailEnd type="none" w="med" len="med"/>
+                    </a:lnT>
+                    <a:lnB w="6350" cap="flat" cmpd="sng" algn="ctr">
+                      <a:solidFill>
+                        <a:srgbClr val="D5DDEA"/>
+                      </a:solidFill>
+                      <a:prstDash val="solid"/>
+                      <a:round/>
+                      <a:headEnd type="none" w="med" len="med"/>
+                      <a:tailEnd type="none" w="med" len="med"/>
+                    </a:lnB>
+                    <a:solidFill>
+                      <a:srgbClr val="1B3A6B"/>
+                    </a:solidFill>
+                  </a:tcPr>
+                </a:tc>
+                <a:tc>
+                  <a:txBody>
+                    <a:bodyPr/>
+                    <a:lstStyle/>
+                    <a:p>
+                      <a:pPr algn="ctr" indent="0" marL="0">
+                        <a:buNone/>
+                      </a:pPr>
+                      <a:r>
+                        <a:rPr lang="en-US" sz="1050" b="1" dirty="0">
+                          <a:solidFill>
+                            <a:srgbClr val="FFFFFF"/>
+                          </a:solidFill>
+                          <a:latin typeface="Calibri" pitchFamily="34" charset="0"/>
+                          <a:ea typeface="Calibri" pitchFamily="34" charset="-122"/>
+                          <a:cs typeface="Calibri" pitchFamily="34" charset="-120"/>
+                        </a:rPr>
+                        <a:t>Unseen person</a:t>
+                      </a:r>
+                      <a:endParaRPr lang="en-US" sz="1050" dirty="0">
+                        <a:latin typeface="Calibri" charset="0"/>
+                        <a:ea typeface="Calibri" charset="0"/>
+                        <a:cs typeface="Calibri" charset="0"/>
+                      </a:endParaRPr>
+                    </a:p>
+                  </a:txBody>
+                  <a:tcPr marL="101600" marR="101600" marT="38100" marB="38100" anchor="ctr">
+                    <a:lnL w="6350" cap="flat" cmpd="sng" algn="ctr">
+                      <a:solidFill>
+                        <a:srgbClr val="D5DDEA"/>
+                      </a:solidFill>
+                      <a:prstDash val="solid"/>
+                      <a:round/>
+                      <a:headEnd type="none" w="med" len="med"/>
+                      <a:tailEnd type="none" w="med" len="med"/>
+                    </a:lnL>
+                    <a:lnR w="6350" cap="flat" cmpd="sng" algn="ctr">
+                      <a:solidFill>
+                        <a:srgbClr val="D5DDEA"/>
+                      </a:solidFill>
+                      <a:prstDash val="solid"/>
+                      <a:round/>
+                      <a:headEnd type="none" w="med" len="med"/>
+                      <a:tailEnd type="none" w="med" len="med"/>
+                    </a:lnR>
+                    <a:lnT w="6350" cap="flat" cmpd="sng" algn="ctr">
+                      <a:solidFill>
+                        <a:srgbClr val="D5DDEA"/>
+                      </a:solidFill>
+                      <a:prstDash val="solid"/>
+                      <a:round/>
+                      <a:headEnd type="none" w="med" len="med"/>
+                      <a:tailEnd type="none" w="med" len="med"/>
+                    </a:lnT>
+                    <a:lnB w="6350" cap="flat" cmpd="sng" algn="ctr">
+                      <a:solidFill>
+                        <a:srgbClr val="D5DDEA"/>
+                      </a:solidFill>
+                      <a:prstDash val="solid"/>
+                      <a:round/>
+                      <a:headEnd type="none" w="med" len="med"/>
+                      <a:tailEnd type="none" w="med" len="med"/>
+                    </a:lnB>
+                    <a:solidFill>
+                      <a:srgbClr val="1B3A6B"/>
+                    </a:solidFill>
+                  </a:tcPr>
+                </a:tc>
+                <a:tc>
+                  <a:txBody>
+                    <a:bodyPr/>
+                    <a:lstStyle/>
+                    <a:p>
+                      <a:pPr algn="ctr" indent="0" marL="0">
+                        <a:buNone/>
+                      </a:pPr>
+                      <a:r>
+                        <a:rPr lang="en-US" sz="1050" b="1" dirty="0">
+                          <a:solidFill>
+                            <a:srgbClr val="FFFFFF"/>
+                          </a:solidFill>
+                          <a:latin typeface="Calibri" pitchFamily="34" charset="0"/>
+                          <a:ea typeface="Calibri" pitchFamily="34" charset="-122"/>
+                          <a:cs typeface="Calibri" pitchFamily="34" charset="-120"/>
+                        </a:rPr>
+                        <a:t>Kappa</a:t>
+                      </a:r>
+                      <a:endParaRPr lang="en-US" sz="1050" dirty="0">
+                        <a:latin typeface="Calibri" charset="0"/>
+                        <a:ea typeface="Calibri" charset="0"/>
+                        <a:cs typeface="Calibri" charset="0"/>
+                      </a:endParaRPr>
+                    </a:p>
+                  </a:txBody>
+                  <a:tcPr marL="101600" marR="101600" marT="38100" marB="38100" anchor="ctr">
+                    <a:lnL w="6350" cap="flat" cmpd="sng" algn="ctr">
+                      <a:solidFill>
+                        <a:srgbClr val="D5DDEA"/>
+                      </a:solidFill>
+                      <a:prstDash val="solid"/>
+                      <a:round/>
+                      <a:headEnd type="none" w="med" len="med"/>
+                      <a:tailEnd type="none" w="med" len="med"/>
+                    </a:lnL>
+                    <a:lnR w="6350" cap="flat" cmpd="sng" algn="ctr">
+                      <a:solidFill>
+                        <a:srgbClr val="D5DDEA"/>
+                      </a:solidFill>
+                      <a:prstDash val="solid"/>
+                      <a:round/>
+                      <a:headEnd type="none" w="med" len="med"/>
+                      <a:tailEnd type="none" w="med" len="med"/>
+                    </a:lnR>
+                    <a:lnT w="6350" cap="flat" cmpd="sng" algn="ctr">
+                      <a:solidFill>
+                        <a:srgbClr val="D5DDEA"/>
+                      </a:solidFill>
+                      <a:prstDash val="solid"/>
+                      <a:round/>
+                      <a:headEnd type="none" w="med" len="med"/>
+                      <a:tailEnd type="none" w="med" len="med"/>
+                    </a:lnT>
+                    <a:lnB w="6350" cap="flat" cmpd="sng" algn="ctr">
+                      <a:solidFill>
+                        <a:srgbClr val="D5DDEA"/>
+                      </a:solidFill>
+                      <a:prstDash val="solid"/>
+                      <a:round/>
+                      <a:headEnd type="none" w="med" len="med"/>
+                      <a:tailEnd type="none" w="med" len="med"/>
+                    </a:lnB>
+                    <a:solidFill>
+                      <a:srgbClr val="1B3A6B"/>
+                    </a:solidFill>
+                  </a:tcPr>
+                </a:tc>
+              </a:tr>
+              <a:tr h="384048">
+                <a:tc>
+                  <a:txBody>
+                    <a:bodyPr/>
+                    <a:lstStyle/>
+                    <a:p>
+                      <a:pPr algn="l" indent="0" marL="0">
+                        <a:buNone/>
+                      </a:pPr>
+                      <a:r>
+                        <a:rPr lang="en-US" sz="1100" b="1" dirty="0">
+                          <a:solidFill>
+                            <a:srgbClr val="122847"/>
+                          </a:solidFill>
+                          <a:latin typeface="Calibri" pitchFamily="34" charset="0"/>
+                          <a:ea typeface="Calibri" pitchFamily="34" charset="-122"/>
+                          <a:cs typeface="Calibri" pitchFamily="34" charset="-120"/>
+                        </a:rPr>
+                        <a:t>ShallowConvNet+</a:t>
+                      </a:r>
+                      <a:endParaRPr lang="en-US" sz="1100" dirty="0">
+                        <a:latin typeface="Calibri" charset="0"/>
+                        <a:ea typeface="Calibri" charset="0"/>
+                        <a:cs typeface="Calibri" charset="0"/>
+                      </a:endParaRPr>
+                    </a:p>
+                  </a:txBody>
+                  <a:tcPr marL="101600" marR="101600" marT="38100" marB="38100" anchor="ctr">
+                    <a:lnL w="6350" cap="flat" cmpd="sng" algn="ctr">
+                      <a:solidFill>
+                        <a:srgbClr val="D5DDEA"/>
+                      </a:solidFill>
+                      <a:prstDash val="solid"/>
+                      <a:round/>
+                      <a:headEnd type="none" w="med" len="med"/>
+                      <a:tailEnd type="none" w="med" len="med"/>
+                    </a:lnL>
+                    <a:lnR w="6350" cap="flat" cmpd="sng" algn="ctr">
+                      <a:solidFill>
+                        <a:srgbClr val="D5DDEA"/>
+                      </a:solidFill>
+                      <a:prstDash val="solid"/>
+                      <a:round/>
+                      <a:headEnd type="none" w="med" len="med"/>
+                      <a:tailEnd type="none" w="med" len="med"/>
+                    </a:lnR>
+                    <a:lnT w="6350" cap="flat" cmpd="sng" algn="ctr">
+                      <a:solidFill>
+                        <a:srgbClr val="D5DDEA"/>
+                      </a:solidFill>
+                      <a:prstDash val="solid"/>
+                      <a:round/>
+                      <a:headEnd type="none" w="med" len="med"/>
+                      <a:tailEnd type="none" w="med" len="med"/>
+                    </a:lnT>
+                    <a:lnB w="6350" cap="flat" cmpd="sng" algn="ctr">
+                      <a:solidFill>
+                        <a:srgbClr val="D5DDEA"/>
+                      </a:solidFill>
+                      <a:prstDash val="solid"/>
+                      <a:round/>
+                      <a:headEnd type="none" w="med" len="med"/>
+                      <a:tailEnd type="none" w="med" len="med"/>
+                    </a:lnB>
+                    <a:solidFill>
+                      <a:srgbClr val="FFFFFF"/>
+                    </a:solidFill>
+                  </a:tcPr>
+                </a:tc>
+                <a:tc>
+                  <a:txBody>
+                    <a:bodyPr/>
+                    <a:lstStyle/>
+                    <a:p>
+                      <a:pPr algn="ctr" indent="0" marL="0">
+                        <a:buNone/>
+                      </a:pPr>
+                      <a:r>
+                        <a:rPr lang="en-US" sz="1100" dirty="0">
+                          <a:solidFill>
+                            <a:srgbClr val="122847"/>
+                          </a:solidFill>
+                          <a:latin typeface="Calibri" pitchFamily="34" charset="0"/>
+                          <a:ea typeface="Calibri" pitchFamily="34" charset="-122"/>
+                          <a:cs typeface="Calibri" pitchFamily="34" charset="-120"/>
+                        </a:rPr>
+                        <a:t>56.75 ± 13.77</a:t>
+                      </a:r>
+                      <a:endParaRPr lang="en-US" sz="1100" dirty="0">
+                        <a:latin typeface="Calibri" charset="0"/>
+                        <a:ea typeface="Calibri" charset="0"/>
+                        <a:cs typeface="Calibri" charset="0"/>
+                      </a:endParaRPr>
+                    </a:p>
+                  </a:txBody>
+                  <a:tcPr marL="101600" marR="101600" marT="38100" marB="38100" anchor="ctr">
+                    <a:lnL w="6350" cap="flat" cmpd="sng" algn="ctr">
+                      <a:solidFill>
+                        <a:srgbClr val="D5DDEA"/>
+                      </a:solidFill>
+                      <a:prstDash val="solid"/>
+                      <a:round/>
+                      <a:headEnd type="none" w="med" len="med"/>
+                      <a:tailEnd type="none" w="med" len="med"/>
+                    </a:lnL>
+                    <a:lnR w="6350" cap="flat" cmpd="sng" algn="ctr">
+                      <a:solidFill>
+                        <a:srgbClr val="D5DDEA"/>
+                      </a:solidFill>
+                      <a:prstDash val="solid"/>
+                      <a:round/>
+                      <a:headEnd type="none" w="med" len="med"/>
+                      <a:tailEnd type="none" w="med" len="med"/>
+                    </a:lnR>
+                    <a:lnT w="6350" cap="flat" cmpd="sng" algn="ctr">
+                      <a:solidFill>
+                        <a:srgbClr val="D5DDEA"/>
+                      </a:solidFill>
+                      <a:prstDash val="solid"/>
+                      <a:round/>
+                      <a:headEnd type="none" w="med" len="med"/>
+                      <a:tailEnd type="none" w="med" len="med"/>
+                    </a:lnT>
+                    <a:lnB w="6350" cap="flat" cmpd="sng" algn="ctr">
+                      <a:solidFill>
+                        <a:srgbClr val="D5DDEA"/>
+                      </a:solidFill>
+                      <a:prstDash val="solid"/>
+                      <a:round/>
+                      <a:headEnd type="none" w="med" len="med"/>
+                      <a:tailEnd type="none" w="med" len="med"/>
+                    </a:lnB>
+                    <a:solidFill>
+                      <a:srgbClr val="FFFFFF"/>
+                    </a:solidFill>
+                  </a:tcPr>
+                </a:tc>
+                <a:tc>
+                  <a:txBody>
+                    <a:bodyPr/>
+                    <a:lstStyle/>
+                    <a:p>
+                      <a:pPr algn="ctr" indent="0" marL="0">
+                        <a:buNone/>
+                      </a:pPr>
+                      <a:r>
+                        <a:rPr lang="en-US" sz="1100" dirty="0">
+                          <a:solidFill>
+                            <a:srgbClr val="122847"/>
+                          </a:solidFill>
+                          <a:latin typeface="Calibri" pitchFamily="34" charset="0"/>
+                          <a:ea typeface="Calibri" pitchFamily="34" charset="-122"/>
+                          <a:cs typeface="Calibri" pitchFamily="34" charset="-120"/>
+                        </a:rPr>
+                        <a:t>0.4234</a:t>
+                      </a:r>
+                      <a:endParaRPr lang="en-US" sz="1100" dirty="0">
+                        <a:latin typeface="Calibri" charset="0"/>
+                        <a:ea typeface="Calibri" charset="0"/>
+                        <a:cs typeface="Calibri" charset="0"/>
+                      </a:endParaRPr>
+                    </a:p>
+                  </a:txBody>
+                  <a:tcPr marL="101600" marR="101600" marT="38100" marB="38100" anchor="ctr">
+                    <a:lnL w="6350" cap="flat" cmpd="sng" algn="ctr">
+                      <a:solidFill>
+                        <a:srgbClr val="D5DDEA"/>
+                      </a:solidFill>
+                      <a:prstDash val="solid"/>
+                      <a:round/>
+                      <a:headEnd type="none" w="med" len="med"/>
+                      <a:tailEnd type="none" w="med" len="med"/>
+                    </a:lnL>
+                    <a:lnR w="6350" cap="flat" cmpd="sng" algn="ctr">
+                      <a:solidFill>
+                        <a:srgbClr val="D5DDEA"/>
+                      </a:solidFill>
+                      <a:prstDash val="solid"/>
+                      <a:round/>
+                      <a:headEnd type="none" w="med" len="med"/>
+                      <a:tailEnd type="none" w="med" len="med"/>
+                    </a:lnR>
+                    <a:lnT w="6350" cap="flat" cmpd="sng" algn="ctr">
+                      <a:solidFill>
+                        <a:srgbClr val="D5DDEA"/>
+                      </a:solidFill>
+                      <a:prstDash val="solid"/>
+                      <a:round/>
+                      <a:headEnd type="none" w="med" len="med"/>
+                      <a:tailEnd type="none" w="med" len="med"/>
+                    </a:lnT>
+                    <a:lnB w="6350" cap="flat" cmpd="sng" algn="ctr">
+                      <a:solidFill>
+                        <a:srgbClr val="D5DDEA"/>
+                      </a:solidFill>
+                      <a:prstDash val="solid"/>
+                      <a:round/>
+                      <a:headEnd type="none" w="med" len="med"/>
+                      <a:tailEnd type="none" w="med" len="med"/>
+                    </a:lnB>
+                    <a:solidFill>
+                      <a:srgbClr val="FFFFFF"/>
+                    </a:solidFill>
+                  </a:tcPr>
+                </a:tc>
+              </a:tr>
+              <a:tr h="384048">
+                <a:tc>
+                  <a:txBody>
+                    <a:bodyPr/>
+                    <a:lstStyle/>
+                    <a:p>
+                      <a:pPr algn="l" indent="0" marL="0">
+                        <a:buNone/>
+                      </a:pPr>
+                      <a:r>
+                        <a:rPr lang="en-US" sz="1100" b="1" dirty="0">
+                          <a:solidFill>
+                            <a:srgbClr val="122847"/>
+                          </a:solidFill>
+                          <a:latin typeface="Calibri" pitchFamily="34" charset="0"/>
+                          <a:ea typeface="Calibri" pitchFamily="34" charset="-122"/>
+                          <a:cs typeface="Calibri" pitchFamily="34" charset="-120"/>
+                        </a:rPr>
+                        <a:t>DeepConvNet+</a:t>
+                      </a:r>
+                      <a:endParaRPr lang="en-US" sz="1100" dirty="0">
+                        <a:latin typeface="Calibri" charset="0"/>
+                        <a:ea typeface="Calibri" charset="0"/>
+                        <a:cs typeface="Calibri" charset="0"/>
+                      </a:endParaRPr>
+                    </a:p>
+                  </a:txBody>
+                  <a:tcPr marL="101600" marR="101600" marT="38100" marB="38100" anchor="ctr">
+                    <a:lnL w="6350" cap="flat" cmpd="sng" algn="ctr">
+                      <a:solidFill>
+                        <a:srgbClr val="D5DDEA"/>
+                      </a:solidFill>
+                      <a:prstDash val="solid"/>
+                      <a:round/>
+                      <a:headEnd type="none" w="med" len="med"/>
+                      <a:tailEnd type="none" w="med" len="med"/>
+                    </a:lnL>
+                    <a:lnR w="6350" cap="flat" cmpd="sng" algn="ctr">
+                      <a:solidFill>
+                        <a:srgbClr val="D5DDEA"/>
+                      </a:solidFill>
+                      <a:prstDash val="solid"/>
+                      <a:round/>
+                      <a:headEnd type="none" w="med" len="med"/>
+                      <a:tailEnd type="none" w="med" len="med"/>
+                    </a:lnR>
+                    <a:lnT w="6350" cap="flat" cmpd="sng" algn="ctr">
+                      <a:solidFill>
+                        <a:srgbClr val="D5DDEA"/>
+                      </a:solidFill>
+                      <a:prstDash val="solid"/>
+                      <a:round/>
+                      <a:headEnd type="none" w="med" len="med"/>
+                      <a:tailEnd type="none" w="med" len="med"/>
+                    </a:lnT>
+                    <a:lnB w="6350" cap="flat" cmpd="sng" algn="ctr">
+                      <a:solidFill>
+                        <a:srgbClr val="D5DDEA"/>
+                      </a:solidFill>
+                      <a:prstDash val="solid"/>
+                      <a:round/>
+                      <a:headEnd type="none" w="med" len="med"/>
+                      <a:tailEnd type="none" w="med" len="med"/>
+                    </a:lnB>
+                    <a:solidFill>
+                      <a:srgbClr val="EFF3F9"/>
+                    </a:solidFill>
+                  </a:tcPr>
+                </a:tc>
+                <a:tc>
+                  <a:txBody>
+                    <a:bodyPr/>
+                    <a:lstStyle/>
+                    <a:p>
+                      <a:pPr algn="ctr" indent="0" marL="0">
+                        <a:buNone/>
+                      </a:pPr>
+                      <a:r>
+                        <a:rPr lang="en-US" sz="1100" dirty="0">
+                          <a:solidFill>
+                            <a:srgbClr val="122847"/>
+                          </a:solidFill>
+                          <a:latin typeface="Calibri" pitchFamily="34" charset="0"/>
+                          <a:ea typeface="Calibri" pitchFamily="34" charset="-122"/>
+                          <a:cs typeface="Calibri" pitchFamily="34" charset="-120"/>
+                        </a:rPr>
+                        <a:t>60.15 ± 12.71</a:t>
+                      </a:r>
+                      <a:endParaRPr lang="en-US" sz="1100" dirty="0">
+                        <a:latin typeface="Calibri" charset="0"/>
+                        <a:ea typeface="Calibri" charset="0"/>
+                        <a:cs typeface="Calibri" charset="0"/>
+                      </a:endParaRPr>
+                    </a:p>
+                  </a:txBody>
+                  <a:tcPr marL="101600" marR="101600" marT="38100" marB="38100" anchor="ctr">
+                    <a:lnL w="6350" cap="flat" cmpd="sng" algn="ctr">
+                      <a:solidFill>
+                        <a:srgbClr val="D5DDEA"/>
+                      </a:solidFill>
+                      <a:prstDash val="solid"/>
+                      <a:round/>
+                      <a:headEnd type="none" w="med" len="med"/>
+                      <a:tailEnd type="none" w="med" len="med"/>
+                    </a:lnL>
+                    <a:lnR w="6350" cap="flat" cmpd="sng" algn="ctr">
+                      <a:solidFill>
+                        <a:srgbClr val="D5DDEA"/>
+                      </a:solidFill>
+                      <a:prstDash val="solid"/>
+                      <a:round/>
+                      <a:headEnd type="none" w="med" len="med"/>
+                      <a:tailEnd type="none" w="med" len="med"/>
+                    </a:lnR>
+                    <a:lnT w="6350" cap="flat" cmpd="sng" algn="ctr">
+                      <a:solidFill>
+                        <a:srgbClr val="D5DDEA"/>
+                      </a:solidFill>
+                      <a:prstDash val="solid"/>
+                      <a:round/>
+                      <a:headEnd type="none" w="med" len="med"/>
+                      <a:tailEnd type="none" w="med" len="med"/>
+                    </a:lnT>
+                    <a:lnB w="6350" cap="flat" cmpd="sng" algn="ctr">
+                      <a:solidFill>
+                        <a:srgbClr val="D5DDEA"/>
+                      </a:solidFill>
+                      <a:prstDash val="solid"/>
+                      <a:round/>
+                      <a:headEnd type="none" w="med" len="med"/>
+                      <a:tailEnd type="none" w="med" len="med"/>
+                    </a:lnB>
+                    <a:solidFill>
+                      <a:srgbClr val="EFF3F9"/>
+                    </a:solidFill>
+                  </a:tcPr>
+                </a:tc>
+                <a:tc>
+                  <a:txBody>
+                    <a:bodyPr/>
+                    <a:lstStyle/>
+                    <a:p>
+                      <a:pPr algn="ctr" indent="0" marL="0">
+                        <a:buNone/>
+                      </a:pPr>
+                      <a:r>
+                        <a:rPr lang="en-US" sz="1100" dirty="0">
+                          <a:solidFill>
+                            <a:srgbClr val="122847"/>
+                          </a:solidFill>
+                          <a:latin typeface="Calibri" pitchFamily="34" charset="0"/>
+                          <a:ea typeface="Calibri" pitchFamily="34" charset="-122"/>
+                          <a:cs typeface="Calibri" pitchFamily="34" charset="-120"/>
+                        </a:rPr>
+                        <a:t>0.4686</a:t>
+                      </a:r>
+                      <a:endParaRPr lang="en-US" sz="1100" dirty="0">
+                        <a:latin typeface="Calibri" charset="0"/>
+                        <a:ea typeface="Calibri" charset="0"/>
+                        <a:cs typeface="Calibri" charset="0"/>
+                      </a:endParaRPr>
+                    </a:p>
+                  </a:txBody>
+                  <a:tcPr marL="101600" marR="101600" marT="38100" marB="38100" anchor="ctr">
+                    <a:lnL w="6350" cap="flat" cmpd="sng" algn="ctr">
+                      <a:solidFill>
+                        <a:srgbClr val="D5DDEA"/>
+                      </a:solidFill>
+                      <a:prstDash val="solid"/>
+                      <a:round/>
+                      <a:headEnd type="none" w="med" len="med"/>
+                      <a:tailEnd type="none" w="med" len="med"/>
+                    </a:lnL>
+                    <a:lnR w="6350" cap="flat" cmpd="sng" algn="ctr">
+                      <a:solidFill>
+                        <a:srgbClr val="D5DDEA"/>
+                      </a:solidFill>
+                      <a:prstDash val="solid"/>
+                      <a:round/>
+                      <a:headEnd type="none" w="med" len="med"/>
+                      <a:tailEnd type="none" w="med" len="med"/>
+                    </a:lnR>
+                    <a:lnT w="6350" cap="flat" cmpd="sng" algn="ctr">
+                      <a:solidFill>
+                        <a:srgbClr val="D5DDEA"/>
+                      </a:solidFill>
+                      <a:prstDash val="solid"/>
+                      <a:round/>
+                      <a:headEnd type="none" w="med" len="med"/>
+                      <a:tailEnd type="none" w="med" len="med"/>
+                    </a:lnT>
+                    <a:lnB w="6350" cap="flat" cmpd="sng" algn="ctr">
+                      <a:solidFill>
+                        <a:srgbClr val="D5DDEA"/>
+                      </a:solidFill>
+                      <a:prstDash val="solid"/>
+                      <a:round/>
+                      <a:headEnd type="none" w="med" len="med"/>
+                      <a:tailEnd type="none" w="med" len="med"/>
+                    </a:lnB>
+                    <a:solidFill>
+                      <a:srgbClr val="EFF3F9"/>
+                    </a:solidFill>
+                  </a:tcPr>
+                </a:tc>
+              </a:tr>
+              <a:tr h="384048">
+                <a:tc>
+                  <a:txBody>
+                    <a:bodyPr/>
+                    <a:lstStyle/>
+                    <a:p>
+                      <a:pPr algn="l" indent="0" marL="0">
+                        <a:buNone/>
+                      </a:pPr>
+                      <a:r>
+                        <a:rPr lang="en-US" sz="1100" b="1" dirty="0">
+                          <a:solidFill>
+                            <a:srgbClr val="122847"/>
+                          </a:solidFill>
+                          <a:latin typeface="Calibri" pitchFamily="34" charset="0"/>
+                          <a:ea typeface="Calibri" pitchFamily="34" charset="-122"/>
+                          <a:cs typeface="Calibri" pitchFamily="34" charset="-120"/>
+                        </a:rPr>
+                        <a:t>EEGNet+</a:t>
+                      </a:r>
+                      <a:endParaRPr lang="en-US" sz="1100" dirty="0">
+                        <a:latin typeface="Calibri" charset="0"/>
+                        <a:ea typeface="Calibri" charset="0"/>
+                        <a:cs typeface="Calibri" charset="0"/>
+                      </a:endParaRPr>
+                    </a:p>
+                  </a:txBody>
+                  <a:tcPr marL="101600" marR="101600" marT="38100" marB="38100" anchor="ctr">
+                    <a:lnL w="6350" cap="flat" cmpd="sng" algn="ctr">
+                      <a:solidFill>
+                        <a:srgbClr val="D5DDEA"/>
+                      </a:solidFill>
+                      <a:prstDash val="solid"/>
+                      <a:round/>
+                      <a:headEnd type="none" w="med" len="med"/>
+                      <a:tailEnd type="none" w="med" len="med"/>
+                    </a:lnL>
+                    <a:lnR w="6350" cap="flat" cmpd="sng" algn="ctr">
+                      <a:solidFill>
+                        <a:srgbClr val="D5DDEA"/>
+                      </a:solidFill>
+                      <a:prstDash val="solid"/>
+                      <a:round/>
+                      <a:headEnd type="none" w="med" len="med"/>
+                      <a:tailEnd type="none" w="med" len="med"/>
+                    </a:lnR>
+                    <a:lnT w="6350" cap="flat" cmpd="sng" algn="ctr">
+                      <a:solidFill>
+                        <a:srgbClr val="D5DDEA"/>
+                      </a:solidFill>
+                      <a:prstDash val="solid"/>
+                      <a:round/>
+                      <a:headEnd type="none" w="med" len="med"/>
+                      <a:tailEnd type="none" w="med" len="med"/>
+                    </a:lnT>
+                    <a:lnB w="6350" cap="flat" cmpd="sng" algn="ctr">
+                      <a:solidFill>
+                        <a:srgbClr val="D5DDEA"/>
+                      </a:solidFill>
+                      <a:prstDash val="solid"/>
+                      <a:round/>
+                      <a:headEnd type="none" w="med" len="med"/>
+                      <a:tailEnd type="none" w="med" len="med"/>
+                    </a:lnB>
+                    <a:solidFill>
+                      <a:srgbClr val="FFFFFF"/>
+                    </a:solidFill>
+                  </a:tcPr>
+                </a:tc>
+                <a:tc>
+                  <a:txBody>
+                    <a:bodyPr/>
+                    <a:lstStyle/>
+                    <a:p>
+                      <a:pPr algn="ctr" indent="0" marL="0">
+                        <a:buNone/>
+                      </a:pPr>
+                      <a:r>
+                        <a:rPr lang="en-US" sz="1100" dirty="0">
+                          <a:solidFill>
+                            <a:srgbClr val="122847"/>
+                          </a:solidFill>
+                          <a:latin typeface="Calibri" pitchFamily="34" charset="0"/>
+                          <a:ea typeface="Calibri" pitchFamily="34" charset="-122"/>
+                          <a:cs typeface="Calibri" pitchFamily="34" charset="-120"/>
+                        </a:rPr>
+                        <a:t>56.85 ± 15.82</a:t>
+                      </a:r>
+                      <a:endParaRPr lang="en-US" sz="1100" dirty="0">
+                        <a:latin typeface="Calibri" charset="0"/>
+                        <a:ea typeface="Calibri" charset="0"/>
+                        <a:cs typeface="Calibri" charset="0"/>
+                      </a:endParaRPr>
+                    </a:p>
+                  </a:txBody>
+                  <a:tcPr marL="101600" marR="101600" marT="38100" marB="38100" anchor="ctr">
+                    <a:lnL w="6350" cap="flat" cmpd="sng" algn="ctr">
+                      <a:solidFill>
+                        <a:srgbClr val="D5DDEA"/>
+                      </a:solidFill>
+                      <a:prstDash val="solid"/>
+                      <a:round/>
+                      <a:headEnd type="none" w="med" len="med"/>
+                      <a:tailEnd type="none" w="med" len="med"/>
+                    </a:lnL>
+                    <a:lnR w="6350" cap="flat" cmpd="sng" algn="ctr">
+                      <a:solidFill>
+                        <a:srgbClr val="D5DDEA"/>
+                      </a:solidFill>
+                      <a:prstDash val="solid"/>
+                      <a:round/>
+                      <a:headEnd type="none" w="med" len="med"/>
+                      <a:tailEnd type="none" w="med" len="med"/>
+                    </a:lnR>
+                    <a:lnT w="6350" cap="flat" cmpd="sng" algn="ctr">
+                      <a:solidFill>
+                        <a:srgbClr val="D5DDEA"/>
+                      </a:solidFill>
+                      <a:prstDash val="solid"/>
+                      <a:round/>
+                      <a:headEnd type="none" w="med" len="med"/>
+                      <a:tailEnd type="none" w="med" len="med"/>
+                    </a:lnT>
+                    <a:lnB w="6350" cap="flat" cmpd="sng" algn="ctr">
+                      <a:solidFill>
+                        <a:srgbClr val="D5DDEA"/>
+                      </a:solidFill>
+                      <a:prstDash val="solid"/>
+                      <a:round/>
+                      <a:headEnd type="none" w="med" len="med"/>
+                      <a:tailEnd type="none" w="med" len="med"/>
+                    </a:lnB>
+                    <a:solidFill>
+                      <a:srgbClr val="FFFFFF"/>
+                    </a:solidFill>
+                  </a:tcPr>
+                </a:tc>
+                <a:tc>
+                  <a:txBody>
+                    <a:bodyPr/>
+                    <a:lstStyle/>
+                    <a:p>
+                      <a:pPr algn="ctr" indent="0" marL="0">
+                        <a:buNone/>
+                      </a:pPr>
+                      <a:r>
+                        <a:rPr lang="en-US" sz="1100" dirty="0">
+                          <a:solidFill>
+                            <a:srgbClr val="122847"/>
+                          </a:solidFill>
+                          <a:latin typeface="Calibri" pitchFamily="34" charset="0"/>
+                          <a:ea typeface="Calibri" pitchFamily="34" charset="-122"/>
+                          <a:cs typeface="Calibri" pitchFamily="34" charset="-120"/>
+                        </a:rPr>
+                        <a:t>0.4246</a:t>
+                      </a:r>
+                      <a:endParaRPr lang="en-US" sz="1100" dirty="0">
+                        <a:latin typeface="Calibri" charset="0"/>
+                        <a:ea typeface="Calibri" charset="0"/>
+                        <a:cs typeface="Calibri" charset="0"/>
+                      </a:endParaRPr>
+                    </a:p>
+                  </a:txBody>
+                  <a:tcPr marL="101600" marR="101600" marT="38100" marB="38100" anchor="ctr">
+                    <a:lnL w="6350" cap="flat" cmpd="sng" algn="ctr">
+                      <a:solidFill>
+                        <a:srgbClr val="D5DDEA"/>
+                      </a:solidFill>
+                      <a:prstDash val="solid"/>
+                      <a:round/>
+                      <a:headEnd type="none" w="med" len="med"/>
+                      <a:tailEnd type="none" w="med" len="med"/>
+                    </a:lnL>
+                    <a:lnR w="6350" cap="flat" cmpd="sng" algn="ctr">
+                      <a:solidFill>
+                        <a:srgbClr val="D5DDEA"/>
+                      </a:solidFill>
+                      <a:prstDash val="solid"/>
+                      <a:round/>
+                      <a:headEnd type="none" w="med" len="med"/>
+                      <a:tailEnd type="none" w="med" len="med"/>
+                    </a:lnR>
+                    <a:lnT w="6350" cap="flat" cmpd="sng" algn="ctr">
+                      <a:solidFill>
+                        <a:srgbClr val="D5DDEA"/>
+                      </a:solidFill>
+                      <a:prstDash val="solid"/>
+                      <a:round/>
+                      <a:headEnd type="none" w="med" len="med"/>
+                      <a:tailEnd type="none" w="med" len="med"/>
+                    </a:lnT>
+                    <a:lnB w="6350" cap="flat" cmpd="sng" algn="ctr">
+                      <a:solidFill>
+                        <a:srgbClr val="D5DDEA"/>
+                      </a:solidFill>
+                      <a:prstDash val="solid"/>
+                      <a:round/>
+                      <a:headEnd type="none" w="med" len="med"/>
+                      <a:tailEnd type="none" w="med" len="med"/>
+                    </a:lnB>
+                    <a:solidFill>
+                      <a:srgbClr val="FFFFFF"/>
+                    </a:solidFill>
+                  </a:tcPr>
+                </a:tc>
+              </a:tr>
+              <a:tr h="384048">
+                <a:tc>
+                  <a:txBody>
+                    <a:bodyPr/>
+                    <a:lstStyle/>
+                    <a:p>
+                      <a:pPr algn="l" indent="0" marL="0">
+                        <a:buNone/>
+                      </a:pPr>
+                      <a:r>
+                        <a:rPr lang="en-US" sz="1100" b="1" dirty="0">
+                          <a:solidFill>
+                            <a:srgbClr val="122847"/>
+                          </a:solidFill>
+                          <a:latin typeface="Calibri" pitchFamily="34" charset="0"/>
+                          <a:ea typeface="Calibri" pitchFamily="34" charset="-122"/>
+                          <a:cs typeface="Calibri" pitchFamily="34" charset="-120"/>
+                        </a:rPr>
+                        <a:t>EEG Conformer+</a:t>
+                      </a:r>
+                      <a:endParaRPr lang="en-US" sz="1100" dirty="0">
+                        <a:latin typeface="Calibri" charset="0"/>
+                        <a:ea typeface="Calibri" charset="0"/>
+                        <a:cs typeface="Calibri" charset="0"/>
+                      </a:endParaRPr>
+                    </a:p>
+                  </a:txBody>
+                  <a:tcPr marL="101600" marR="101600" marT="38100" marB="38100" anchor="ctr">
+                    <a:lnL w="6350" cap="flat" cmpd="sng" algn="ctr">
+                      <a:solidFill>
+                        <a:srgbClr val="D5DDEA"/>
+                      </a:solidFill>
+                      <a:prstDash val="solid"/>
+                      <a:round/>
+                      <a:headEnd type="none" w="med" len="med"/>
+                      <a:tailEnd type="none" w="med" len="med"/>
+                    </a:lnL>
+                    <a:lnR w="6350" cap="flat" cmpd="sng" algn="ctr">
+                      <a:solidFill>
+                        <a:srgbClr val="D5DDEA"/>
+                      </a:solidFill>
+                      <a:prstDash val="solid"/>
+                      <a:round/>
+                      <a:headEnd type="none" w="med" len="med"/>
+                      <a:tailEnd type="none" w="med" len="med"/>
+                    </a:lnR>
+                    <a:lnT w="6350" cap="flat" cmpd="sng" algn="ctr">
+                      <a:solidFill>
+                        <a:srgbClr val="D5DDEA"/>
+                      </a:solidFill>
+                      <a:prstDash val="solid"/>
+                      <a:round/>
+                      <a:headEnd type="none" w="med" len="med"/>
+                      <a:tailEnd type="none" w="med" len="med"/>
+                    </a:lnT>
+                    <a:lnB w="6350" cap="flat" cmpd="sng" algn="ctr">
+                      <a:solidFill>
+                        <a:srgbClr val="D5DDEA"/>
+                      </a:solidFill>
+                      <a:prstDash val="solid"/>
+                      <a:round/>
+                      <a:headEnd type="none" w="med" len="med"/>
+                      <a:tailEnd type="none" w="med" len="med"/>
+                    </a:lnB>
+                    <a:solidFill>
+                      <a:srgbClr val="EFF3F9"/>
+                    </a:solidFill>
+                  </a:tcPr>
+                </a:tc>
+                <a:tc>
+                  <a:txBody>
+                    <a:bodyPr/>
+                    <a:lstStyle/>
+                    <a:p>
+                      <a:pPr algn="ctr" indent="0" marL="0">
+                        <a:buNone/>
+                      </a:pPr>
+                      <a:r>
+                        <a:rPr lang="en-US" sz="1100" dirty="0">
+                          <a:solidFill>
+                            <a:srgbClr val="122847"/>
+                          </a:solidFill>
+                          <a:latin typeface="Calibri" pitchFamily="34" charset="0"/>
+                          <a:ea typeface="Calibri" pitchFamily="34" charset="-122"/>
+                          <a:cs typeface="Calibri" pitchFamily="34" charset="-120"/>
+                        </a:rPr>
+                        <a:t>53.41 ± 17.08</a:t>
+                      </a:r>
+                      <a:endParaRPr lang="en-US" sz="1100" dirty="0">
+                        <a:latin typeface="Calibri" charset="0"/>
+                        <a:ea typeface="Calibri" charset="0"/>
+                        <a:cs typeface="Calibri" charset="0"/>
+                      </a:endParaRPr>
+                    </a:p>
+                  </a:txBody>
+                  <a:tcPr marL="101600" marR="101600" marT="38100" marB="38100" anchor="ctr">
+                    <a:lnL w="6350" cap="flat" cmpd="sng" algn="ctr">
+                      <a:solidFill>
+                        <a:srgbClr val="D5DDEA"/>
+                      </a:solidFill>
+                      <a:prstDash val="solid"/>
+                      <a:round/>
+                      <a:headEnd type="none" w="med" len="med"/>
+                      <a:tailEnd type="none" w="med" len="med"/>
+                    </a:lnL>
+                    <a:lnR w="6350" cap="flat" cmpd="sng" algn="ctr">
+                      <a:solidFill>
+                        <a:srgbClr val="D5DDEA"/>
+                      </a:solidFill>
+                      <a:prstDash val="solid"/>
+                      <a:round/>
+                      <a:headEnd type="none" w="med" len="med"/>
+                      <a:tailEnd type="none" w="med" len="med"/>
+                    </a:lnR>
+                    <a:lnT w="6350" cap="flat" cmpd="sng" algn="ctr">
+                      <a:solidFill>
+                        <a:srgbClr val="D5DDEA"/>
+                      </a:solidFill>
+                      <a:prstDash val="solid"/>
+                      <a:round/>
+                      <a:headEnd type="none" w="med" len="med"/>
+                      <a:tailEnd type="none" w="med" len="med"/>
+                    </a:lnT>
+                    <a:lnB w="6350" cap="flat" cmpd="sng" algn="ctr">
+                      <a:solidFill>
+                        <a:srgbClr val="D5DDEA"/>
+                      </a:solidFill>
+                      <a:prstDash val="solid"/>
+                      <a:round/>
+                      <a:headEnd type="none" w="med" len="med"/>
+                      <a:tailEnd type="none" w="med" len="med"/>
+                    </a:lnB>
+                    <a:solidFill>
+                      <a:srgbClr val="EFF3F9"/>
+                    </a:solidFill>
+                  </a:tcPr>
+                </a:tc>
+                <a:tc>
+                  <a:txBody>
+                    <a:bodyPr/>
+                    <a:lstStyle/>
+                    <a:p>
+                      <a:pPr algn="ctr" indent="0" marL="0">
+                        <a:buNone/>
+                      </a:pPr>
+                      <a:r>
+                        <a:rPr lang="en-US" sz="1100" dirty="0">
+                          <a:solidFill>
+                            <a:srgbClr val="122847"/>
+                          </a:solidFill>
+                          <a:latin typeface="Calibri" pitchFamily="34" charset="0"/>
+                          <a:ea typeface="Calibri" pitchFamily="34" charset="-122"/>
+                          <a:cs typeface="Calibri" pitchFamily="34" charset="-120"/>
+                        </a:rPr>
+                        <a:t>0.3789</a:t>
+                      </a:r>
+                      <a:endParaRPr lang="en-US" sz="1100" dirty="0">
+                        <a:latin typeface="Calibri" charset="0"/>
+                        <a:ea typeface="Calibri" charset="0"/>
+                        <a:cs typeface="Calibri" charset="0"/>
+                      </a:endParaRPr>
+                    </a:p>
+                  </a:txBody>
+                  <a:tcPr marL="101600" marR="101600" marT="38100" marB="38100" anchor="ctr">
+                    <a:lnL w="6350" cap="flat" cmpd="sng" algn="ctr">
+                      <a:solidFill>
+                        <a:srgbClr val="D5DDEA"/>
+                      </a:solidFill>
+                      <a:prstDash val="solid"/>
+                      <a:round/>
+                      <a:headEnd type="none" w="med" len="med"/>
+                      <a:tailEnd type="none" w="med" len="med"/>
+                    </a:lnL>
+                    <a:lnR w="6350" cap="flat" cmpd="sng" algn="ctr">
+                      <a:solidFill>
+                        <a:srgbClr val="D5DDEA"/>
+                      </a:solidFill>
+                      <a:prstDash val="solid"/>
+                      <a:round/>
+                      <a:headEnd type="none" w="med" len="med"/>
+                      <a:tailEnd type="none" w="med" len="med"/>
+                    </a:lnR>
+                    <a:lnT w="6350" cap="flat" cmpd="sng" algn="ctr">
+                      <a:solidFill>
+                        <a:srgbClr val="D5DDEA"/>
+                      </a:solidFill>
+                      <a:prstDash val="solid"/>
+                      <a:round/>
+                      <a:headEnd type="none" w="med" len="med"/>
+                      <a:tailEnd type="none" w="med" len="med"/>
+                    </a:lnT>
+                    <a:lnB w="6350" cap="flat" cmpd="sng" algn="ctr">
+                      <a:solidFill>
+                        <a:srgbClr val="D5DDEA"/>
+                      </a:solidFill>
+                      <a:prstDash val="solid"/>
+                      <a:round/>
+                      <a:headEnd type="none" w="med" len="med"/>
+                      <a:tailEnd type="none" w="med" len="med"/>
+                    </a:lnB>
+                    <a:solidFill>
+                      <a:srgbClr val="EFF3F9"/>
+                    </a:solidFill>
+                  </a:tcPr>
+                </a:tc>
+              </a:tr>
+              <a:tr h="384048">
+                <a:tc>
+                  <a:txBody>
+                    <a:bodyPr/>
+                    <a:lstStyle/>
+                    <a:p>
+                      <a:pPr algn="l" indent="0" marL="0">
+                        <a:buNone/>
+                      </a:pPr>
+                      <a:r>
+                        <a:rPr lang="en-US" sz="1100" b="1" dirty="0">
+                          <a:solidFill>
+                            <a:srgbClr val="122847"/>
+                          </a:solidFill>
+                          <a:latin typeface="Calibri" pitchFamily="34" charset="0"/>
+                          <a:ea typeface="Calibri" pitchFamily="34" charset="-122"/>
+                          <a:cs typeface="Calibri" pitchFamily="34" charset="-120"/>
+                        </a:rPr>
+                        <a:t>CTNet</a:t>
+                      </a:r>
+                      <a:endParaRPr lang="en-US" sz="1100" dirty="0">
+                        <a:latin typeface="Calibri" charset="0"/>
+                        <a:ea typeface="Calibri" charset="0"/>
+                        <a:cs typeface="Calibri" charset="0"/>
+                      </a:endParaRPr>
+                    </a:p>
+                  </a:txBody>
+                  <a:tcPr marL="101600" marR="101600" marT="38100" marB="38100" anchor="ctr">
+                    <a:lnL w="6350" cap="flat" cmpd="sng" algn="ctr">
+                      <a:solidFill>
+                        <a:srgbClr val="D5DDEA"/>
+                      </a:solidFill>
+                      <a:prstDash val="solid"/>
+                      <a:round/>
+                      <a:headEnd type="none" w="med" len="med"/>
+                      <a:tailEnd type="none" w="med" len="med"/>
+                    </a:lnL>
+                    <a:lnR w="6350" cap="flat" cmpd="sng" algn="ctr">
+                      <a:solidFill>
+                        <a:srgbClr val="D5DDEA"/>
+                      </a:solidFill>
+                      <a:prstDash val="solid"/>
+                      <a:round/>
+                      <a:headEnd type="none" w="med" len="med"/>
+                      <a:tailEnd type="none" w="med" len="med"/>
+                    </a:lnR>
+                    <a:lnT w="6350" cap="flat" cmpd="sng" algn="ctr">
+                      <a:solidFill>
+                        <a:srgbClr val="D5DDEA"/>
+                      </a:solidFill>
+                      <a:prstDash val="solid"/>
+                      <a:round/>
+                      <a:headEnd type="none" w="med" len="med"/>
+                      <a:tailEnd type="none" w="med" len="med"/>
+                    </a:lnT>
+                    <a:lnB w="6350" cap="flat" cmpd="sng" algn="ctr">
+                      <a:solidFill>
+                        <a:srgbClr val="D5DDEA"/>
+                      </a:solidFill>
+                      <a:prstDash val="solid"/>
+                      <a:round/>
+                      <a:headEnd type="none" w="med" len="med"/>
+                      <a:tailEnd type="none" w="med" len="med"/>
+                    </a:lnB>
+                    <a:solidFill>
+                      <a:srgbClr val="FFFFFF"/>
+                    </a:solidFill>
+                  </a:tcPr>
+                </a:tc>
+                <a:tc>
+                  <a:txBody>
+                    <a:bodyPr/>
+                    <a:lstStyle/>
+                    <a:p>
+                      <a:pPr algn="ctr" indent="0" marL="0">
+                        <a:buNone/>
+                      </a:pPr>
+                      <a:r>
+                        <a:rPr lang="en-US" sz="1100" dirty="0">
+                          <a:solidFill>
+                            <a:srgbClr val="122847"/>
+                          </a:solidFill>
+                          <a:latin typeface="Calibri" pitchFamily="34" charset="0"/>
+                          <a:ea typeface="Calibri" pitchFamily="34" charset="-122"/>
+                          <a:cs typeface="Calibri" pitchFamily="34" charset="-120"/>
+                        </a:rPr>
+                        <a:t>58.64 ± 14.61</a:t>
+                      </a:r>
+                      <a:endParaRPr lang="en-US" sz="1100" dirty="0">
+                        <a:latin typeface="Calibri" charset="0"/>
+                        <a:ea typeface="Calibri" charset="0"/>
+                        <a:cs typeface="Calibri" charset="0"/>
+                      </a:endParaRPr>
+                    </a:p>
+                  </a:txBody>
+                  <a:tcPr marL="101600" marR="101600" marT="38100" marB="38100" anchor="ctr">
+                    <a:lnL w="6350" cap="flat" cmpd="sng" algn="ctr">
+                      <a:solidFill>
+                        <a:srgbClr val="D5DDEA"/>
+                      </a:solidFill>
+                      <a:prstDash val="solid"/>
+                      <a:round/>
+                      <a:headEnd type="none" w="med" len="med"/>
+                      <a:tailEnd type="none" w="med" len="med"/>
+                    </a:lnL>
+                    <a:lnR w="6350" cap="flat" cmpd="sng" algn="ctr">
+                      <a:solidFill>
+                        <a:srgbClr val="D5DDEA"/>
+                      </a:solidFill>
+                      <a:prstDash val="solid"/>
+                      <a:round/>
+                      <a:headEnd type="none" w="med" len="med"/>
+                      <a:tailEnd type="none" w="med" len="med"/>
+                    </a:lnR>
+                    <a:lnT w="6350" cap="flat" cmpd="sng" algn="ctr">
+                      <a:solidFill>
+                        <a:srgbClr val="D5DDEA"/>
+                      </a:solidFill>
+                      <a:prstDash val="solid"/>
+                      <a:round/>
+                      <a:headEnd type="none" w="med" len="med"/>
+                      <a:tailEnd type="none" w="med" len="med"/>
+                    </a:lnT>
+                    <a:lnB w="6350" cap="flat" cmpd="sng" algn="ctr">
+                      <a:solidFill>
+                        <a:srgbClr val="D5DDEA"/>
+                      </a:solidFill>
+                      <a:prstDash val="solid"/>
+                      <a:round/>
+                      <a:headEnd type="none" w="med" len="med"/>
+                      <a:tailEnd type="none" w="med" len="med"/>
+                    </a:lnB>
+                    <a:solidFill>
+                      <a:srgbClr val="FFFFFF"/>
+                    </a:solidFill>
+                  </a:tcPr>
+                </a:tc>
+                <a:tc>
+                  <a:txBody>
+                    <a:bodyPr/>
+                    <a:lstStyle/>
+                    <a:p>
+                      <a:pPr algn="ctr" indent="0" marL="0">
+                        <a:buNone/>
+                      </a:pPr>
+                      <a:r>
+                        <a:rPr lang="en-US" sz="1100" dirty="0">
+                          <a:solidFill>
+                            <a:srgbClr val="122847"/>
+                          </a:solidFill>
+                          <a:latin typeface="Calibri" pitchFamily="34" charset="0"/>
+                          <a:ea typeface="Calibri" pitchFamily="34" charset="-122"/>
+                          <a:cs typeface="Calibri" pitchFamily="34" charset="-120"/>
+                        </a:rPr>
+                        <a:t>0.4486</a:t>
+                      </a:r>
+                      <a:endParaRPr lang="en-US" sz="1100" dirty="0">
+                        <a:latin typeface="Calibri" charset="0"/>
+                        <a:ea typeface="Calibri" charset="0"/>
+                        <a:cs typeface="Calibri" charset="0"/>
+                      </a:endParaRPr>
+                    </a:p>
+                  </a:txBody>
+                  <a:tcPr marL="101600" marR="101600" marT="38100" marB="38100" anchor="ctr">
+                    <a:lnL w="6350" cap="flat" cmpd="sng" algn="ctr">
+                      <a:solidFill>
+                        <a:srgbClr val="D5DDEA"/>
+                      </a:solidFill>
+                      <a:prstDash val="solid"/>
+                      <a:round/>
+                      <a:headEnd type="none" w="med" len="med"/>
+                      <a:tailEnd type="none" w="med" len="med"/>
+                    </a:lnL>
+                    <a:lnR w="6350" cap="flat" cmpd="sng" algn="ctr">
+                      <a:solidFill>
+                        <a:srgbClr val="D5DDEA"/>
+                      </a:solidFill>
+                      <a:prstDash val="solid"/>
+                      <a:round/>
+                      <a:headEnd type="none" w="med" len="med"/>
+                      <a:tailEnd type="none" w="med" len="med"/>
+                    </a:lnR>
+                    <a:lnT w="6350" cap="flat" cmpd="sng" algn="ctr">
+                      <a:solidFill>
+                        <a:srgbClr val="D5DDEA"/>
+                      </a:solidFill>
+                      <a:prstDash val="solid"/>
+                      <a:round/>
+                      <a:headEnd type="none" w="med" len="med"/>
+                      <a:tailEnd type="none" w="med" len="med"/>
+                    </a:lnT>
+                    <a:lnB w="6350" cap="flat" cmpd="sng" algn="ctr">
+                      <a:solidFill>
+                        <a:srgbClr val="D5DDEA"/>
+                      </a:solidFill>
+                      <a:prstDash val="solid"/>
+                      <a:round/>
+                      <a:headEnd type="none" w="med" len="med"/>
+                      <a:tailEnd type="none" w="med" len="med"/>
+                    </a:lnB>
+                    <a:solidFill>
+                      <a:srgbClr val="FFFFFF"/>
+                    </a:solidFill>
+                  </a:tcPr>
+                </a:tc>
+              </a:tr>
+            </a:tbl>
+          </a:graphicData>
+        </a:graphic>
+      </p:graphicFrame>
+      <p:graphicFrame>
+        <p:nvGraphicFramePr>
+          <p:cNvPr id="21" name="Table 1"/>
+          <p:cNvGraphicFramePr>
+            <a:graphicFrameLocks noGrp="1"/>
+          </p:cNvGraphicFramePr>
+          <p:nvPr>
+            <p:extLst>
+              <p:ext uri="{D42A27DB-BD31-4B8C-83A1-F6EECF244321}">
+                <p14:modId xmlns:p14="http://schemas.microsoft.com/office/powerpoint/2010/main" val="1579011935"/>
+              </p:ext>
+            </p:extLst>
+          </p:nvPr>
+        </p:nvGraphicFramePr>
+        <p:xfrm>
+          <a:off x="6053328" y="1691640"/>
+          <a:ext cx="5541264" cy="914400"/>
+        </p:xfrm>
+        <a:graphic>
+          <a:graphicData uri="http://schemas.openxmlformats.org/drawingml/2006/table">
+            <a:tbl>
+              <a:tblPr/>
+              <a:tblGrid>
+                <a:gridCol w="1554480"/>
+                <a:gridCol w="1143000"/>
+                <a:gridCol w="2843784"/>
+              </a:tblGrid>
+              <a:tr h="365760">
+                <a:tc>
+                  <a:txBody>
+                    <a:bodyPr/>
+                    <a:lstStyle/>
+                    <a:p>
+                      <a:pPr algn="l" indent="0" marL="0">
+                        <a:buNone/>
+                      </a:pPr>
+                      <a:r>
+                        <a:rPr lang="en-US" sz="1050" b="1" dirty="0">
+                          <a:solidFill>
+                            <a:srgbClr val="FFFFFF"/>
+                          </a:solidFill>
+                          <a:latin typeface="Calibri" pitchFamily="34" charset="0"/>
+                          <a:ea typeface="Calibri" pitchFamily="34" charset="-122"/>
+                          <a:cs typeface="Calibri" pitchFamily="34" charset="-120"/>
+                        </a:rPr>
+                        <a:t>Model</a:t>
+                      </a:r>
+                      <a:endParaRPr lang="en-US" sz="1050" dirty="0">
+                        <a:latin typeface="Calibri" charset="0"/>
+                        <a:ea typeface="Calibri" charset="0"/>
+                        <a:cs typeface="Calibri" charset="0"/>
+                      </a:endParaRPr>
+                    </a:p>
+                  </a:txBody>
+                  <a:tcPr marL="101600" marR="101600" marT="38100" marB="38100" anchor="ctr">
+                    <a:lnL w="6350" cap="flat" cmpd="sng" algn="ctr">
+                      <a:solidFill>
+                        <a:srgbClr val="D5DDEA"/>
+                      </a:solidFill>
+                      <a:prstDash val="solid"/>
+                      <a:round/>
+                      <a:headEnd type="none" w="med" len="med"/>
+                      <a:tailEnd type="none" w="med" len="med"/>
+                    </a:lnL>
+                    <a:lnR w="6350" cap="flat" cmpd="sng" algn="ctr">
+                      <a:solidFill>
+                        <a:srgbClr val="D5DDEA"/>
+                      </a:solidFill>
+                      <a:prstDash val="solid"/>
+                      <a:round/>
+                      <a:headEnd type="none" w="med" len="med"/>
+                      <a:tailEnd type="none" w="med" len="med"/>
+                    </a:lnR>
+                    <a:lnT w="6350" cap="flat" cmpd="sng" algn="ctr">
+                      <a:solidFill>
+                        <a:srgbClr val="D5DDEA"/>
+                      </a:solidFill>
+                      <a:prstDash val="solid"/>
+                      <a:round/>
+                      <a:headEnd type="none" w="med" len="med"/>
+                      <a:tailEnd type="none" w="med" len="med"/>
+                    </a:lnT>
+                    <a:lnB w="6350" cap="flat" cmpd="sng" algn="ctr">
+                      <a:solidFill>
+                        <a:srgbClr val="D5DDEA"/>
+                      </a:solidFill>
+                      <a:prstDash val="solid"/>
+                      <a:round/>
+                      <a:headEnd type="none" w="med" len="med"/>
+                      <a:tailEnd type="none" w="med" len="med"/>
+                    </a:lnB>
+                    <a:solidFill>
+                      <a:srgbClr val="1B3A6B"/>
+                    </a:solidFill>
+                  </a:tcPr>
+                </a:tc>
+                <a:tc>
+                  <a:txBody>
+                    <a:bodyPr/>
+                    <a:lstStyle/>
+                    <a:p>
+                      <a:pPr algn="ctr" indent="0" marL="0">
+                        <a:buNone/>
+                      </a:pPr>
+                      <a:r>
+                        <a:rPr lang="en-US" sz="1050" b="1" dirty="0">
+                          <a:solidFill>
+                            <a:srgbClr val="FFFFFF"/>
+                          </a:solidFill>
+                          <a:latin typeface="Calibri" pitchFamily="34" charset="0"/>
+                          <a:ea typeface="Calibri" pitchFamily="34" charset="-122"/>
+                          <a:cs typeface="Calibri" pitchFamily="34" charset="-120"/>
+                        </a:rPr>
+                        <a:t>Same person</a:t>
+                      </a:r>
+                      <a:endParaRPr lang="en-US" sz="1050" dirty="0">
+                        <a:latin typeface="Calibri" charset="0"/>
+                        <a:ea typeface="Calibri" charset="0"/>
+                        <a:cs typeface="Calibri" charset="0"/>
+                      </a:endParaRPr>
+                    </a:p>
+                  </a:txBody>
+                  <a:tcPr marL="101600" marR="101600" marT="38100" marB="38100" anchor="ctr">
+                    <a:lnL w="6350" cap="flat" cmpd="sng" algn="ctr">
+                      <a:solidFill>
+                        <a:srgbClr val="D5DDEA"/>
+                      </a:solidFill>
+                      <a:prstDash val="solid"/>
+                      <a:round/>
+                      <a:headEnd type="none" w="med" len="med"/>
+                      <a:tailEnd type="none" w="med" len="med"/>
+                    </a:lnL>
+                    <a:lnR w="6350" cap="flat" cmpd="sng" algn="ctr">
+                      <a:solidFill>
+                        <a:srgbClr val="D5DDEA"/>
+                      </a:solidFill>
+                      <a:prstDash val="solid"/>
+                      <a:round/>
+                      <a:headEnd type="none" w="med" len="med"/>
+                      <a:tailEnd type="none" w="med" len="med"/>
+                    </a:lnR>
+                    <a:lnT w="6350" cap="flat" cmpd="sng" algn="ctr">
+                      <a:solidFill>
+                        <a:srgbClr val="D5DDEA"/>
+                      </a:solidFill>
+                      <a:prstDash val="solid"/>
+                      <a:round/>
+                      <a:headEnd type="none" w="med" len="med"/>
+                      <a:tailEnd type="none" w="med" len="med"/>
+                    </a:lnT>
+                    <a:lnB w="6350" cap="flat" cmpd="sng" algn="ctr">
+                      <a:solidFill>
+                        <a:srgbClr val="D5DDEA"/>
+                      </a:solidFill>
+                      <a:prstDash val="solid"/>
+                      <a:round/>
+                      <a:headEnd type="none" w="med" len="med"/>
+                      <a:tailEnd type="none" w="med" len="med"/>
+                    </a:lnB>
+                    <a:solidFill>
+                      <a:srgbClr val="1B3A6B"/>
+                    </a:solidFill>
+                  </a:tcPr>
+                </a:tc>
+                <a:tc>
+                  <a:txBody>
+                    <a:bodyPr/>
+                    <a:lstStyle/>
+                    <a:p>
+                      <a:pPr algn="l" indent="0" marL="0">
+                        <a:buNone/>
+                      </a:pPr>
+                      <a:r>
+                        <a:rPr lang="en-US" sz="1050" b="1" dirty="0">
+                          <a:solidFill>
+                            <a:srgbClr val="FFFFFF"/>
+                          </a:solidFill>
+                          <a:latin typeface="Calibri" pitchFamily="34" charset="0"/>
+                          <a:ea typeface="Calibri" pitchFamily="34" charset="-122"/>
+                          <a:cs typeface="Calibri" pitchFamily="34" charset="-120"/>
+                        </a:rPr>
+                        <a:t>Source</a:t>
+                      </a:r>
+                      <a:endParaRPr lang="en-US" sz="1050" dirty="0">
+                        <a:latin typeface="Calibri" charset="0"/>
+                        <a:ea typeface="Calibri" charset="0"/>
+                        <a:cs typeface="Calibri" charset="0"/>
+                      </a:endParaRPr>
+                    </a:p>
+                  </a:txBody>
+                  <a:tcPr marL="101600" marR="101600" marT="38100" marB="38100" anchor="ctr">
+                    <a:lnL w="6350" cap="flat" cmpd="sng" algn="ctr">
+                      <a:solidFill>
+                        <a:srgbClr val="D5DDEA"/>
+                      </a:solidFill>
+                      <a:prstDash val="solid"/>
+                      <a:round/>
+                      <a:headEnd type="none" w="med" len="med"/>
+                      <a:tailEnd type="none" w="med" len="med"/>
+                    </a:lnL>
+                    <a:lnR w="6350" cap="flat" cmpd="sng" algn="ctr">
+                      <a:solidFill>
+                        <a:srgbClr val="D5DDEA"/>
+                      </a:solidFill>
+                      <a:prstDash val="solid"/>
+                      <a:round/>
+                      <a:headEnd type="none" w="med" len="med"/>
+                      <a:tailEnd type="none" w="med" len="med"/>
+                    </a:lnR>
+                    <a:lnT w="6350" cap="flat" cmpd="sng" algn="ctr">
+                      <a:solidFill>
+                        <a:srgbClr val="D5DDEA"/>
+                      </a:solidFill>
+                      <a:prstDash val="solid"/>
+                      <a:round/>
+                      <a:headEnd type="none" w="med" len="med"/>
+                      <a:tailEnd type="none" w="med" len="med"/>
+                    </a:lnT>
+                    <a:lnB w="6350" cap="flat" cmpd="sng" algn="ctr">
+                      <a:solidFill>
+                        <a:srgbClr val="D5DDEA"/>
+                      </a:solidFill>
+                      <a:prstDash val="solid"/>
+                      <a:round/>
+                      <a:headEnd type="none" w="med" len="med"/>
+                      <a:tailEnd type="none" w="med" len="med"/>
+                    </a:lnB>
+                    <a:solidFill>
+                      <a:srgbClr val="1B3A6B"/>
+                    </a:solidFill>
+                  </a:tcPr>
+                </a:tc>
+              </a:tr>
+              <a:tr h="384048">
+                <a:tc>
+                  <a:txBody>
+                    <a:bodyPr/>
+                    <a:lstStyle/>
+                    <a:p>
+                      <a:pPr algn="l" indent="0" marL="0">
+                        <a:buNone/>
+                      </a:pPr>
+                      <a:r>
+                        <a:rPr lang="en-US" sz="1100" b="1" dirty="0">
+                          <a:solidFill>
+                            <a:srgbClr val="122847"/>
+                          </a:solidFill>
+                          <a:latin typeface="Calibri" pitchFamily="34" charset="0"/>
+                          <a:ea typeface="Calibri" pitchFamily="34" charset="-122"/>
+                          <a:cs typeface="Calibri" pitchFamily="34" charset="-120"/>
+                        </a:rPr>
+                        <a:t>CTNet</a:t>
+                      </a:r>
+                      <a:endParaRPr lang="en-US" sz="1100" dirty="0">
+                        <a:latin typeface="Calibri" charset="0"/>
+                        <a:ea typeface="Calibri" charset="0"/>
+                        <a:cs typeface="Calibri" charset="0"/>
+                      </a:endParaRPr>
+                    </a:p>
+                  </a:txBody>
+                  <a:tcPr marL="101600" marR="101600" marT="38100" marB="38100" anchor="ctr">
+                    <a:lnL w="6350" cap="flat" cmpd="sng" algn="ctr">
+                      <a:solidFill>
+                        <a:srgbClr val="D5DDEA"/>
+                      </a:solidFill>
+                      <a:prstDash val="solid"/>
+                      <a:round/>
+                      <a:headEnd type="none" w="med" len="med"/>
+                      <a:tailEnd type="none" w="med" len="med"/>
+                    </a:lnL>
+                    <a:lnR w="6350" cap="flat" cmpd="sng" algn="ctr">
+                      <a:solidFill>
+                        <a:srgbClr val="D5DDEA"/>
+                      </a:solidFill>
+                      <a:prstDash val="solid"/>
+                      <a:round/>
+                      <a:headEnd type="none" w="med" len="med"/>
+                      <a:tailEnd type="none" w="med" len="med"/>
+                    </a:lnR>
+                    <a:lnT w="6350" cap="flat" cmpd="sng" algn="ctr">
+                      <a:solidFill>
+                        <a:srgbClr val="D5DDEA"/>
+                      </a:solidFill>
+                      <a:prstDash val="solid"/>
+                      <a:round/>
+                      <a:headEnd type="none" w="med" len="med"/>
+                      <a:tailEnd type="none" w="med" len="med"/>
+                    </a:lnT>
+                    <a:lnB w="6350" cap="flat" cmpd="sng" algn="ctr">
+                      <a:solidFill>
+                        <a:srgbClr val="D5DDEA"/>
+                      </a:solidFill>
+                      <a:prstDash val="solid"/>
+                      <a:round/>
+                      <a:headEnd type="none" w="med" len="med"/>
+                      <a:tailEnd type="none" w="med" len="med"/>
+                    </a:lnB>
+                    <a:solidFill>
+                      <a:srgbClr val="FFFFFF"/>
+                    </a:solidFill>
+                  </a:tcPr>
+                </a:tc>
+                <a:tc>
+                  <a:txBody>
+                    <a:bodyPr/>
+                    <a:lstStyle/>
+                    <a:p>
+                      <a:pPr algn="ctr" indent="0" marL="0">
+                        <a:buNone/>
+                      </a:pPr>
+                      <a:r>
+                        <a:rPr lang="en-US" sz="1100" dirty="0">
+                          <a:solidFill>
+                            <a:srgbClr val="122847"/>
+                          </a:solidFill>
+                          <a:latin typeface="Calibri" pitchFamily="34" charset="0"/>
+                          <a:ea typeface="Calibri" pitchFamily="34" charset="-122"/>
+                          <a:cs typeface="Calibri" pitchFamily="34" charset="-120"/>
+                        </a:rPr>
+                        <a:t>82.52%</a:t>
+                      </a:r>
+                      <a:endParaRPr lang="en-US" sz="1100" dirty="0">
+                        <a:latin typeface="Calibri" charset="0"/>
+                        <a:ea typeface="Calibri" charset="0"/>
+                        <a:cs typeface="Calibri" charset="0"/>
+                      </a:endParaRPr>
+                    </a:p>
+                  </a:txBody>
+                  <a:tcPr marL="101600" marR="101600" marT="38100" marB="38100" anchor="ctr">
+                    <a:lnL w="6350" cap="flat" cmpd="sng" algn="ctr">
+                      <a:solidFill>
+                        <a:srgbClr val="D5DDEA"/>
+                      </a:solidFill>
+                      <a:prstDash val="solid"/>
+                      <a:round/>
+                      <a:headEnd type="none" w="med" len="med"/>
+                      <a:tailEnd type="none" w="med" len="med"/>
+                    </a:lnL>
+                    <a:lnR w="6350" cap="flat" cmpd="sng" algn="ctr">
+                      <a:solidFill>
+                        <a:srgbClr val="D5DDEA"/>
+                      </a:solidFill>
+                      <a:prstDash val="solid"/>
+                      <a:round/>
+                      <a:headEnd type="none" w="med" len="med"/>
+                      <a:tailEnd type="none" w="med" len="med"/>
+                    </a:lnR>
+                    <a:lnT w="6350" cap="flat" cmpd="sng" algn="ctr">
+                      <a:solidFill>
+                        <a:srgbClr val="D5DDEA"/>
+                      </a:solidFill>
+                      <a:prstDash val="solid"/>
+                      <a:round/>
+                      <a:headEnd type="none" w="med" len="med"/>
+                      <a:tailEnd type="none" w="med" len="med"/>
+                    </a:lnT>
+                    <a:lnB w="6350" cap="flat" cmpd="sng" algn="ctr">
+                      <a:solidFill>
+                        <a:srgbClr val="D5DDEA"/>
+                      </a:solidFill>
+                      <a:prstDash val="solid"/>
+                      <a:round/>
+                      <a:headEnd type="none" w="med" len="med"/>
+                      <a:tailEnd type="none" w="med" len="med"/>
+                    </a:lnB>
+                    <a:solidFill>
+                      <a:srgbClr val="FFFFFF"/>
+                    </a:solidFill>
+                  </a:tcPr>
+                </a:tc>
+                <a:tc>
+                  <a:txBody>
+                    <a:bodyPr/>
+                    <a:lstStyle/>
+                    <a:p>
+                      <a:pPr algn="l" indent="0" marL="0">
+                        <a:buNone/>
+                      </a:pPr>
+                      <a:r>
+                        <a:rPr lang="en-US" sz="1100" dirty="0">
+                          <a:solidFill>
+                            <a:srgbClr val="122847"/>
+                          </a:solidFill>
+                          <a:latin typeface="Calibri" pitchFamily="34" charset="0"/>
+                          <a:ea typeface="Calibri" pitchFamily="34" charset="-122"/>
+                          <a:cs typeface="Calibri" pitchFamily="34" charset="-120"/>
+                        </a:rPr>
+                        <a:t>Zhao et al. (2024)</a:t>
+                      </a:r>
+                      <a:endParaRPr lang="en-US" sz="1100" dirty="0">
+                        <a:latin typeface="Calibri" charset="0"/>
+                        <a:ea typeface="Calibri" charset="0"/>
+                        <a:cs typeface="Calibri" charset="0"/>
+                      </a:endParaRPr>
+                    </a:p>
+                  </a:txBody>
+                  <a:tcPr marL="101600" marR="101600" marT="38100" marB="38100" anchor="ctr">
+                    <a:lnL w="6350" cap="flat" cmpd="sng" algn="ctr">
+                      <a:solidFill>
+                        <a:srgbClr val="D5DDEA"/>
+                      </a:solidFill>
+                      <a:prstDash val="solid"/>
+                      <a:round/>
+                      <a:headEnd type="none" w="med" len="med"/>
+                      <a:tailEnd type="none" w="med" len="med"/>
+                    </a:lnL>
+                    <a:lnR w="6350" cap="flat" cmpd="sng" algn="ctr">
+                      <a:solidFill>
+                        <a:srgbClr val="D5DDEA"/>
+                      </a:solidFill>
+                      <a:prstDash val="solid"/>
+                      <a:round/>
+                      <a:headEnd type="none" w="med" len="med"/>
+                      <a:tailEnd type="none" w="med" len="med"/>
+                    </a:lnR>
+                    <a:lnT w="6350" cap="flat" cmpd="sng" algn="ctr">
+                      <a:solidFill>
+                        <a:srgbClr val="D5DDEA"/>
+                      </a:solidFill>
+                      <a:prstDash val="solid"/>
+                      <a:round/>
+                      <a:headEnd type="none" w="med" len="med"/>
+                      <a:tailEnd type="none" w="med" len="med"/>
+                    </a:lnT>
+                    <a:lnB w="6350" cap="flat" cmpd="sng" algn="ctr">
+                      <a:solidFill>
+                        <a:srgbClr val="D5DDEA"/>
+                      </a:solidFill>
+                      <a:prstDash val="solid"/>
+                      <a:round/>
+                      <a:headEnd type="none" w="med" len="med"/>
+                      <a:tailEnd type="none" w="med" len="med"/>
+                    </a:lnB>
+                    <a:solidFill>
+                      <a:srgbClr val="FFFFFF"/>
+                    </a:solidFill>
+                  </a:tcPr>
+                </a:tc>
+              </a:tr>
+              <a:tr h="384048">
+                <a:tc>
+                  <a:txBody>
+                    <a:bodyPr/>
+                    <a:lstStyle/>
+                    <a:p>
+                      <a:pPr algn="l" indent="0" marL="0">
+                        <a:buNone/>
+                      </a:pPr>
+                      <a:r>
+                        <a:rPr lang="en-US" sz="1100" b="1" dirty="0">
+                          <a:solidFill>
+                            <a:srgbClr val="122847"/>
+                          </a:solidFill>
+                          <a:latin typeface="Calibri" pitchFamily="34" charset="0"/>
+                          <a:ea typeface="Calibri" pitchFamily="34" charset="-122"/>
+                          <a:cs typeface="Calibri" pitchFamily="34" charset="-120"/>
+                        </a:rPr>
+                        <a:t>EEG Conformer</a:t>
+                      </a:r>
+                      <a:endParaRPr lang="en-US" sz="1100" dirty="0">
+                        <a:latin typeface="Calibri" charset="0"/>
+                        <a:ea typeface="Calibri" charset="0"/>
+                        <a:cs typeface="Calibri" charset="0"/>
+                      </a:endParaRPr>
+                    </a:p>
+                  </a:txBody>
+                  <a:tcPr marL="101600" marR="101600" marT="38100" marB="38100" anchor="ctr">
+                    <a:lnL w="6350" cap="flat" cmpd="sng" algn="ctr">
+                      <a:solidFill>
+                        <a:srgbClr val="D5DDEA"/>
+                      </a:solidFill>
+                      <a:prstDash val="solid"/>
+                      <a:round/>
+                      <a:headEnd type="none" w="med" len="med"/>
+                      <a:tailEnd type="none" w="med" len="med"/>
+                    </a:lnL>
+                    <a:lnR w="6350" cap="flat" cmpd="sng" algn="ctr">
+                      <a:solidFill>
+                        <a:srgbClr val="D5DDEA"/>
+                      </a:solidFill>
+                      <a:prstDash val="solid"/>
+                      <a:round/>
+                      <a:headEnd type="none" w="med" len="med"/>
+                      <a:tailEnd type="none" w="med" len="med"/>
+                    </a:lnR>
+                    <a:lnT w="6350" cap="flat" cmpd="sng" algn="ctr">
+                      <a:solidFill>
+                        <a:srgbClr val="D5DDEA"/>
+                      </a:solidFill>
+                      <a:prstDash val="solid"/>
+                      <a:round/>
+                      <a:headEnd type="none" w="med" len="med"/>
+                      <a:tailEnd type="none" w="med" len="med"/>
+                    </a:lnT>
+                    <a:lnB w="6350" cap="flat" cmpd="sng" algn="ctr">
+                      <a:solidFill>
+                        <a:srgbClr val="D5DDEA"/>
+                      </a:solidFill>
+                      <a:prstDash val="solid"/>
+                      <a:round/>
+                      <a:headEnd type="none" w="med" len="med"/>
+                      <a:tailEnd type="none" w="med" len="med"/>
+                    </a:lnB>
+                    <a:solidFill>
+                      <a:srgbClr val="EFF3F9"/>
+                    </a:solidFill>
+                  </a:tcPr>
+                </a:tc>
+                <a:tc>
+                  <a:txBody>
+                    <a:bodyPr/>
+                    <a:lstStyle/>
+                    <a:p>
+                      <a:pPr algn="ctr" indent="0" marL="0">
+                        <a:buNone/>
+                      </a:pPr>
+                      <a:r>
+                        <a:rPr lang="en-US" sz="1100" dirty="0">
+                          <a:solidFill>
+                            <a:srgbClr val="122847"/>
+                          </a:solidFill>
+                          <a:latin typeface="Calibri" pitchFamily="34" charset="0"/>
+                          <a:ea typeface="Calibri" pitchFamily="34" charset="-122"/>
+                          <a:cs typeface="Calibri" pitchFamily="34" charset="-120"/>
+                        </a:rPr>
+                        <a:t>78.66%</a:t>
+                      </a:r>
+                      <a:endParaRPr lang="en-US" sz="1100" dirty="0">
+                        <a:latin typeface="Calibri" charset="0"/>
+                        <a:ea typeface="Calibri" charset="0"/>
+                        <a:cs typeface="Calibri" charset="0"/>
+                      </a:endParaRPr>
+                    </a:p>
+                  </a:txBody>
+                  <a:tcPr marL="101600" marR="101600" marT="38100" marB="38100" anchor="ctr">
+                    <a:lnL w="6350" cap="flat" cmpd="sng" algn="ctr">
+                      <a:solidFill>
+                        <a:srgbClr val="D5DDEA"/>
+                      </a:solidFill>
+                      <a:prstDash val="solid"/>
+                      <a:round/>
+                      <a:headEnd type="none" w="med" len="med"/>
+                      <a:tailEnd type="none" w="med" len="med"/>
+                    </a:lnL>
+                    <a:lnR w="6350" cap="flat" cmpd="sng" algn="ctr">
+                      <a:solidFill>
+                        <a:srgbClr val="D5DDEA"/>
+                      </a:solidFill>
+                      <a:prstDash val="solid"/>
+                      <a:round/>
+                      <a:headEnd type="none" w="med" len="med"/>
+                      <a:tailEnd type="none" w="med" len="med"/>
+                    </a:lnR>
+                    <a:lnT w="6350" cap="flat" cmpd="sng" algn="ctr">
+                      <a:solidFill>
+                        <a:srgbClr val="D5DDEA"/>
+                      </a:solidFill>
+                      <a:prstDash val="solid"/>
+                      <a:round/>
+                      <a:headEnd type="none" w="med" len="med"/>
+                      <a:tailEnd type="none" w="med" len="med"/>
+                    </a:lnT>
+                    <a:lnB w="6350" cap="flat" cmpd="sng" algn="ctr">
+                      <a:solidFill>
+                        <a:srgbClr val="D5DDEA"/>
+                      </a:solidFill>
+                      <a:prstDash val="solid"/>
+                      <a:round/>
+                      <a:headEnd type="none" w="med" len="med"/>
+                      <a:tailEnd type="none" w="med" len="med"/>
+                    </a:lnB>
+                    <a:solidFill>
+                      <a:srgbClr val="EFF3F9"/>
+                    </a:solidFill>
+                  </a:tcPr>
+                </a:tc>
+                <a:tc>
+                  <a:txBody>
+                    <a:bodyPr/>
+                    <a:lstStyle/>
+                    <a:p>
+                      <a:pPr algn="l" indent="0" marL="0">
+                        <a:buNone/>
+                      </a:pPr>
+                      <a:r>
+                        <a:rPr lang="en-US" sz="1100" dirty="0">
+                          <a:solidFill>
+                            <a:srgbClr val="122847"/>
+                          </a:solidFill>
+                          <a:latin typeface="Calibri" pitchFamily="34" charset="0"/>
+                          <a:ea typeface="Calibri" pitchFamily="34" charset="-122"/>
+                          <a:cs typeface="Calibri" pitchFamily="34" charset="-120"/>
+                        </a:rPr>
+                        <a:t>Authors' repository, hold-out</a:t>
+                      </a:r>
+                      <a:endParaRPr lang="en-US" sz="1100" dirty="0">
+                        <a:latin typeface="Calibri" charset="0"/>
+                        <a:ea typeface="Calibri" charset="0"/>
+                        <a:cs typeface="Calibri" charset="0"/>
+                      </a:endParaRPr>
+                    </a:p>
+                  </a:txBody>
+                  <a:tcPr marL="101600" marR="101600" marT="38100" marB="38100" anchor="ctr">
+                    <a:lnL w="6350" cap="flat" cmpd="sng" algn="ctr">
+                      <a:solidFill>
+                        <a:srgbClr val="D5DDEA"/>
+                      </a:solidFill>
+                      <a:prstDash val="solid"/>
+                      <a:round/>
+                      <a:headEnd type="none" w="med" len="med"/>
+                      <a:tailEnd type="none" w="med" len="med"/>
+                    </a:lnL>
+                    <a:lnR w="6350" cap="flat" cmpd="sng" algn="ctr">
+                      <a:solidFill>
+                        <a:srgbClr val="D5DDEA"/>
+                      </a:solidFill>
+                      <a:prstDash val="solid"/>
+                      <a:round/>
+                      <a:headEnd type="none" w="med" len="med"/>
+                      <a:tailEnd type="none" w="med" len="med"/>
+                    </a:lnR>
+                    <a:lnT w="6350" cap="flat" cmpd="sng" algn="ctr">
+                      <a:solidFill>
+                        <a:srgbClr val="D5DDEA"/>
+                      </a:solidFill>
+                      <a:prstDash val="solid"/>
+                      <a:round/>
+                      <a:headEnd type="none" w="med" len="med"/>
+                      <a:tailEnd type="none" w="med" len="med"/>
+                    </a:lnT>
+                    <a:lnB w="6350" cap="flat" cmpd="sng" algn="ctr">
+                      <a:solidFill>
+                        <a:srgbClr val="D5DDEA"/>
+                      </a:solidFill>
+                      <a:prstDash val="solid"/>
+                      <a:round/>
+                      <a:headEnd type="none" w="med" len="med"/>
+                      <a:tailEnd type="none" w="med" len="med"/>
+                    </a:lnB>
+                    <a:solidFill>
+                      <a:srgbClr val="EFF3F9"/>
+                    </a:solidFill>
+                  </a:tcPr>
+                </a:tc>
+              </a:tr>
+              <a:tr h="384048">
+                <a:tc>
+                  <a:txBody>
+                    <a:bodyPr/>
+                    <a:lstStyle/>
+                    <a:p>
+                      <a:pPr algn="l" indent="0" marL="0">
+                        <a:buNone/>
+                      </a:pPr>
+                      <a:r>
+                        <a:rPr lang="en-US" sz="1100" b="1" dirty="0">
+                          <a:solidFill>
+                            <a:srgbClr val="122847"/>
+                          </a:solidFill>
+                          <a:latin typeface="Calibri" pitchFamily="34" charset="0"/>
+                          <a:ea typeface="Calibri" pitchFamily="34" charset="-122"/>
+                          <a:cs typeface="Calibri" pitchFamily="34" charset="-120"/>
+                        </a:rPr>
+                        <a:t>ATCNet</a:t>
+                      </a:r>
+                      <a:endParaRPr lang="en-US" sz="1100" dirty="0">
+                        <a:latin typeface="Calibri" charset="0"/>
+                        <a:ea typeface="Calibri" charset="0"/>
+                        <a:cs typeface="Calibri" charset="0"/>
+                      </a:endParaRPr>
+                    </a:p>
+                  </a:txBody>
+                  <a:tcPr marL="101600" marR="101600" marT="38100" marB="38100" anchor="ctr">
+                    <a:lnL w="6350" cap="flat" cmpd="sng" algn="ctr">
+                      <a:solidFill>
+                        <a:srgbClr val="D5DDEA"/>
+                      </a:solidFill>
+                      <a:prstDash val="solid"/>
+                      <a:round/>
+                      <a:headEnd type="none" w="med" len="med"/>
+                      <a:tailEnd type="none" w="med" len="med"/>
+                    </a:lnL>
+                    <a:lnR w="6350" cap="flat" cmpd="sng" algn="ctr">
+                      <a:solidFill>
+                        <a:srgbClr val="D5DDEA"/>
+                      </a:solidFill>
+                      <a:prstDash val="solid"/>
+                      <a:round/>
+                      <a:headEnd type="none" w="med" len="med"/>
+                      <a:tailEnd type="none" w="med" len="med"/>
+                    </a:lnR>
+                    <a:lnT w="6350" cap="flat" cmpd="sng" algn="ctr">
+                      <a:solidFill>
+                        <a:srgbClr val="D5DDEA"/>
+                      </a:solidFill>
+                      <a:prstDash val="solid"/>
+                      <a:round/>
+                      <a:headEnd type="none" w="med" len="med"/>
+                      <a:tailEnd type="none" w="med" len="med"/>
+                    </a:lnT>
+                    <a:lnB w="6350" cap="flat" cmpd="sng" algn="ctr">
+                      <a:solidFill>
+                        <a:srgbClr val="D5DDEA"/>
+                      </a:solidFill>
+                      <a:prstDash val="solid"/>
+                      <a:round/>
+                      <a:headEnd type="none" w="med" len="med"/>
+                      <a:tailEnd type="none" w="med" len="med"/>
+                    </a:lnB>
+                    <a:solidFill>
+                      <a:srgbClr val="FFFFFF"/>
+                    </a:solidFill>
+                  </a:tcPr>
+                </a:tc>
+                <a:tc>
+                  <a:txBody>
+                    <a:bodyPr/>
+                    <a:lstStyle/>
+                    <a:p>
+                      <a:pPr algn="ctr" indent="0" marL="0">
+                        <a:buNone/>
+                      </a:pPr>
+                      <a:r>
+                        <a:rPr lang="en-US" sz="1100" dirty="0">
+                          <a:solidFill>
+                            <a:srgbClr val="122847"/>
+                          </a:solidFill>
+                          <a:latin typeface="Calibri" pitchFamily="34" charset="0"/>
+                          <a:ea typeface="Calibri" pitchFamily="34" charset="-122"/>
+                          <a:cs typeface="Calibri" pitchFamily="34" charset="-120"/>
+                        </a:rPr>
+                        <a:t>85.38%</a:t>
+                      </a:r>
+                      <a:endParaRPr lang="en-US" sz="1100" dirty="0">
+                        <a:latin typeface="Calibri" charset="0"/>
+                        <a:ea typeface="Calibri" charset="0"/>
+                        <a:cs typeface="Calibri" charset="0"/>
+                      </a:endParaRPr>
+                    </a:p>
+                  </a:txBody>
+                  <a:tcPr marL="101600" marR="101600" marT="38100" marB="38100" anchor="ctr">
+                    <a:lnL w="6350" cap="flat" cmpd="sng" algn="ctr">
+                      <a:solidFill>
+                        <a:srgbClr val="D5DDEA"/>
+                      </a:solidFill>
+                      <a:prstDash val="solid"/>
+                      <a:round/>
+                      <a:headEnd type="none" w="med" len="med"/>
+                      <a:tailEnd type="none" w="med" len="med"/>
+                    </a:lnL>
+                    <a:lnR w="6350" cap="flat" cmpd="sng" algn="ctr">
+                      <a:solidFill>
+                        <a:srgbClr val="D5DDEA"/>
+                      </a:solidFill>
+                      <a:prstDash val="solid"/>
+                      <a:round/>
+                      <a:headEnd type="none" w="med" len="med"/>
+                      <a:tailEnd type="none" w="med" len="med"/>
+                    </a:lnR>
+                    <a:lnT w="6350" cap="flat" cmpd="sng" algn="ctr">
+                      <a:solidFill>
+                        <a:srgbClr val="D5DDEA"/>
+                      </a:solidFill>
+                      <a:prstDash val="solid"/>
+                      <a:round/>
+                      <a:headEnd type="none" w="med" len="med"/>
+                      <a:tailEnd type="none" w="med" len="med"/>
+                    </a:lnT>
+                    <a:lnB w="6350" cap="flat" cmpd="sng" algn="ctr">
+                      <a:solidFill>
+                        <a:srgbClr val="D5DDEA"/>
+                      </a:solidFill>
+                      <a:prstDash val="solid"/>
+                      <a:round/>
+                      <a:headEnd type="none" w="med" len="med"/>
+                      <a:tailEnd type="none" w="med" len="med"/>
+                    </a:lnB>
+                    <a:solidFill>
+                      <a:srgbClr val="FFFFFF"/>
+                    </a:solidFill>
+                  </a:tcPr>
+                </a:tc>
+                <a:tc>
+                  <a:txBody>
+                    <a:bodyPr/>
+                    <a:lstStyle/>
+                    <a:p>
+                      <a:pPr algn="l" indent="0" marL="0">
+                        <a:buNone/>
+                      </a:pPr>
+                      <a:r>
+                        <a:rPr lang="en-US" sz="1100" dirty="0">
+                          <a:solidFill>
+                            <a:srgbClr val="122847"/>
+                          </a:solidFill>
+                          <a:latin typeface="Calibri" pitchFamily="34" charset="0"/>
+                          <a:ea typeface="Calibri" pitchFamily="34" charset="-122"/>
+                          <a:cs typeface="Calibri" pitchFamily="34" charset="-120"/>
+                        </a:rPr>
+                        <a:t>Paper, subject-dependent</a:t>
+                      </a:r>
+                      <a:endParaRPr lang="en-US" sz="1100" dirty="0">
+                        <a:latin typeface="Calibri" charset="0"/>
+                        <a:ea typeface="Calibri" charset="0"/>
+                        <a:cs typeface="Calibri" charset="0"/>
+                      </a:endParaRPr>
+                    </a:p>
+                  </a:txBody>
+                  <a:tcPr marL="101600" marR="101600" marT="38100" marB="38100" anchor="ctr">
+                    <a:lnL w="6350" cap="flat" cmpd="sng" algn="ctr">
+                      <a:solidFill>
+                        <a:srgbClr val="D5DDEA"/>
+                      </a:solidFill>
+                      <a:prstDash val="solid"/>
+                      <a:round/>
+                      <a:headEnd type="none" w="med" len="med"/>
+                      <a:tailEnd type="none" w="med" len="med"/>
+                    </a:lnL>
+                    <a:lnR w="6350" cap="flat" cmpd="sng" algn="ctr">
+                      <a:solidFill>
+                        <a:srgbClr val="D5DDEA"/>
+                      </a:solidFill>
+                      <a:prstDash val="solid"/>
+                      <a:round/>
+                      <a:headEnd type="none" w="med" len="med"/>
+                      <a:tailEnd type="none" w="med" len="med"/>
+                    </a:lnR>
+                    <a:lnT w="6350" cap="flat" cmpd="sng" algn="ctr">
+                      <a:solidFill>
+                        <a:srgbClr val="D5DDEA"/>
+                      </a:solidFill>
+                      <a:prstDash val="solid"/>
+                      <a:round/>
+                      <a:headEnd type="none" w="med" len="med"/>
+                      <a:tailEnd type="none" w="med" len="med"/>
+                    </a:lnT>
+                    <a:lnB w="6350" cap="flat" cmpd="sng" algn="ctr">
+                      <a:solidFill>
+                        <a:srgbClr val="D5DDEA"/>
+                      </a:solidFill>
+                      <a:prstDash val="solid"/>
+                      <a:round/>
+                      <a:headEnd type="none" w="med" len="med"/>
+                      <a:tailEnd type="none" w="med" len="med"/>
+                    </a:lnB>
+                    <a:solidFill>
+                      <a:srgbClr val="FFFFFF"/>
+                    </a:solidFill>
+                  </a:tcPr>
+                </a:tc>
+              </a:tr>
+              <a:tr h="384048">
+                <a:tc>
+                  <a:txBody>
+                    <a:bodyPr/>
+                    <a:lstStyle/>
+                    <a:p>
+                      <a:pPr algn="l" indent="0" marL="0">
+                        <a:buNone/>
+                      </a:pPr>
+                      <a:r>
+                        <a:rPr lang="en-US" sz="1100" b="1" dirty="0">
+                          <a:solidFill>
+                            <a:srgbClr val="122847"/>
+                          </a:solidFill>
+                          <a:latin typeface="Calibri" pitchFamily="34" charset="0"/>
+                          <a:ea typeface="Calibri" pitchFamily="34" charset="-122"/>
+                          <a:cs typeface="Calibri" pitchFamily="34" charset="-120"/>
+                        </a:rPr>
+                        <a:t>ATCNet</a:t>
+                      </a:r>
+                      <a:endParaRPr lang="en-US" sz="1100" dirty="0">
+                        <a:latin typeface="Calibri" charset="0"/>
+                        <a:ea typeface="Calibri" charset="0"/>
+                        <a:cs typeface="Calibri" charset="0"/>
+                      </a:endParaRPr>
+                    </a:p>
+                  </a:txBody>
+                  <a:tcPr marL="101600" marR="101600" marT="38100" marB="38100" anchor="ctr">
+                    <a:lnL w="6350" cap="flat" cmpd="sng" algn="ctr">
+                      <a:solidFill>
+                        <a:srgbClr val="D5DDEA"/>
+                      </a:solidFill>
+                      <a:prstDash val="solid"/>
+                      <a:round/>
+                      <a:headEnd type="none" w="med" len="med"/>
+                      <a:tailEnd type="none" w="med" len="med"/>
+                    </a:lnL>
+                    <a:lnR w="6350" cap="flat" cmpd="sng" algn="ctr">
+                      <a:solidFill>
+                        <a:srgbClr val="D5DDEA"/>
+                      </a:solidFill>
+                      <a:prstDash val="solid"/>
+                      <a:round/>
+                      <a:headEnd type="none" w="med" len="med"/>
+                      <a:tailEnd type="none" w="med" len="med"/>
+                    </a:lnR>
+                    <a:lnT w="6350" cap="flat" cmpd="sng" algn="ctr">
+                      <a:solidFill>
+                        <a:srgbClr val="D5DDEA"/>
+                      </a:solidFill>
+                      <a:prstDash val="solid"/>
+                      <a:round/>
+                      <a:headEnd type="none" w="med" len="med"/>
+                      <a:tailEnd type="none" w="med" len="med"/>
+                    </a:lnT>
+                    <a:lnB w="6350" cap="flat" cmpd="sng" algn="ctr">
+                      <a:solidFill>
+                        <a:srgbClr val="D5DDEA"/>
+                      </a:solidFill>
+                      <a:prstDash val="solid"/>
+                      <a:round/>
+                      <a:headEnd type="none" w="med" len="med"/>
+                      <a:tailEnd type="none" w="med" len="med"/>
+                    </a:lnB>
+                    <a:solidFill>
+                      <a:srgbClr val="EFF3F9"/>
+                    </a:solidFill>
+                  </a:tcPr>
+                </a:tc>
+                <a:tc>
+                  <a:txBody>
+                    <a:bodyPr/>
+                    <a:lstStyle/>
+                    <a:p>
+                      <a:pPr algn="ctr" indent="0" marL="0">
+                        <a:buNone/>
+                      </a:pPr>
+                      <a:r>
+                        <a:rPr lang="en-US" sz="1100" dirty="0">
+                          <a:solidFill>
+                            <a:srgbClr val="122847"/>
+                          </a:solidFill>
+                          <a:latin typeface="Calibri" pitchFamily="34" charset="0"/>
+                          <a:ea typeface="Calibri" pitchFamily="34" charset="-122"/>
+                          <a:cs typeface="Calibri" pitchFamily="34" charset="-120"/>
+                        </a:rPr>
+                        <a:t>81.10%</a:t>
+                      </a:r>
+                      <a:endParaRPr lang="en-US" sz="1100" dirty="0">
+                        <a:latin typeface="Calibri" charset="0"/>
+                        <a:ea typeface="Calibri" charset="0"/>
+                        <a:cs typeface="Calibri" charset="0"/>
+                      </a:endParaRPr>
+                    </a:p>
+                  </a:txBody>
+                  <a:tcPr marL="101600" marR="101600" marT="38100" marB="38100" anchor="ctr">
+                    <a:lnL w="6350" cap="flat" cmpd="sng" algn="ctr">
+                      <a:solidFill>
+                        <a:srgbClr val="D5DDEA"/>
+                      </a:solidFill>
+                      <a:prstDash val="solid"/>
+                      <a:round/>
+                      <a:headEnd type="none" w="med" len="med"/>
+                      <a:tailEnd type="none" w="med" len="med"/>
+                    </a:lnL>
+                    <a:lnR w="6350" cap="flat" cmpd="sng" algn="ctr">
+                      <a:solidFill>
+                        <a:srgbClr val="D5DDEA"/>
+                      </a:solidFill>
+                      <a:prstDash val="solid"/>
+                      <a:round/>
+                      <a:headEnd type="none" w="med" len="med"/>
+                      <a:tailEnd type="none" w="med" len="med"/>
+                    </a:lnR>
+                    <a:lnT w="6350" cap="flat" cmpd="sng" algn="ctr">
+                      <a:solidFill>
+                        <a:srgbClr val="D5DDEA"/>
+                      </a:solidFill>
+                      <a:prstDash val="solid"/>
+                      <a:round/>
+                      <a:headEnd type="none" w="med" len="med"/>
+                      <a:tailEnd type="none" w="med" len="med"/>
+                    </a:lnT>
+                    <a:lnB w="6350" cap="flat" cmpd="sng" algn="ctr">
+                      <a:solidFill>
+                        <a:srgbClr val="D5DDEA"/>
+                      </a:solidFill>
+                      <a:prstDash val="solid"/>
+                      <a:round/>
+                      <a:headEnd type="none" w="med" len="med"/>
+                      <a:tailEnd type="none" w="med" len="med"/>
+                    </a:lnB>
+                    <a:solidFill>
+                      <a:srgbClr val="EFF3F9"/>
+                    </a:solidFill>
+                  </a:tcPr>
+                </a:tc>
+                <a:tc>
+                  <a:txBody>
+                    <a:bodyPr/>
+                    <a:lstStyle/>
+                    <a:p>
+                      <a:pPr algn="l" indent="0" marL="0">
+                        <a:buNone/>
+                      </a:pPr>
+                      <a:r>
+                        <a:rPr lang="en-US" sz="1100" dirty="0">
+                          <a:solidFill>
+                            <a:srgbClr val="122847"/>
+                          </a:solidFill>
+                          <a:latin typeface="Calibri" pitchFamily="34" charset="0"/>
+                          <a:ea typeface="Calibri" pitchFamily="34" charset="-122"/>
+                          <a:cs typeface="Calibri" pitchFamily="34" charset="-120"/>
+                        </a:rPr>
+                        <a:t>ATCNet repository script</a:t>
+                      </a:r>
+                      <a:endParaRPr lang="en-US" sz="1100" dirty="0">
+                        <a:latin typeface="Calibri" charset="0"/>
+                        <a:ea typeface="Calibri" charset="0"/>
+                        <a:cs typeface="Calibri" charset="0"/>
+                      </a:endParaRPr>
+                    </a:p>
+                  </a:txBody>
+                  <a:tcPr marL="101600" marR="101600" marT="38100" marB="38100" anchor="ctr">
+                    <a:lnL w="6350" cap="flat" cmpd="sng" algn="ctr">
+                      <a:solidFill>
+                        <a:srgbClr val="D5DDEA"/>
+                      </a:solidFill>
+                      <a:prstDash val="solid"/>
+                      <a:round/>
+                      <a:headEnd type="none" w="med" len="med"/>
+                      <a:tailEnd type="none" w="med" len="med"/>
+                    </a:lnL>
+                    <a:lnR w="6350" cap="flat" cmpd="sng" algn="ctr">
+                      <a:solidFill>
+                        <a:srgbClr val="D5DDEA"/>
+                      </a:solidFill>
+                      <a:prstDash val="solid"/>
+                      <a:round/>
+                      <a:headEnd type="none" w="med" len="med"/>
+                      <a:tailEnd type="none" w="med" len="med"/>
+                    </a:lnR>
+                    <a:lnT w="6350" cap="flat" cmpd="sng" algn="ctr">
+                      <a:solidFill>
+                        <a:srgbClr val="D5DDEA"/>
+                      </a:solidFill>
+                      <a:prstDash val="solid"/>
+                      <a:round/>
+                      <a:headEnd type="none" w="med" len="med"/>
+                      <a:tailEnd type="none" w="med" len="med"/>
+                    </a:lnT>
+                    <a:lnB w="6350" cap="flat" cmpd="sng" algn="ctr">
+                      <a:solidFill>
+                        <a:srgbClr val="D5DDEA"/>
+                      </a:solidFill>
+                      <a:prstDash val="solid"/>
+                      <a:round/>
+                      <a:headEnd type="none" w="med" len="med"/>
+                      <a:tailEnd type="none" w="med" len="med"/>
+                    </a:lnB>
+                    <a:solidFill>
+                      <a:srgbClr val="EFF3F9"/>
+                    </a:solidFill>
+                  </a:tcPr>
+                </a:tc>
+              </a:tr>
+              <a:tr h="384048">
+                <a:tc>
+                  <a:txBody>
+                    <a:bodyPr/>
+                    <a:lstStyle/>
+                    <a:p>
+                      <a:pPr algn="l" indent="0" marL="0">
+                        <a:buNone/>
+                      </a:pPr>
+                      <a:r>
+                        <a:rPr lang="en-US" sz="1100" b="1" dirty="0">
+                          <a:solidFill>
+                            <a:srgbClr val="122847"/>
+                          </a:solidFill>
+                          <a:latin typeface="Calibri" pitchFamily="34" charset="0"/>
+                          <a:ea typeface="Calibri" pitchFamily="34" charset="-122"/>
+                          <a:cs typeface="Calibri" pitchFamily="34" charset="-120"/>
+                        </a:rPr>
+                        <a:t>EEGNet</a:t>
+                      </a:r>
+                      <a:endParaRPr lang="en-US" sz="1100" dirty="0">
+                        <a:latin typeface="Calibri" charset="0"/>
+                        <a:ea typeface="Calibri" charset="0"/>
+                        <a:cs typeface="Calibri" charset="0"/>
+                      </a:endParaRPr>
+                    </a:p>
+                  </a:txBody>
+                  <a:tcPr marL="101600" marR="101600" marT="38100" marB="38100" anchor="ctr">
+                    <a:lnL w="6350" cap="flat" cmpd="sng" algn="ctr">
+                      <a:solidFill>
+                        <a:srgbClr val="D5DDEA"/>
+                      </a:solidFill>
+                      <a:prstDash val="solid"/>
+                      <a:round/>
+                      <a:headEnd type="none" w="med" len="med"/>
+                      <a:tailEnd type="none" w="med" len="med"/>
+                    </a:lnL>
+                    <a:lnR w="6350" cap="flat" cmpd="sng" algn="ctr">
+                      <a:solidFill>
+                        <a:srgbClr val="D5DDEA"/>
+                      </a:solidFill>
+                      <a:prstDash val="solid"/>
+                      <a:round/>
+                      <a:headEnd type="none" w="med" len="med"/>
+                      <a:tailEnd type="none" w="med" len="med"/>
+                    </a:lnR>
+                    <a:lnT w="6350" cap="flat" cmpd="sng" algn="ctr">
+                      <a:solidFill>
+                        <a:srgbClr val="D5DDEA"/>
+                      </a:solidFill>
+                      <a:prstDash val="solid"/>
+                      <a:round/>
+                      <a:headEnd type="none" w="med" len="med"/>
+                      <a:tailEnd type="none" w="med" len="med"/>
+                    </a:lnT>
+                    <a:lnB w="6350" cap="flat" cmpd="sng" algn="ctr">
+                      <a:solidFill>
+                        <a:srgbClr val="D5DDEA"/>
+                      </a:solidFill>
+                      <a:prstDash val="solid"/>
+                      <a:round/>
+                      <a:headEnd type="none" w="med" len="med"/>
+                      <a:tailEnd type="none" w="med" len="med"/>
+                    </a:lnB>
+                    <a:solidFill>
+                      <a:srgbClr val="FFFFFF"/>
+                    </a:solidFill>
+                  </a:tcPr>
+                </a:tc>
+                <a:tc>
+                  <a:txBody>
+                    <a:bodyPr/>
+                    <a:lstStyle/>
+                    <a:p>
+                      <a:pPr algn="ctr" indent="0" marL="0">
+                        <a:buNone/>
+                      </a:pPr>
+                      <a:r>
+                        <a:rPr lang="en-US" sz="1100" dirty="0">
+                          <a:solidFill>
+                            <a:srgbClr val="122847"/>
+                          </a:solidFill>
+                          <a:latin typeface="Calibri" pitchFamily="34" charset="0"/>
+                          <a:ea typeface="Calibri" pitchFamily="34" charset="-122"/>
+                          <a:cs typeface="Calibri" pitchFamily="34" charset="-120"/>
+                        </a:rPr>
+                        <a:t>68.67%</a:t>
+                      </a:r>
+                      <a:endParaRPr lang="en-US" sz="1100" dirty="0">
+                        <a:latin typeface="Calibri" charset="0"/>
+                        <a:ea typeface="Calibri" charset="0"/>
+                        <a:cs typeface="Calibri" charset="0"/>
+                      </a:endParaRPr>
+                    </a:p>
+                  </a:txBody>
+                  <a:tcPr marL="101600" marR="101600" marT="38100" marB="38100" anchor="ctr">
+                    <a:lnL w="6350" cap="flat" cmpd="sng" algn="ctr">
+                      <a:solidFill>
+                        <a:srgbClr val="D5DDEA"/>
+                      </a:solidFill>
+                      <a:prstDash val="solid"/>
+                      <a:round/>
+                      <a:headEnd type="none" w="med" len="med"/>
+                      <a:tailEnd type="none" w="med" len="med"/>
+                    </a:lnL>
+                    <a:lnR w="6350" cap="flat" cmpd="sng" algn="ctr">
+                      <a:solidFill>
+                        <a:srgbClr val="D5DDEA"/>
+                      </a:solidFill>
+                      <a:prstDash val="solid"/>
+                      <a:round/>
+                      <a:headEnd type="none" w="med" len="med"/>
+                      <a:tailEnd type="none" w="med" len="med"/>
+                    </a:lnR>
+                    <a:lnT w="6350" cap="flat" cmpd="sng" algn="ctr">
+                      <a:solidFill>
+                        <a:srgbClr val="D5DDEA"/>
+                      </a:solidFill>
+                      <a:prstDash val="solid"/>
+                      <a:round/>
+                      <a:headEnd type="none" w="med" len="med"/>
+                      <a:tailEnd type="none" w="med" len="med"/>
+                    </a:lnT>
+                    <a:lnB w="6350" cap="flat" cmpd="sng" algn="ctr">
+                      <a:solidFill>
+                        <a:srgbClr val="D5DDEA"/>
+                      </a:solidFill>
+                      <a:prstDash val="solid"/>
+                      <a:round/>
+                      <a:headEnd type="none" w="med" len="med"/>
+                      <a:tailEnd type="none" w="med" len="med"/>
+                    </a:lnB>
+                    <a:solidFill>
+                      <a:srgbClr val="FFFFFF"/>
+                    </a:solidFill>
+                  </a:tcPr>
+                </a:tc>
+                <a:tc>
+                  <a:txBody>
+                    <a:bodyPr/>
+                    <a:lstStyle/>
+                    <a:p>
+                      <a:pPr algn="l" indent="0" marL="0">
+                        <a:buNone/>
+                      </a:pPr>
+                      <a:r>
+                        <a:rPr lang="en-US" sz="1100" dirty="0">
+                          <a:solidFill>
+                            <a:srgbClr val="122847"/>
+                          </a:solidFill>
+                          <a:latin typeface="Calibri" pitchFamily="34" charset="0"/>
+                          <a:ea typeface="Calibri" pitchFamily="34" charset="-122"/>
+                          <a:cs typeface="Calibri" pitchFamily="34" charset="-120"/>
+                        </a:rPr>
+                        <a:t>ATCNet repository script</a:t>
+                      </a:r>
+                      <a:endParaRPr lang="en-US" sz="1100" dirty="0">
+                        <a:latin typeface="Calibri" charset="0"/>
+                        <a:ea typeface="Calibri" charset="0"/>
+                        <a:cs typeface="Calibri" charset="0"/>
+                      </a:endParaRPr>
+                    </a:p>
+                  </a:txBody>
+                  <a:tcPr marL="101600" marR="101600" marT="38100" marB="38100" anchor="ctr">
+                    <a:lnL w="6350" cap="flat" cmpd="sng" algn="ctr">
+                      <a:solidFill>
+                        <a:srgbClr val="D5DDEA"/>
+                      </a:solidFill>
+                      <a:prstDash val="solid"/>
+                      <a:round/>
+                      <a:headEnd type="none" w="med" len="med"/>
+                      <a:tailEnd type="none" w="med" len="med"/>
+                    </a:lnL>
+                    <a:lnR w="6350" cap="flat" cmpd="sng" algn="ctr">
+                      <a:solidFill>
+                        <a:srgbClr val="D5DDEA"/>
+                      </a:solidFill>
+                      <a:prstDash val="solid"/>
+                      <a:round/>
+                      <a:headEnd type="none" w="med" len="med"/>
+                      <a:tailEnd type="none" w="med" len="med"/>
+                    </a:lnR>
+                    <a:lnT w="6350" cap="flat" cmpd="sng" algn="ctr">
+                      <a:solidFill>
+                        <a:srgbClr val="D5DDEA"/>
+                      </a:solidFill>
+                      <a:prstDash val="solid"/>
+                      <a:round/>
+                      <a:headEnd type="none" w="med" len="med"/>
+                      <a:tailEnd type="none" w="med" len="med"/>
+                    </a:lnT>
+                    <a:lnB w="6350" cap="flat" cmpd="sng" algn="ctr">
+                      <a:solidFill>
+                        <a:srgbClr val="D5DDEA"/>
+                      </a:solidFill>
+                      <a:prstDash val="solid"/>
+                      <a:round/>
+                      <a:headEnd type="none" w="med" len="med"/>
+                      <a:tailEnd type="none" w="med" len="med"/>
+                    </a:lnB>
+                    <a:solidFill>
+                      <a:srgbClr val="FFFFFF"/>
+                    </a:solidFill>
+                  </a:tcPr>
+                </a:tc>
+              </a:tr>
+              <a:tr h="384048">
+                <a:tc>
+                  <a:txBody>
+                    <a:bodyPr/>
+                    <a:lstStyle/>
+                    <a:p>
+                      <a:pPr algn="l" indent="0" marL="0">
+                        <a:buNone/>
+                      </a:pPr>
+                      <a:r>
+                        <a:rPr lang="en-US" sz="1100" b="1" dirty="0">
+                          <a:solidFill>
+                            <a:srgbClr val="122847"/>
+                          </a:solidFill>
+                          <a:latin typeface="Calibri" pitchFamily="34" charset="0"/>
+                          <a:ea typeface="Calibri" pitchFamily="34" charset="-122"/>
+                          <a:cs typeface="Calibri" pitchFamily="34" charset="-120"/>
+                        </a:rPr>
+                        <a:t>EEGNet+</a:t>
+                      </a:r>
+                      <a:endParaRPr lang="en-US" sz="1100" dirty="0">
+                        <a:latin typeface="Calibri" charset="0"/>
+                        <a:ea typeface="Calibri" charset="0"/>
+                        <a:cs typeface="Calibri" charset="0"/>
+                      </a:endParaRPr>
+                    </a:p>
+                  </a:txBody>
+                  <a:tcPr marL="101600" marR="101600" marT="38100" marB="38100" anchor="ctr">
+                    <a:lnL w="6350" cap="flat" cmpd="sng" algn="ctr">
+                      <a:solidFill>
+                        <a:srgbClr val="D5DDEA"/>
+                      </a:solidFill>
+                      <a:prstDash val="solid"/>
+                      <a:round/>
+                      <a:headEnd type="none" w="med" len="med"/>
+                      <a:tailEnd type="none" w="med" len="med"/>
+                    </a:lnL>
+                    <a:lnR w="6350" cap="flat" cmpd="sng" algn="ctr">
+                      <a:solidFill>
+                        <a:srgbClr val="D5DDEA"/>
+                      </a:solidFill>
+                      <a:prstDash val="solid"/>
+                      <a:round/>
+                      <a:headEnd type="none" w="med" len="med"/>
+                      <a:tailEnd type="none" w="med" len="med"/>
+                    </a:lnR>
+                    <a:lnT w="6350" cap="flat" cmpd="sng" algn="ctr">
+                      <a:solidFill>
+                        <a:srgbClr val="D5DDEA"/>
+                      </a:solidFill>
+                      <a:prstDash val="solid"/>
+                      <a:round/>
+                      <a:headEnd type="none" w="med" len="med"/>
+                      <a:tailEnd type="none" w="med" len="med"/>
+                    </a:lnT>
+                    <a:lnB w="6350" cap="flat" cmpd="sng" algn="ctr">
+                      <a:solidFill>
+                        <a:srgbClr val="D5DDEA"/>
+                      </a:solidFill>
+                      <a:prstDash val="solid"/>
+                      <a:round/>
+                      <a:headEnd type="none" w="med" len="med"/>
+                      <a:tailEnd type="none" w="med" len="med"/>
+                    </a:lnB>
+                    <a:solidFill>
+                      <a:srgbClr val="EFF3F9"/>
+                    </a:solidFill>
+                  </a:tcPr>
+                </a:tc>
+                <a:tc>
+                  <a:txBody>
+                    <a:bodyPr/>
+                    <a:lstStyle/>
+                    <a:p>
+                      <a:pPr algn="ctr" indent="0" marL="0">
+                        <a:buNone/>
+                      </a:pPr>
+                      <a:r>
+                        <a:rPr lang="en-US" sz="1100" dirty="0">
+                          <a:solidFill>
+                            <a:srgbClr val="122847"/>
+                          </a:solidFill>
+                          <a:latin typeface="Calibri" pitchFamily="34" charset="0"/>
+                          <a:ea typeface="Calibri" pitchFamily="34" charset="-122"/>
+                          <a:cs typeface="Calibri" pitchFamily="34" charset="-120"/>
+                        </a:rPr>
+                        <a:t>77.39%</a:t>
+                      </a:r>
+                      <a:endParaRPr lang="en-US" sz="1100" dirty="0">
+                        <a:latin typeface="Calibri" charset="0"/>
+                        <a:ea typeface="Calibri" charset="0"/>
+                        <a:cs typeface="Calibri" charset="0"/>
+                      </a:endParaRPr>
+                    </a:p>
+                  </a:txBody>
+                  <a:tcPr marL="101600" marR="101600" marT="38100" marB="38100" anchor="ctr">
+                    <a:lnL w="6350" cap="flat" cmpd="sng" algn="ctr">
+                      <a:solidFill>
+                        <a:srgbClr val="D5DDEA"/>
+                      </a:solidFill>
+                      <a:prstDash val="solid"/>
+                      <a:round/>
+                      <a:headEnd type="none" w="med" len="med"/>
+                      <a:tailEnd type="none" w="med" len="med"/>
+                    </a:lnL>
+                    <a:lnR w="6350" cap="flat" cmpd="sng" algn="ctr">
+                      <a:solidFill>
+                        <a:srgbClr val="D5DDEA"/>
+                      </a:solidFill>
+                      <a:prstDash val="solid"/>
+                      <a:round/>
+                      <a:headEnd type="none" w="med" len="med"/>
+                      <a:tailEnd type="none" w="med" len="med"/>
+                    </a:lnR>
+                    <a:lnT w="6350" cap="flat" cmpd="sng" algn="ctr">
+                      <a:solidFill>
+                        <a:srgbClr val="D5DDEA"/>
+                      </a:solidFill>
+                      <a:prstDash val="solid"/>
+                      <a:round/>
+                      <a:headEnd type="none" w="med" len="med"/>
+                      <a:tailEnd type="none" w="med" len="med"/>
+                    </a:lnT>
+                    <a:lnB w="6350" cap="flat" cmpd="sng" algn="ctr">
+                      <a:solidFill>
+                        <a:srgbClr val="D5DDEA"/>
+                      </a:solidFill>
+                      <a:prstDash val="solid"/>
+                      <a:round/>
+                      <a:headEnd type="none" w="med" len="med"/>
+                      <a:tailEnd type="none" w="med" len="med"/>
+                    </a:lnB>
+                    <a:solidFill>
+                      <a:srgbClr val="EFF3F9"/>
+                    </a:solidFill>
+                  </a:tcPr>
+                </a:tc>
+                <a:tc>
+                  <a:txBody>
+                    <a:bodyPr/>
+                    <a:lstStyle/>
+                    <a:p>
+                      <a:pPr algn="l" indent="0" marL="0">
+                        <a:buNone/>
+                      </a:pPr>
+                      <a:r>
+                        <a:rPr lang="en-US" sz="1100" dirty="0">
+                          <a:solidFill>
+                            <a:srgbClr val="122847"/>
+                          </a:solidFill>
+                          <a:latin typeface="Calibri" pitchFamily="34" charset="0"/>
+                          <a:ea typeface="Calibri" pitchFamily="34" charset="-122"/>
+                          <a:cs typeface="Calibri" pitchFamily="34" charset="-120"/>
+                        </a:rPr>
+                        <a:t>Zhao et al. (2024), re-implemented</a:t>
+                      </a:r>
+                      <a:endParaRPr lang="en-US" sz="1100" dirty="0">
+                        <a:latin typeface="Calibri" charset="0"/>
+                        <a:ea typeface="Calibri" charset="0"/>
+                        <a:cs typeface="Calibri" charset="0"/>
+                      </a:endParaRPr>
+                    </a:p>
+                  </a:txBody>
+                  <a:tcPr marL="101600" marR="101600" marT="38100" marB="38100" anchor="ctr">
+                    <a:lnL w="6350" cap="flat" cmpd="sng" algn="ctr">
+                      <a:solidFill>
+                        <a:srgbClr val="D5DDEA"/>
+                      </a:solidFill>
+                      <a:prstDash val="solid"/>
+                      <a:round/>
+                      <a:headEnd type="none" w="med" len="med"/>
+                      <a:tailEnd type="none" w="med" len="med"/>
+                    </a:lnL>
+                    <a:lnR w="6350" cap="flat" cmpd="sng" algn="ctr">
+                      <a:solidFill>
+                        <a:srgbClr val="D5DDEA"/>
+                      </a:solidFill>
+                      <a:prstDash val="solid"/>
+                      <a:round/>
+                      <a:headEnd type="none" w="med" len="med"/>
+                      <a:tailEnd type="none" w="med" len="med"/>
+                    </a:lnR>
+                    <a:lnT w="6350" cap="flat" cmpd="sng" algn="ctr">
+                      <a:solidFill>
+                        <a:srgbClr val="D5DDEA"/>
+                      </a:solidFill>
+                      <a:prstDash val="solid"/>
+                      <a:round/>
+                      <a:headEnd type="none" w="med" len="med"/>
+                      <a:tailEnd type="none" w="med" len="med"/>
+                    </a:lnT>
+                    <a:lnB w="6350" cap="flat" cmpd="sng" algn="ctr">
+                      <a:solidFill>
+                        <a:srgbClr val="D5DDEA"/>
+                      </a:solidFill>
+                      <a:prstDash val="solid"/>
+                      <a:round/>
+                      <a:headEnd type="none" w="med" len="med"/>
+                      <a:tailEnd type="none" w="med" len="med"/>
+                    </a:lnB>
+                    <a:solidFill>
+                      <a:srgbClr val="EFF3F9"/>
+                    </a:solidFill>
+                  </a:tcPr>
+                </a:tc>
+              </a:tr>
+            </a:tbl>
+          </a:graphicData>
+        </a:graphic>
+      </p:graphicFrame>
+      <p:sp>
+        <p:nvSpPr>
+          <p:cNvPr id="9" name="Text 5"/>
+          <p:cNvSpPr txBox="1"/>
+          <p:nvPr/>
+        </p:nvSpPr>
+        <p:spPr>
+          <a:xfrm>
+            <a:off x="566928" y="4754880"/>
+            <a:ext cx="11027664" cy="868680"/>
           </a:xfrm>
           <a:prstGeom prst="rect">
             <a:avLst/>
@@ -2675,7 +5492,7 @@
               <a:buNone/>
             </a:pPr>
             <a:r>
-              <a:rPr lang="en-US" sz="1080" dirty="0">
+              <a:rPr lang="en-US" sz="1150" i="1" dirty="0">
                 <a:solidFill>
                   <a:srgbClr val="5A6478"/>
                 </a:solidFill>
@@ -2683,363 +5500,9 @@
                 <a:ea typeface="Calibri" pitchFamily="34" charset="-122"/>
                 <a:cs typeface="Calibri" pitchFamily="34" charset="-120"/>
               </a:rPr>
-              <a:t>Mean and standard deviation over nine folds</a:t>
+              <a:t>Cross-subject: each subject held out in turn, trained on the other eight for 600 epochs on the 2–6 s window, no alignment and no fine-tuning on the held-out subject. + marks baselines re-implemented by the CTNet authors under the same conditions. This is the reference for our own cross-subject results.</a:t>
             </a:r>
-            <a:endParaRPr lang="en-US" sz="1080" dirty="0"/>
-          </a:p>
-        </p:txBody>
-      </p:sp>
-      <p:sp>
-        <p:nvSpPr>
-          <p:cNvPr id="9" name="Shape 6"/>
-          <p:cNvSpPr/>
-          <p:nvPr/>
-        </p:nvSpPr>
-        <p:spPr>
-          <a:xfrm>
-            <a:off x="3410712" y="4830172"/>
-            <a:ext cx="2670048" cy="1024128"/>
-          </a:xfrm>
-          <a:prstGeom prst="roundRect">
-            <a:avLst>
-              <a:gd name="adj" fmla="val 6250"/>
-            </a:avLst>
-          </a:prstGeom>
-          <a:solidFill>
-            <a:srgbClr val="EFF3F9"/>
-          </a:solidFill>
-          <a:ln w="12700">
-            <a:solidFill>
-              <a:srgbClr val="EFF3F9"/>
-            </a:solidFill>
-            <a:prstDash val="solid"/>
-          </a:ln>
-        </p:spPr>
-      </p:sp>
-      <p:sp>
-        <p:nvSpPr>
-          <p:cNvPr id="10" name="Text 7"/>
-          <p:cNvSpPr txBox="1"/>
-          <p:nvPr/>
-        </p:nvSpPr>
-        <p:spPr>
-          <a:xfrm>
-            <a:off x="3593592" y="4958188"/>
-            <a:ext cx="2304288" cy="274320"/>
-          </a:xfrm>
-          <a:prstGeom prst="rect">
-            <a:avLst/>
-          </a:prstGeom>
-          <a:noFill/>
-          <a:ln/>
-        </p:spPr>
-        <p:txBody>
-          <a:bodyPr wrap="square" lIns="0" tIns="0" rIns="0" bIns="0" rtlCol="0" anchor="ctr"/>
-          <a:lstStyle/>
-          <a:p>
-            <a:pPr indent="0" marL="0">
-              <a:buNone/>
-            </a:pPr>
-            <a:r>
-              <a:rPr lang="en-US" sz="1200" b="1" dirty="0">
-                <a:solidFill>
-                  <a:srgbClr val="1B3A6B"/>
-                </a:solidFill>
-                <a:latin typeface="Calibri" pitchFamily="34" charset="0"/>
-                <a:ea typeface="Calibri" pitchFamily="34" charset="-122"/>
-                <a:cs typeface="Calibri" pitchFamily="34" charset="-120"/>
-              </a:rPr>
-              <a:t>Cohen's kappa</a:t>
-            </a:r>
-            <a:endParaRPr lang="en-US" sz="1200" dirty="0"/>
-          </a:p>
-        </p:txBody>
-      </p:sp>
-      <p:sp>
-        <p:nvSpPr>
-          <p:cNvPr id="11" name="Text 8"/>
-          <p:cNvSpPr txBox="1"/>
-          <p:nvPr/>
-        </p:nvSpPr>
-        <p:spPr>
-          <a:xfrm>
-            <a:off x="3593592" y="5241652"/>
-            <a:ext cx="2304288" cy="548640"/>
-          </a:xfrm>
-          <a:prstGeom prst="rect">
-            <a:avLst/>
-          </a:prstGeom>
-          <a:noFill/>
-          <a:ln/>
-        </p:spPr>
-        <p:txBody>
-          <a:bodyPr wrap="square" lIns="0" tIns="0" rIns="0" bIns="0" rtlCol="0" anchor="t"/>
-          <a:lstStyle/>
-          <a:p>
-            <a:pPr indent="0" marL="0">
-              <a:buNone/>
-            </a:pPr>
-            <a:r>
-              <a:rPr lang="en-US" sz="1080" dirty="0">
-                <a:solidFill>
-                  <a:srgbClr val="5A6478"/>
-                </a:solidFill>
-                <a:latin typeface="Calibri" pitchFamily="34" charset="0"/>
-                <a:ea typeface="Calibri" pitchFamily="34" charset="-122"/>
-                <a:cs typeface="Calibri" pitchFamily="34" charset="-120"/>
-              </a:rPr>
-              <a:t>Corrected for chance agreement</a:t>
-            </a:r>
-            <a:endParaRPr lang="en-US" sz="1080" dirty="0"/>
-          </a:p>
-        </p:txBody>
-      </p:sp>
-      <p:sp>
-        <p:nvSpPr>
-          <p:cNvPr id="12" name="Shape 9"/>
-          <p:cNvSpPr/>
-          <p:nvPr/>
-        </p:nvSpPr>
-        <p:spPr>
-          <a:xfrm>
-            <a:off x="6254496" y="4830172"/>
-            <a:ext cx="2670048" cy="1024128"/>
-          </a:xfrm>
-          <a:prstGeom prst="roundRect">
-            <a:avLst>
-              <a:gd name="adj" fmla="val 6250"/>
-            </a:avLst>
-          </a:prstGeom>
-          <a:solidFill>
-            <a:srgbClr val="EFF3F9"/>
-          </a:solidFill>
-          <a:ln w="12700">
-            <a:solidFill>
-              <a:srgbClr val="EFF3F9"/>
-            </a:solidFill>
-            <a:prstDash val="solid"/>
-          </a:ln>
-        </p:spPr>
-      </p:sp>
-      <p:sp>
-        <p:nvSpPr>
-          <p:cNvPr id="13" name="Text 10"/>
-          <p:cNvSpPr txBox="1"/>
-          <p:nvPr/>
-        </p:nvSpPr>
-        <p:spPr>
-          <a:xfrm>
-            <a:off x="6437376" y="4958188"/>
-            <a:ext cx="2304288" cy="274320"/>
-          </a:xfrm>
-          <a:prstGeom prst="rect">
-            <a:avLst/>
-          </a:prstGeom>
-          <a:noFill/>
-          <a:ln/>
-        </p:spPr>
-        <p:txBody>
-          <a:bodyPr wrap="square" lIns="0" tIns="0" rIns="0" bIns="0" rtlCol="0" anchor="ctr"/>
-          <a:lstStyle/>
-          <a:p>
-            <a:pPr indent="0" marL="0">
-              <a:buNone/>
-            </a:pPr>
-            <a:r>
-              <a:rPr lang="en-US" sz="1200" b="1" dirty="0">
-                <a:solidFill>
-                  <a:srgbClr val="1B3A6B"/>
-                </a:solidFill>
-                <a:latin typeface="Calibri" pitchFamily="34" charset="0"/>
-                <a:ea typeface="Calibri" pitchFamily="34" charset="-122"/>
-                <a:cs typeface="Calibri" pitchFamily="34" charset="-120"/>
-              </a:rPr>
-              <a:t>Precision, recall, F1</a:t>
-            </a:r>
-            <a:endParaRPr lang="en-US" sz="1200" dirty="0"/>
-          </a:p>
-        </p:txBody>
-      </p:sp>
-      <p:sp>
-        <p:nvSpPr>
-          <p:cNvPr id="14" name="Text 11"/>
-          <p:cNvSpPr txBox="1"/>
-          <p:nvPr/>
-        </p:nvSpPr>
-        <p:spPr>
-          <a:xfrm>
-            <a:off x="6437376" y="5241652"/>
-            <a:ext cx="2304288" cy="548640"/>
-          </a:xfrm>
-          <a:prstGeom prst="rect">
-            <a:avLst/>
-          </a:prstGeom>
-          <a:noFill/>
-          <a:ln/>
-        </p:spPr>
-        <p:txBody>
-          <a:bodyPr wrap="square" lIns="0" tIns="0" rIns="0" bIns="0" rtlCol="0" anchor="t"/>
-          <a:lstStyle/>
-          <a:p>
-            <a:pPr indent="0" marL="0">
-              <a:buNone/>
-            </a:pPr>
-            <a:r>
-              <a:rPr lang="en-US" sz="1080" dirty="0">
-                <a:solidFill>
-                  <a:srgbClr val="5A6478"/>
-                </a:solidFill>
-                <a:latin typeface="Calibri" pitchFamily="34" charset="0"/>
-                <a:ea typeface="Calibri" pitchFamily="34" charset="-122"/>
-                <a:cs typeface="Calibri" pitchFamily="34" charset="-120"/>
-              </a:rPr>
-              <a:t>Macro-averaged over the four classes</a:t>
-            </a:r>
-            <a:endParaRPr lang="en-US" sz="1080" dirty="0"/>
-          </a:p>
-        </p:txBody>
-      </p:sp>
-      <p:sp>
-        <p:nvSpPr>
-          <p:cNvPr id="15" name="Shape 12"/>
-          <p:cNvSpPr/>
-          <p:nvPr/>
-        </p:nvSpPr>
-        <p:spPr>
-          <a:xfrm>
-            <a:off x="9098280" y="4830172"/>
-            <a:ext cx="2670048" cy="1024128"/>
-          </a:xfrm>
-          <a:prstGeom prst="roundRect">
-            <a:avLst>
-              <a:gd name="adj" fmla="val 6250"/>
-            </a:avLst>
-          </a:prstGeom>
-          <a:solidFill>
-            <a:srgbClr val="F1EDF9"/>
-          </a:solidFill>
-          <a:ln w="12700">
-            <a:solidFill>
-              <a:srgbClr val="F1EDF9"/>
-            </a:solidFill>
-            <a:prstDash val="solid"/>
-          </a:ln>
-        </p:spPr>
-      </p:sp>
-      <p:sp>
-        <p:nvSpPr>
-          <p:cNvPr id="16" name="Text 13"/>
-          <p:cNvSpPr txBox="1"/>
-          <p:nvPr/>
-        </p:nvSpPr>
-        <p:spPr>
-          <a:xfrm>
-            <a:off x="9281160" y="4958188"/>
-            <a:ext cx="2304288" cy="274320"/>
-          </a:xfrm>
-          <a:prstGeom prst="rect">
-            <a:avLst/>
-          </a:prstGeom>
-          <a:noFill/>
-          <a:ln/>
-        </p:spPr>
-        <p:txBody>
-          <a:bodyPr wrap="square" lIns="0" tIns="0" rIns="0" bIns="0" rtlCol="0" anchor="ctr"/>
-          <a:lstStyle/>
-          <a:p>
-            <a:pPr indent="0" marL="0">
-              <a:buNone/>
-            </a:pPr>
-            <a:r>
-              <a:rPr lang="en-US" sz="1200" b="1" dirty="0">
-                <a:solidFill>
-                  <a:srgbClr val="5B3E96"/>
-                </a:solidFill>
-                <a:latin typeface="Calibri" pitchFamily="34" charset="0"/>
-                <a:ea typeface="Calibri" pitchFamily="34" charset="-122"/>
-                <a:cs typeface="Calibri" pitchFamily="34" charset="-120"/>
-              </a:rPr>
-              <a:t>Parameters and time</a:t>
-            </a:r>
-            <a:endParaRPr lang="en-US" sz="1200" dirty="0"/>
-          </a:p>
-        </p:txBody>
-      </p:sp>
-      <p:sp>
-        <p:nvSpPr>
-          <p:cNvPr id="17" name="Text 14"/>
-          <p:cNvSpPr txBox="1"/>
-          <p:nvPr/>
-        </p:nvSpPr>
-        <p:spPr>
-          <a:xfrm>
-            <a:off x="9281160" y="5241652"/>
-            <a:ext cx="2304288" cy="548640"/>
-          </a:xfrm>
-          <a:prstGeom prst="rect">
-            <a:avLst/>
-          </a:prstGeom>
-          <a:noFill/>
-          <a:ln/>
-        </p:spPr>
-        <p:txBody>
-          <a:bodyPr wrap="square" lIns="0" tIns="0" rIns="0" bIns="0" rtlCol="0" anchor="t"/>
-          <a:lstStyle/>
-          <a:p>
-            <a:pPr indent="0" marL="0">
-              <a:buNone/>
-            </a:pPr>
-            <a:r>
-              <a:rPr lang="en-US" sz="1080" dirty="0">
-                <a:solidFill>
-                  <a:srgbClr val="5A6478"/>
-                </a:solidFill>
-                <a:latin typeface="Calibri" pitchFamily="34" charset="0"/>
-                <a:ea typeface="Calibri" pitchFamily="34" charset="-122"/>
-                <a:cs typeface="Calibri" pitchFamily="34" charset="-120"/>
-              </a:rPr>
-              <a:t>Model complexity and computational cost</a:t>
-            </a:r>
-            <a:endParaRPr lang="en-US" sz="1080" dirty="0"/>
-          </a:p>
-        </p:txBody>
-      </p:sp>
-      <p:sp>
-        <p:nvSpPr>
-          <p:cNvPr id="18" name="Text 15"/>
-          <p:cNvSpPr txBox="1"/>
-          <p:nvPr/>
-        </p:nvSpPr>
-        <p:spPr>
-          <a:xfrm>
-            <a:off x="566928" y="5964028"/>
-            <a:ext cx="10332720" cy="457200"/>
-          </a:xfrm>
-          <a:prstGeom prst="rect">
-            <a:avLst/>
-          </a:prstGeom>
-          <a:noFill/>
-          <a:ln/>
-        </p:spPr>
-        <p:txBody>
-          <a:bodyPr wrap="square" lIns="0" tIns="0" rIns="0" bIns="0" rtlCol="0" anchor="ctr"/>
-          <a:lstStyle/>
-          <a:p>
-            <a:pPr indent="0" marL="0">
-              <a:buNone/>
-            </a:pPr>
-            <a:r>
-              <a:rPr lang="en-US" sz="1180" dirty="0">
-                <a:solidFill>
-                  <a:srgbClr val="122847"/>
-                </a:solidFill>
-                <a:latin typeface="Calibri" pitchFamily="34" charset="0"/>
-                <a:ea typeface="Calibri" pitchFamily="34" charset="-122"/>
-                <a:cs typeface="Calibri" pitchFamily="34" charset="-120"/>
-              </a:rPr>
-              <a:t>A Wilcoxon signed-rank test, paired across the nine subjects, is used to decide whether a difference between two models is meaningful. Results are reported per subject as well as averaged.</a:t>
-            </a:r>
-            <a:endParaRPr lang="en-US" sz="1180" dirty="0"/>
+            <a:endParaRPr lang="en-US" sz="1150" dirty="0"/>
           </a:p>
         </p:txBody>
       </p:sp>
@@ -3108,7 +5571,7 @@
                 <a:ea typeface="Calibri" pitchFamily="34" charset="-122"/>
                 <a:cs typeface="Calibri" pitchFamily="34" charset="-120"/>
               </a:rPr>
-              <a:t>EXPECTED OUTCOMES AND NOVELTY</a:t>
+              <a:t>EVALUATION STRATEGY</a:t>
             </a:r>
             <a:endParaRPr lang="en-US" sz="1050" dirty="0"/>
           </a:p>
@@ -3147,7 +5610,7 @@
                 <a:ea typeface="Cambria" pitchFamily="34" charset="-122"/>
                 <a:cs typeface="Cambria" pitchFamily="34" charset="-120"/>
               </a:rPr>
-              <a:t>What we expect, and what is actually new</a:t>
+              <a:t>Leave-one-subject-out evaluation</a:t>
             </a:r>
             <a:endParaRPr lang="en-US" sz="2700" dirty="0"/>
           </a:p>
@@ -3192,20 +5655,44 @@
           </a:p>
         </p:txBody>
       </p:sp>
-      <p:sp>
-        <p:nvSpPr>
-          <p:cNvPr id="5" name="Shape 3"/>
+      <p:pic>
+        <p:nvPicPr>
+          <p:cNvPr id="5" name="Image 0" descr="fig/f_loso_concept.png">    </p:cNvPr>
+          <p:cNvPicPr>
+            <a:picLocks noChangeAspect="1"/>
+          </p:cNvPicPr>
+          <p:nvPr/>
+        </p:nvPicPr>
+        <p:blipFill>
+          <a:blip r:embed="rId1"/>
+          <a:stretch>
+            <a:fillRect/>
+          </a:stretch>
+        </p:blipFill>
+        <p:spPr>
+          <a:xfrm>
+            <a:off x="896112" y="1261872"/>
+            <a:ext cx="10378440" cy="3312268"/>
+          </a:xfrm>
+          <a:prstGeom prst="rect">
+            <a:avLst/>
+          </a:prstGeom>
+        </p:spPr>
+      </p:pic>
+      <p:sp>
+        <p:nvSpPr>
+          <p:cNvPr id="6" name="Shape 3"/>
           <p:cNvSpPr/>
           <p:nvPr/>
         </p:nvSpPr>
         <p:spPr>
           <a:xfrm>
-            <a:off x="566928" y="1325880"/>
-            <a:ext cx="5422392" cy="3246120"/>
+            <a:off x="566928" y="4830172"/>
+            <a:ext cx="2670048" cy="1024128"/>
           </a:xfrm>
           <a:prstGeom prst="roundRect">
             <a:avLst>
-              <a:gd name="adj" fmla="val 1972"/>
+              <a:gd name="adj" fmla="val 6250"/>
             </a:avLst>
           </a:prstGeom>
           <a:solidFill>
@@ -3221,14 +5708,14 @@
       </p:sp>
       <p:sp>
         <p:nvSpPr>
-          <p:cNvPr id="6" name="Text 4"/>
+          <p:cNvPr id="7" name="Text 4"/>
           <p:cNvSpPr txBox="1"/>
           <p:nvPr/>
         </p:nvSpPr>
         <p:spPr>
           <a:xfrm>
-            <a:off x="822960" y="1481328"/>
-            <a:ext cx="4937760" cy="292608"/>
+            <a:off x="749808" y="4958188"/>
+            <a:ext cx="2304288" cy="274320"/>
           </a:xfrm>
           <a:prstGeom prst="rect">
             <a:avLst/>
@@ -3244,7 +5731,7 @@
               <a:buNone/>
             </a:pPr>
             <a:r>
-              <a:rPr lang="en-US" sz="1300" b="1" dirty="0">
+              <a:rPr lang="en-US" sz="1200" b="1" dirty="0">
                 <a:solidFill>
                   <a:srgbClr val="1B3A6B"/>
                 </a:solidFill>
@@ -3252,22 +5739,22 @@
                 <a:ea typeface="Calibri" pitchFamily="34" charset="-122"/>
                 <a:cs typeface="Calibri" pitchFamily="34" charset="-120"/>
               </a:rPr>
-              <a:t>Expected outcomes</a:t>
+              <a:t>Accuracy</a:t>
             </a:r>
-            <a:endParaRPr lang="en-US" sz="1300" dirty="0"/>
+            <a:endParaRPr lang="en-US" sz="1200" dirty="0"/>
           </a:p>
         </p:txBody>
       </p:sp>
       <p:sp>
         <p:nvSpPr>
-          <p:cNvPr id="7" name="Text 5"/>
+          <p:cNvPr id="8" name="Text 5"/>
           <p:cNvSpPr txBox="1"/>
           <p:nvPr/>
         </p:nvSpPr>
         <p:spPr>
           <a:xfrm>
-            <a:off x="1069848" y="1874520"/>
-            <a:ext cx="4709160" cy="548640"/>
+            <a:off x="749808" y="5241652"/>
+            <a:ext cx="2304288" cy="548640"/>
           </a:xfrm>
           <a:prstGeom prst="rect">
             <a:avLst/>
@@ -3279,35 +5766,61 @@
           <a:bodyPr wrap="square" lIns="0" tIns="0" rIns="0" bIns="0" rtlCol="0" anchor="t"/>
           <a:lstStyle/>
           <a:p>
-            <a:pPr marL="342900" indent="-342900">
-              <a:buSzPct val="100000"/>
-              <a:buChar char="•"/>
+            <a:pPr indent="0" marL="0">
+              <a:buNone/>
             </a:pPr>
             <a:r>
-              <a:rPr lang="en-US" sz="1160" dirty="0">
+              <a:rPr lang="en-US" sz="1080" dirty="0">
                 <a:solidFill>
-                  <a:srgbClr val="122847"/>
+                  <a:srgbClr val="5A6478"/>
                 </a:solidFill>
                 <a:latin typeface="Calibri" pitchFamily="34" charset="0"/>
                 <a:ea typeface="Calibri" pitchFamily="34" charset="-122"/>
                 <a:cs typeface="Calibri" pitchFamily="34" charset="-120"/>
               </a:rPr>
-              <a:t>Better generalisation to unseen subjects than the heavier baselines</a:t>
+              <a:t>Mean and standard deviation over nine folds</a:t>
             </a:r>
-            <a:endParaRPr lang="en-US" sz="1160" dirty="0"/>
+            <a:endParaRPr lang="en-US" sz="1080" dirty="0"/>
           </a:p>
         </p:txBody>
       </p:sp>
       <p:sp>
         <p:nvSpPr>
-          <p:cNvPr id="8" name="Text 6"/>
+          <p:cNvPr id="9" name="Shape 6"/>
+          <p:cNvSpPr/>
+          <p:nvPr/>
+        </p:nvSpPr>
+        <p:spPr>
+          <a:xfrm>
+            <a:off x="3410712" y="4830172"/>
+            <a:ext cx="2670048" cy="1024128"/>
+          </a:xfrm>
+          <a:prstGeom prst="roundRect">
+            <a:avLst>
+              <a:gd name="adj" fmla="val 6250"/>
+            </a:avLst>
+          </a:prstGeom>
+          <a:solidFill>
+            <a:srgbClr val="EFF3F9"/>
+          </a:solidFill>
+          <a:ln w="12700">
+            <a:solidFill>
+              <a:srgbClr val="EFF3F9"/>
+            </a:solidFill>
+            <a:prstDash val="solid"/>
+          </a:ln>
+        </p:spPr>
+      </p:sp>
+      <p:sp>
+        <p:nvSpPr>
+          <p:cNvPr id="10" name="Text 7"/>
           <p:cNvSpPr txBox="1"/>
           <p:nvPr/>
         </p:nvSpPr>
         <p:spPr>
           <a:xfrm>
-            <a:off x="1069848" y="2478024"/>
-            <a:ext cx="4709160" cy="548640"/>
+            <a:off x="3593592" y="4958188"/>
+            <a:ext cx="2304288" cy="274320"/>
           </a:xfrm>
           <a:prstGeom prst="rect">
             <a:avLst/>
@@ -3316,38 +5829,37 @@
           <a:ln/>
         </p:spPr>
         <p:txBody>
-          <a:bodyPr wrap="square" lIns="0" tIns="0" rIns="0" bIns="0" rtlCol="0" anchor="t"/>
+          <a:bodyPr wrap="square" lIns="0" tIns="0" rIns="0" bIns="0" rtlCol="0" anchor="ctr"/>
           <a:lstStyle/>
           <a:p>
-            <a:pPr marL="342900" indent="-342900">
-              <a:buSzPct val="100000"/>
-              <a:buChar char="•"/>
+            <a:pPr indent="0" marL="0">
+              <a:buNone/>
             </a:pPr>
             <a:r>
-              <a:rPr lang="en-US" sz="1160" dirty="0">
+              <a:rPr lang="en-US" sz="1200" b="1" dirty="0">
                 <a:solidFill>
-                  <a:srgbClr val="122847"/>
+                  <a:srgbClr val="1B3A6B"/>
                 </a:solidFill>
                 <a:latin typeface="Calibri" pitchFamily="34" charset="0"/>
                 <a:ea typeface="Calibri" pitchFamily="34" charset="-122"/>
                 <a:cs typeface="Calibri" pitchFamily="34" charset="-120"/>
               </a:rPr>
-              <a:t>Competitive motor imagery classification accuracy</a:t>
+              <a:t>Cohen's kappa</a:t>
             </a:r>
-            <a:endParaRPr lang="en-US" sz="1160" dirty="0"/>
+            <a:endParaRPr lang="en-US" sz="1200" dirty="0"/>
           </a:p>
         </p:txBody>
       </p:sp>
       <p:sp>
         <p:nvSpPr>
-          <p:cNvPr id="9" name="Text 7"/>
+          <p:cNvPr id="11" name="Text 8"/>
           <p:cNvSpPr txBox="1"/>
           <p:nvPr/>
         </p:nvSpPr>
         <p:spPr>
           <a:xfrm>
-            <a:off x="1069848" y="3081528"/>
-            <a:ext cx="4709160" cy="548640"/>
+            <a:off x="3593592" y="5241652"/>
+            <a:ext cx="2304288" cy="548640"/>
           </a:xfrm>
           <a:prstGeom prst="rect">
             <a:avLst/>
@@ -3359,35 +5871,61 @@
           <a:bodyPr wrap="square" lIns="0" tIns="0" rIns="0" bIns="0" rtlCol="0" anchor="t"/>
           <a:lstStyle/>
           <a:p>
-            <a:pPr marL="342900" indent="-342900">
-              <a:buSzPct val="100000"/>
-              <a:buChar char="•"/>
+            <a:pPr indent="0" marL="0">
+              <a:buNone/>
             </a:pPr>
             <a:r>
-              <a:rPr lang="en-US" sz="1160" dirty="0">
+              <a:rPr lang="en-US" sz="1080" dirty="0">
                 <a:solidFill>
-                  <a:srgbClr val="122847"/>
+                  <a:srgbClr val="5A6478"/>
                 </a:solidFill>
                 <a:latin typeface="Calibri" pitchFamily="34" charset="0"/>
                 <a:ea typeface="Calibri" pitchFamily="34" charset="-122"/>
                 <a:cs typeface="Calibri" pitchFamily="34" charset="-120"/>
               </a:rPr>
-              <a:t>A lightweight architecture — 20,996 parameters, about one fifth the size of ATCNet</a:t>
+              <a:t>Corrected for chance agreement</a:t>
             </a:r>
-            <a:endParaRPr lang="en-US" sz="1160" dirty="0"/>
+            <a:endParaRPr lang="en-US" sz="1080" dirty="0"/>
           </a:p>
         </p:txBody>
       </p:sp>
       <p:sp>
         <p:nvSpPr>
-          <p:cNvPr id="10" name="Text 8"/>
+          <p:cNvPr id="12" name="Shape 9"/>
+          <p:cNvSpPr/>
+          <p:nvPr/>
+        </p:nvSpPr>
+        <p:spPr>
+          <a:xfrm>
+            <a:off x="6254496" y="4830172"/>
+            <a:ext cx="2670048" cy="1024128"/>
+          </a:xfrm>
+          <a:prstGeom prst="roundRect">
+            <a:avLst>
+              <a:gd name="adj" fmla="val 6250"/>
+            </a:avLst>
+          </a:prstGeom>
+          <a:solidFill>
+            <a:srgbClr val="EFF3F9"/>
+          </a:solidFill>
+          <a:ln w="12700">
+            <a:solidFill>
+              <a:srgbClr val="EFF3F9"/>
+            </a:solidFill>
+            <a:prstDash val="solid"/>
+          </a:ln>
+        </p:spPr>
+      </p:sp>
+      <p:sp>
+        <p:nvSpPr>
+          <p:cNvPr id="13" name="Text 10"/>
           <p:cNvSpPr txBox="1"/>
           <p:nvPr/>
         </p:nvSpPr>
         <p:spPr>
           <a:xfrm>
-            <a:off x="1069848" y="3685032"/>
-            <a:ext cx="4709160" cy="548640"/>
+            <a:off x="6437376" y="4958188"/>
+            <a:ext cx="2304288" cy="274320"/>
           </a:xfrm>
           <a:prstGeom prst="rect">
             <a:avLst/>
@@ -3396,42 +5934,80 @@
           <a:ln/>
         </p:spPr>
         <p:txBody>
-          <a:bodyPr wrap="square" lIns="0" tIns="0" rIns="0" bIns="0" rtlCol="0" anchor="t"/>
+          <a:bodyPr wrap="square" lIns="0" tIns="0" rIns="0" bIns="0" rtlCol="0" anchor="ctr"/>
           <a:lstStyle/>
           <a:p>
-            <a:pPr marL="342900" indent="-342900">
-              <a:buSzPct val="100000"/>
-              <a:buChar char="•"/>
+            <a:pPr indent="0" marL="0">
+              <a:buNone/>
             </a:pPr>
             <a:r>
-              <a:rPr lang="en-US" sz="1160" dirty="0">
+              <a:rPr lang="en-US" sz="1200" b="1" dirty="0">
                 <a:solidFill>
-                  <a:srgbClr val="122847"/>
+                  <a:srgbClr val="1B3A6B"/>
                 </a:solidFill>
                 <a:latin typeface="Calibri" pitchFamily="34" charset="0"/>
                 <a:ea typeface="Calibri" pitchFamily="34" charset="-122"/>
                 <a:cs typeface="Calibri" pitchFamily="34" charset="-120"/>
               </a:rPr>
-              <a:t>Reduced dependence on subject-specific calibration</a:t>
+              <a:t>Precision, recall, F1</a:t>
             </a:r>
-            <a:endParaRPr lang="en-US" sz="1160" dirty="0"/>
+            <a:endParaRPr lang="en-US" sz="1200" dirty="0"/>
           </a:p>
         </p:txBody>
       </p:sp>
       <p:sp>
         <p:nvSpPr>
-          <p:cNvPr id="11" name="Shape 9"/>
+          <p:cNvPr id="14" name="Text 11"/>
+          <p:cNvSpPr txBox="1"/>
+          <p:nvPr/>
+        </p:nvSpPr>
+        <p:spPr>
+          <a:xfrm>
+            <a:off x="6437376" y="5241652"/>
+            <a:ext cx="2304288" cy="548640"/>
+          </a:xfrm>
+          <a:prstGeom prst="rect">
+            <a:avLst/>
+          </a:prstGeom>
+          <a:noFill/>
+          <a:ln/>
+        </p:spPr>
+        <p:txBody>
+          <a:bodyPr wrap="square" lIns="0" tIns="0" rIns="0" bIns="0" rtlCol="0" anchor="t"/>
+          <a:lstStyle/>
+          <a:p>
+            <a:pPr indent="0" marL="0">
+              <a:buNone/>
+            </a:pPr>
+            <a:r>
+              <a:rPr lang="en-US" sz="1080" dirty="0">
+                <a:solidFill>
+                  <a:srgbClr val="5A6478"/>
+                </a:solidFill>
+                <a:latin typeface="Calibri" pitchFamily="34" charset="0"/>
+                <a:ea typeface="Calibri" pitchFamily="34" charset="-122"/>
+                <a:cs typeface="Calibri" pitchFamily="34" charset="-120"/>
+              </a:rPr>
+              <a:t>Macro-averaged over the four classes</a:t>
+            </a:r>
+            <a:endParaRPr lang="en-US" sz="1080" dirty="0"/>
+          </a:p>
+        </p:txBody>
+      </p:sp>
+      <p:sp>
+        <p:nvSpPr>
+          <p:cNvPr id="15" name="Shape 12"/>
           <p:cNvSpPr/>
           <p:nvPr/>
         </p:nvSpPr>
         <p:spPr>
           <a:xfrm>
-            <a:off x="6172200" y="1325880"/>
-            <a:ext cx="5422392" cy="3246120"/>
+            <a:off x="9098280" y="4830172"/>
+            <a:ext cx="2670048" cy="1024128"/>
           </a:xfrm>
           <a:prstGeom prst="roundRect">
             <a:avLst>
-              <a:gd name="adj" fmla="val 1972"/>
+              <a:gd name="adj" fmla="val 6250"/>
             </a:avLst>
           </a:prstGeom>
           <a:solidFill>
@@ -3447,14 +6023,14 @@
       </p:sp>
       <p:sp>
         <p:nvSpPr>
-          <p:cNvPr id="12" name="Text 10"/>
+          <p:cNvPr id="16" name="Text 13"/>
           <p:cNvSpPr txBox="1"/>
           <p:nvPr/>
         </p:nvSpPr>
         <p:spPr>
           <a:xfrm>
-            <a:off x="6428232" y="1481328"/>
-            <a:ext cx="4937760" cy="292608"/>
+            <a:off x="9281160" y="4958188"/>
+            <a:ext cx="2304288" cy="274320"/>
           </a:xfrm>
           <a:prstGeom prst="rect">
             <a:avLst/>
@@ -3470,7 +6046,7 @@
               <a:buNone/>
             </a:pPr>
             <a:r>
-              <a:rPr lang="en-US" sz="1300" b="1" dirty="0">
+              <a:rPr lang="en-US" sz="1200" b="1" dirty="0">
                 <a:solidFill>
                   <a:srgbClr val="5B3E96"/>
                 </a:solidFill>
@@ -3478,22 +6054,22 @@
                 <a:ea typeface="Calibri" pitchFamily="34" charset="-122"/>
                 <a:cs typeface="Calibri" pitchFamily="34" charset="-120"/>
               </a:rPr>
-              <a:t>What the project contributes</a:t>
+              <a:t>Parameters and time</a:t>
             </a:r>
-            <a:endParaRPr lang="en-US" sz="1300" dirty="0"/>
+            <a:endParaRPr lang="en-US" sz="1200" dirty="0"/>
           </a:p>
         </p:txBody>
       </p:sp>
       <p:sp>
         <p:nvSpPr>
-          <p:cNvPr id="13" name="Text 11"/>
+          <p:cNvPr id="17" name="Text 14"/>
           <p:cNvSpPr txBox="1"/>
           <p:nvPr/>
         </p:nvSpPr>
         <p:spPr>
           <a:xfrm>
-            <a:off x="6675120" y="1874520"/>
-            <a:ext cx="4709160" cy="548640"/>
+            <a:off x="9281160" y="5241652"/>
+            <a:ext cx="2304288" cy="548640"/>
           </a:xfrm>
           <a:prstGeom prst="rect">
             <a:avLst/>
@@ -3505,182 +6081,34 @@
           <a:bodyPr wrap="square" lIns="0" tIns="0" rIns="0" bIns="0" rtlCol="0" anchor="t"/>
           <a:lstStyle/>
           <a:p>
-            <a:pPr marL="342900" indent="-342900">
-              <a:buSzPct val="100000"/>
-              <a:buChar char="•"/>
+            <a:pPr indent="0" marL="0">
+              <a:buNone/>
             </a:pPr>
             <a:r>
-              <a:rPr lang="en-US" sz="1160" dirty="0">
+              <a:rPr lang="en-US" sz="1080" dirty="0">
                 <a:solidFill>
-                  <a:srgbClr val="122847"/>
+                  <a:srgbClr val="5A6478"/>
                 </a:solidFill>
                 <a:latin typeface="Calibri" pitchFamily="34" charset="0"/>
                 <a:ea typeface="Calibri" pitchFamily="34" charset="-122"/>
                 <a:cs typeface="Calibri" pitchFamily="34" charset="-120"/>
               </a:rPr>
-              <a:t>A comparison of all four architectures under one identical LOSO protocol</a:t>
+              <a:t>Model complexity and computational cost</a:t>
             </a:r>
-            <a:endParaRPr lang="en-US" sz="1160" dirty="0"/>
+            <a:endParaRPr lang="en-US" sz="1080" dirty="0"/>
           </a:p>
         </p:txBody>
       </p:sp>
       <p:sp>
         <p:nvSpPr>
-          <p:cNvPr id="14" name="Text 12"/>
+          <p:cNvPr id="18" name="Text 15"/>
           <p:cNvSpPr txBox="1"/>
           <p:nvPr/>
         </p:nvSpPr>
         <p:spPr>
           <a:xfrm>
-            <a:off x="6675120" y="2478024"/>
-            <a:ext cx="4709160" cy="548640"/>
-          </a:xfrm>
-          <a:prstGeom prst="rect">
-            <a:avLst/>
-          </a:prstGeom>
-          <a:noFill/>
-          <a:ln/>
-        </p:spPr>
-        <p:txBody>
-          <a:bodyPr wrap="square" lIns="0" tIns="0" rIns="0" bIns="0" rtlCol="0" anchor="t"/>
-          <a:lstStyle/>
-          <a:p>
-            <a:pPr marL="342900" indent="-342900">
-              <a:buSzPct val="100000"/>
-              <a:buChar char="•"/>
-            </a:pPr>
-            <a:r>
-              <a:rPr lang="en-US" sz="1160" dirty="0">
-                <a:solidFill>
-                  <a:srgbClr val="122847"/>
-                </a:solidFill>
-                <a:latin typeface="Calibri" pitchFamily="34" charset="0"/>
-                <a:ea typeface="Calibri" pitchFamily="34" charset="-122"/>
-                <a:cs typeface="Calibri" pitchFamily="34" charset="-120"/>
-              </a:rPr>
-              <a:t>A specific lightweight combination, with attention depth reduced to suit the dataset size</a:t>
-            </a:r>
-            <a:endParaRPr lang="en-US" sz="1160" dirty="0"/>
-          </a:p>
-        </p:txBody>
-      </p:sp>
-      <p:sp>
-        <p:nvSpPr>
-          <p:cNvPr id="15" name="Text 13"/>
-          <p:cNvSpPr txBox="1"/>
-          <p:nvPr/>
-        </p:nvSpPr>
-        <p:spPr>
-          <a:xfrm>
-            <a:off x="6675120" y="3081528"/>
-            <a:ext cx="4709160" cy="548640"/>
-          </a:xfrm>
-          <a:prstGeom prst="rect">
-            <a:avLst/>
-          </a:prstGeom>
-          <a:noFill/>
-          <a:ln/>
-        </p:spPr>
-        <p:txBody>
-          <a:bodyPr wrap="square" lIns="0" tIns="0" rIns="0" bIns="0" rtlCol="0" anchor="t"/>
-          <a:lstStyle/>
-          <a:p>
-            <a:pPr marL="342900" indent="-342900">
-              <a:buSzPct val="100000"/>
-              <a:buChar char="•"/>
-            </a:pPr>
-            <a:r>
-              <a:rPr lang="en-US" sz="1160" dirty="0">
-                <a:solidFill>
-                  <a:srgbClr val="122847"/>
-                </a:solidFill>
-                <a:latin typeface="Calibri" pitchFamily="34" charset="0"/>
-                <a:ea typeface="Calibri" pitchFamily="34" charset="-122"/>
-                <a:cs typeface="Calibri" pitchFamily="34" charset="-120"/>
-              </a:rPr>
-              <a:t>A component-wise study showing what each part contributes to cross-subject accuracy</a:t>
-            </a:r>
-            <a:endParaRPr lang="en-US" sz="1160" dirty="0"/>
-          </a:p>
-        </p:txBody>
-      </p:sp>
-      <p:sp>
-        <p:nvSpPr>
-          <p:cNvPr id="16" name="Text 14"/>
-          <p:cNvSpPr txBox="1"/>
-          <p:nvPr/>
-        </p:nvSpPr>
-        <p:spPr>
-          <a:xfrm>
-            <a:off x="6675120" y="3685032"/>
-            <a:ext cx="4709160" cy="548640"/>
-          </a:xfrm>
-          <a:prstGeom prst="rect">
-            <a:avLst/>
-          </a:prstGeom>
-          <a:noFill/>
-          <a:ln/>
-        </p:spPr>
-        <p:txBody>
-          <a:bodyPr wrap="square" lIns="0" tIns="0" rIns="0" bIns="0" rtlCol="0" anchor="t"/>
-          <a:lstStyle/>
-          <a:p>
-            <a:pPr marL="342900" indent="-342900">
-              <a:buSzPct val="100000"/>
-              <a:buChar char="•"/>
-            </a:pPr>
-            <a:r>
-              <a:rPr lang="en-US" sz="1160" dirty="0">
-                <a:solidFill>
-                  <a:srgbClr val="122847"/>
-                </a:solidFill>
-                <a:latin typeface="Calibri" pitchFamily="34" charset="0"/>
-                <a:ea typeface="Calibri" pitchFamily="34" charset="-122"/>
-                <a:cs typeface="Calibri" pitchFamily="34" charset="-120"/>
-              </a:rPr>
-              <a:t>Accuracy measured against parameter count under a single protocol</a:t>
-            </a:r>
-            <a:endParaRPr lang="en-US" sz="1160" dirty="0"/>
-          </a:p>
-        </p:txBody>
-      </p:sp>
-      <p:sp>
-        <p:nvSpPr>
-          <p:cNvPr id="17" name="Shape 15"/>
-          <p:cNvSpPr/>
-          <p:nvPr/>
-        </p:nvSpPr>
-        <p:spPr>
-          <a:xfrm>
-            <a:off x="566928" y="4754880"/>
-            <a:ext cx="11027664" cy="1143000"/>
-          </a:xfrm>
-          <a:prstGeom prst="roundRect">
-            <a:avLst>
-              <a:gd name="adj" fmla="val 5600"/>
-            </a:avLst>
-          </a:prstGeom>
-          <a:solidFill>
-            <a:srgbClr val="122847"/>
-          </a:solidFill>
-          <a:ln w="12700">
-            <a:solidFill>
-              <a:srgbClr val="333333"/>
-            </a:solidFill>
-            <a:prstDash val="solid"/>
-          </a:ln>
-        </p:spPr>
-      </p:sp>
-      <p:sp>
-        <p:nvSpPr>
-          <p:cNvPr id="18" name="Text 16"/>
-          <p:cNvSpPr txBox="1"/>
-          <p:nvPr/>
-        </p:nvSpPr>
-        <p:spPr>
-          <a:xfrm>
-            <a:off x="886968" y="4901184"/>
-            <a:ext cx="10424160" cy="292608"/>
+            <a:off x="566928" y="5964028"/>
+            <a:ext cx="10332720" cy="457200"/>
           </a:xfrm>
           <a:prstGeom prst="rect">
             <a:avLst/>
@@ -3696,54 +6124,15 @@
               <a:buNone/>
             </a:pPr>
             <a:r>
-              <a:rPr lang="en-US" sz="1300" b="1" dirty="0">
+              <a:rPr lang="en-US" sz="1180" dirty="0">
                 <a:solidFill>
-                  <a:srgbClr val="C9D6EC"/>
+                  <a:srgbClr val="122847"/>
                 </a:solidFill>
                 <a:latin typeface="Calibri" pitchFamily="34" charset="0"/>
                 <a:ea typeface="Calibri" pitchFamily="34" charset="-122"/>
                 <a:cs typeface="Calibri" pitchFamily="34" charset="-120"/>
               </a:rPr>
-              <a:t>These are expected outcomes, not results.</a:t>
-            </a:r>
-            <a:endParaRPr lang="en-US" sz="1300" dirty="0"/>
-          </a:p>
-        </p:txBody>
-      </p:sp>
-      <p:sp>
-        <p:nvSpPr>
-          <p:cNvPr id="19" name="Text 17"/>
-          <p:cNvSpPr txBox="1"/>
-          <p:nvPr/>
-        </p:nvSpPr>
-        <p:spPr>
-          <a:xfrm>
-            <a:off x="886968" y="5193792"/>
-            <a:ext cx="10424160" cy="566928"/>
-          </a:xfrm>
-          <a:prstGeom prst="rect">
-            <a:avLst/>
-          </a:prstGeom>
-          <a:noFill/>
-          <a:ln/>
-        </p:spPr>
-        <p:txBody>
-          <a:bodyPr wrap="square" lIns="0" tIns="0" rIns="0" bIns="0" rtlCol="0" anchor="t"/>
-          <a:lstStyle/>
-          <a:p>
-            <a:pPr indent="0" marL="0">
-              <a:buNone/>
-            </a:pPr>
-            <a:r>
-              <a:rPr lang="en-US" sz="1180" dirty="0">
-                <a:solidFill>
-                  <a:srgbClr val="FFFFFF"/>
-                </a:solidFill>
-                <a:latin typeface="Calibri" pitchFamily="34" charset="0"/>
-                <a:ea typeface="Calibri" pitchFamily="34" charset="-122"/>
-                <a:cs typeface="Calibri" pitchFamily="34" charset="-120"/>
-              </a:rPr>
-              <a:t>No experiments have been run at this stage. The individual components are all taken from published work; what is proposed is the particular combination, the subject-independent evaluation, and the study of what each component contributes.</a:t>
+              <a:t>A Wilcoxon signed-rank test, paired across the nine subjects, is used to decide whether a difference between two models is meaningful. Results are reported per subject as well as averaged.</a:t>
             </a:r>
             <a:endParaRPr lang="en-US" sz="1180" dirty="0"/>
           </a:p>
@@ -3814,6 +6203,712 @@
                 <a:ea typeface="Calibri" pitchFamily="34" charset="-122"/>
                 <a:cs typeface="Calibri" pitchFamily="34" charset="-120"/>
               </a:rPr>
+              <a:t>EXPECTED OUTCOMES AND NOVELTY</a:t>
+            </a:r>
+            <a:endParaRPr lang="en-US" sz="1050" dirty="0"/>
+          </a:p>
+        </p:txBody>
+      </p:sp>
+      <p:sp>
+        <p:nvSpPr>
+          <p:cNvPr id="3" name="Text 1"/>
+          <p:cNvSpPr txBox="1"/>
+          <p:nvPr/>
+        </p:nvSpPr>
+        <p:spPr>
+          <a:xfrm>
+            <a:off x="566928" y="576072"/>
+            <a:ext cx="11027664" cy="530352"/>
+          </a:xfrm>
+          <a:prstGeom prst="rect">
+            <a:avLst/>
+          </a:prstGeom>
+          <a:noFill/>
+          <a:ln/>
+        </p:spPr>
+        <p:txBody>
+          <a:bodyPr wrap="square" lIns="0" tIns="0" rIns="0" bIns="0" rtlCol="0" anchor="t"/>
+          <a:lstStyle/>
+          <a:p>
+            <a:pPr indent="0" marL="0">
+              <a:buNone/>
+            </a:pPr>
+            <a:r>
+              <a:rPr lang="en-US" sz="2700" b="1" dirty="0">
+                <a:solidFill>
+                  <a:srgbClr val="122847"/>
+                </a:solidFill>
+                <a:latin typeface="Cambria" pitchFamily="34" charset="0"/>
+                <a:ea typeface="Cambria" pitchFamily="34" charset="-122"/>
+                <a:cs typeface="Cambria" pitchFamily="34" charset="-120"/>
+              </a:rPr>
+              <a:t>What we expect, and what is actually new</a:t>
+            </a:r>
+            <a:endParaRPr lang="en-US" sz="2700" dirty="0"/>
+          </a:p>
+        </p:txBody>
+      </p:sp>
+      <p:sp>
+        <p:nvSpPr>
+          <p:cNvPr id="4" name="Text 2"/>
+          <p:cNvSpPr txBox="1"/>
+          <p:nvPr/>
+        </p:nvSpPr>
+        <p:spPr>
+          <a:xfrm>
+            <a:off x="11045952" y="6419088"/>
+            <a:ext cx="548640" cy="237744"/>
+          </a:xfrm>
+          <a:prstGeom prst="rect">
+            <a:avLst/>
+          </a:prstGeom>
+          <a:noFill/>
+          <a:ln/>
+        </p:spPr>
+        <p:txBody>
+          <a:bodyPr wrap="square" lIns="0" tIns="0" rIns="0" bIns="0" rtlCol="0" anchor="ctr"/>
+          <a:lstStyle/>
+          <a:p>
+            <a:pPr algn="r" indent="0" marL="0">
+              <a:buNone/>
+            </a:pPr>
+            <a:r>
+              <a:rPr lang="en-US" sz="1000" dirty="0">
+                <a:solidFill>
+                  <a:srgbClr val="8C96AC"/>
+                </a:solidFill>
+                <a:latin typeface="Calibri" pitchFamily="34" charset="0"/>
+                <a:ea typeface="Calibri" pitchFamily="34" charset="-122"/>
+                <a:cs typeface="Calibri" pitchFamily="34" charset="-120"/>
+              </a:rPr>
+              <a:t>12</a:t>
+            </a:r>
+            <a:endParaRPr lang="en-US" sz="1000" dirty="0"/>
+          </a:p>
+        </p:txBody>
+      </p:sp>
+      <p:sp>
+        <p:nvSpPr>
+          <p:cNvPr id="5" name="Shape 3"/>
+          <p:cNvSpPr/>
+          <p:nvPr/>
+        </p:nvSpPr>
+        <p:spPr>
+          <a:xfrm>
+            <a:off x="566928" y="1325880"/>
+            <a:ext cx="5422392" cy="3246120"/>
+          </a:xfrm>
+          <a:prstGeom prst="roundRect">
+            <a:avLst>
+              <a:gd name="adj" fmla="val 1972"/>
+            </a:avLst>
+          </a:prstGeom>
+          <a:solidFill>
+            <a:srgbClr val="EFF3F9"/>
+          </a:solidFill>
+          <a:ln w="12700">
+            <a:solidFill>
+              <a:srgbClr val="EFF3F9"/>
+            </a:solidFill>
+            <a:prstDash val="solid"/>
+          </a:ln>
+        </p:spPr>
+      </p:sp>
+      <p:sp>
+        <p:nvSpPr>
+          <p:cNvPr id="6" name="Text 4"/>
+          <p:cNvSpPr txBox="1"/>
+          <p:nvPr/>
+        </p:nvSpPr>
+        <p:spPr>
+          <a:xfrm>
+            <a:off x="822960" y="1481328"/>
+            <a:ext cx="4937760" cy="292608"/>
+          </a:xfrm>
+          <a:prstGeom prst="rect">
+            <a:avLst/>
+          </a:prstGeom>
+          <a:noFill/>
+          <a:ln/>
+        </p:spPr>
+        <p:txBody>
+          <a:bodyPr wrap="square" lIns="0" tIns="0" rIns="0" bIns="0" rtlCol="0" anchor="ctr"/>
+          <a:lstStyle/>
+          <a:p>
+            <a:pPr indent="0" marL="0">
+              <a:buNone/>
+            </a:pPr>
+            <a:r>
+              <a:rPr lang="en-US" sz="1300" b="1" dirty="0">
+                <a:solidFill>
+                  <a:srgbClr val="1B3A6B"/>
+                </a:solidFill>
+                <a:latin typeface="Calibri" pitchFamily="34" charset="0"/>
+                <a:ea typeface="Calibri" pitchFamily="34" charset="-122"/>
+                <a:cs typeface="Calibri" pitchFamily="34" charset="-120"/>
+              </a:rPr>
+              <a:t>Expected outcomes</a:t>
+            </a:r>
+            <a:endParaRPr lang="en-US" sz="1300" dirty="0"/>
+          </a:p>
+        </p:txBody>
+      </p:sp>
+      <p:sp>
+        <p:nvSpPr>
+          <p:cNvPr id="7" name="Text 5"/>
+          <p:cNvSpPr txBox="1"/>
+          <p:nvPr/>
+        </p:nvSpPr>
+        <p:spPr>
+          <a:xfrm>
+            <a:off x="1069848" y="1874520"/>
+            <a:ext cx="4709160" cy="548640"/>
+          </a:xfrm>
+          <a:prstGeom prst="rect">
+            <a:avLst/>
+          </a:prstGeom>
+          <a:noFill/>
+          <a:ln/>
+        </p:spPr>
+        <p:txBody>
+          <a:bodyPr wrap="square" lIns="0" tIns="0" rIns="0" bIns="0" rtlCol="0" anchor="t"/>
+          <a:lstStyle/>
+          <a:p>
+            <a:pPr marL="342900" indent="-342900">
+              <a:buSzPct val="100000"/>
+              <a:buChar char="•"/>
+            </a:pPr>
+            <a:r>
+              <a:rPr lang="en-US" sz="1160" dirty="0">
+                <a:solidFill>
+                  <a:srgbClr val="122847"/>
+                </a:solidFill>
+                <a:latin typeface="Calibri" pitchFamily="34" charset="0"/>
+                <a:ea typeface="Calibri" pitchFamily="34" charset="-122"/>
+                <a:cs typeface="Calibri" pitchFamily="34" charset="-120"/>
+              </a:rPr>
+              <a:t>Better generalisation to unseen subjects than the heavier baselines</a:t>
+            </a:r>
+            <a:endParaRPr lang="en-US" sz="1160" dirty="0"/>
+          </a:p>
+        </p:txBody>
+      </p:sp>
+      <p:sp>
+        <p:nvSpPr>
+          <p:cNvPr id="8" name="Text 6"/>
+          <p:cNvSpPr txBox="1"/>
+          <p:nvPr/>
+        </p:nvSpPr>
+        <p:spPr>
+          <a:xfrm>
+            <a:off x="1069848" y="2478024"/>
+            <a:ext cx="4709160" cy="548640"/>
+          </a:xfrm>
+          <a:prstGeom prst="rect">
+            <a:avLst/>
+          </a:prstGeom>
+          <a:noFill/>
+          <a:ln/>
+        </p:spPr>
+        <p:txBody>
+          <a:bodyPr wrap="square" lIns="0" tIns="0" rIns="0" bIns="0" rtlCol="0" anchor="t"/>
+          <a:lstStyle/>
+          <a:p>
+            <a:pPr marL="342900" indent="-342900">
+              <a:buSzPct val="100000"/>
+              <a:buChar char="•"/>
+            </a:pPr>
+            <a:r>
+              <a:rPr lang="en-US" sz="1160" dirty="0">
+                <a:solidFill>
+                  <a:srgbClr val="122847"/>
+                </a:solidFill>
+                <a:latin typeface="Calibri" pitchFamily="34" charset="0"/>
+                <a:ea typeface="Calibri" pitchFamily="34" charset="-122"/>
+                <a:cs typeface="Calibri" pitchFamily="34" charset="-120"/>
+              </a:rPr>
+              <a:t>Competitive motor imagery classification accuracy</a:t>
+            </a:r>
+            <a:endParaRPr lang="en-US" sz="1160" dirty="0"/>
+          </a:p>
+        </p:txBody>
+      </p:sp>
+      <p:sp>
+        <p:nvSpPr>
+          <p:cNvPr id="9" name="Text 7"/>
+          <p:cNvSpPr txBox="1"/>
+          <p:nvPr/>
+        </p:nvSpPr>
+        <p:spPr>
+          <a:xfrm>
+            <a:off x="1069848" y="3081528"/>
+            <a:ext cx="4709160" cy="548640"/>
+          </a:xfrm>
+          <a:prstGeom prst="rect">
+            <a:avLst/>
+          </a:prstGeom>
+          <a:noFill/>
+          <a:ln/>
+        </p:spPr>
+        <p:txBody>
+          <a:bodyPr wrap="square" lIns="0" tIns="0" rIns="0" bIns="0" rtlCol="0" anchor="t"/>
+          <a:lstStyle/>
+          <a:p>
+            <a:pPr marL="342900" indent="-342900">
+              <a:buSzPct val="100000"/>
+              <a:buChar char="•"/>
+            </a:pPr>
+            <a:r>
+              <a:rPr lang="en-US" sz="1160" dirty="0">
+                <a:solidFill>
+                  <a:srgbClr val="122847"/>
+                </a:solidFill>
+                <a:latin typeface="Calibri" pitchFamily="34" charset="0"/>
+                <a:ea typeface="Calibri" pitchFamily="34" charset="-122"/>
+                <a:cs typeface="Calibri" pitchFamily="34" charset="-120"/>
+              </a:rPr>
+              <a:t>A lightweight architecture — 20,996 parameters, about one fifth the size of ATCNet</a:t>
+            </a:r>
+            <a:endParaRPr lang="en-US" sz="1160" dirty="0"/>
+          </a:p>
+        </p:txBody>
+      </p:sp>
+      <p:sp>
+        <p:nvSpPr>
+          <p:cNvPr id="10" name="Text 8"/>
+          <p:cNvSpPr txBox="1"/>
+          <p:nvPr/>
+        </p:nvSpPr>
+        <p:spPr>
+          <a:xfrm>
+            <a:off x="1069848" y="3685032"/>
+            <a:ext cx="4709160" cy="548640"/>
+          </a:xfrm>
+          <a:prstGeom prst="rect">
+            <a:avLst/>
+          </a:prstGeom>
+          <a:noFill/>
+          <a:ln/>
+        </p:spPr>
+        <p:txBody>
+          <a:bodyPr wrap="square" lIns="0" tIns="0" rIns="0" bIns="0" rtlCol="0" anchor="t"/>
+          <a:lstStyle/>
+          <a:p>
+            <a:pPr marL="342900" indent="-342900">
+              <a:buSzPct val="100000"/>
+              <a:buChar char="•"/>
+            </a:pPr>
+            <a:r>
+              <a:rPr lang="en-US" sz="1160" dirty="0">
+                <a:solidFill>
+                  <a:srgbClr val="122847"/>
+                </a:solidFill>
+                <a:latin typeface="Calibri" pitchFamily="34" charset="0"/>
+                <a:ea typeface="Calibri" pitchFamily="34" charset="-122"/>
+                <a:cs typeface="Calibri" pitchFamily="34" charset="-120"/>
+              </a:rPr>
+              <a:t>Reduced dependence on subject-specific calibration</a:t>
+            </a:r>
+            <a:endParaRPr lang="en-US" sz="1160" dirty="0"/>
+          </a:p>
+        </p:txBody>
+      </p:sp>
+      <p:sp>
+        <p:nvSpPr>
+          <p:cNvPr id="11" name="Shape 9"/>
+          <p:cNvSpPr/>
+          <p:nvPr/>
+        </p:nvSpPr>
+        <p:spPr>
+          <a:xfrm>
+            <a:off x="6172200" y="1325880"/>
+            <a:ext cx="5422392" cy="3246120"/>
+          </a:xfrm>
+          <a:prstGeom prst="roundRect">
+            <a:avLst>
+              <a:gd name="adj" fmla="val 1972"/>
+            </a:avLst>
+          </a:prstGeom>
+          <a:solidFill>
+            <a:srgbClr val="F1EDF9"/>
+          </a:solidFill>
+          <a:ln w="12700">
+            <a:solidFill>
+              <a:srgbClr val="F1EDF9"/>
+            </a:solidFill>
+            <a:prstDash val="solid"/>
+          </a:ln>
+        </p:spPr>
+      </p:sp>
+      <p:sp>
+        <p:nvSpPr>
+          <p:cNvPr id="12" name="Text 10"/>
+          <p:cNvSpPr txBox="1"/>
+          <p:nvPr/>
+        </p:nvSpPr>
+        <p:spPr>
+          <a:xfrm>
+            <a:off x="6428232" y="1481328"/>
+            <a:ext cx="4937760" cy="292608"/>
+          </a:xfrm>
+          <a:prstGeom prst="rect">
+            <a:avLst/>
+          </a:prstGeom>
+          <a:noFill/>
+          <a:ln/>
+        </p:spPr>
+        <p:txBody>
+          <a:bodyPr wrap="square" lIns="0" tIns="0" rIns="0" bIns="0" rtlCol="0" anchor="ctr"/>
+          <a:lstStyle/>
+          <a:p>
+            <a:pPr indent="0" marL="0">
+              <a:buNone/>
+            </a:pPr>
+            <a:r>
+              <a:rPr lang="en-US" sz="1300" b="1" dirty="0">
+                <a:solidFill>
+                  <a:srgbClr val="5B3E96"/>
+                </a:solidFill>
+                <a:latin typeface="Calibri" pitchFamily="34" charset="0"/>
+                <a:ea typeface="Calibri" pitchFamily="34" charset="-122"/>
+                <a:cs typeface="Calibri" pitchFamily="34" charset="-120"/>
+              </a:rPr>
+              <a:t>What the project contributes</a:t>
+            </a:r>
+            <a:endParaRPr lang="en-US" sz="1300" dirty="0"/>
+          </a:p>
+        </p:txBody>
+      </p:sp>
+      <p:sp>
+        <p:nvSpPr>
+          <p:cNvPr id="13" name="Text 11"/>
+          <p:cNvSpPr txBox="1"/>
+          <p:nvPr/>
+        </p:nvSpPr>
+        <p:spPr>
+          <a:xfrm>
+            <a:off x="6675120" y="1874520"/>
+            <a:ext cx="4709160" cy="548640"/>
+          </a:xfrm>
+          <a:prstGeom prst="rect">
+            <a:avLst/>
+          </a:prstGeom>
+          <a:noFill/>
+          <a:ln/>
+        </p:spPr>
+        <p:txBody>
+          <a:bodyPr wrap="square" lIns="0" tIns="0" rIns="0" bIns="0" rtlCol="0" anchor="t"/>
+          <a:lstStyle/>
+          <a:p>
+            <a:pPr marL="342900" indent="-342900">
+              <a:buSzPct val="100000"/>
+              <a:buChar char="•"/>
+            </a:pPr>
+            <a:r>
+              <a:rPr lang="en-US" sz="1160" dirty="0">
+                <a:solidFill>
+                  <a:srgbClr val="122847"/>
+                </a:solidFill>
+                <a:latin typeface="Calibri" pitchFamily="34" charset="0"/>
+                <a:ea typeface="Calibri" pitchFamily="34" charset="-122"/>
+                <a:cs typeface="Calibri" pitchFamily="34" charset="-120"/>
+              </a:rPr>
+              <a:t>A comparison of all four architectures under one identical LOSO protocol</a:t>
+            </a:r>
+            <a:endParaRPr lang="en-US" sz="1160" dirty="0"/>
+          </a:p>
+        </p:txBody>
+      </p:sp>
+      <p:sp>
+        <p:nvSpPr>
+          <p:cNvPr id="14" name="Text 12"/>
+          <p:cNvSpPr txBox="1"/>
+          <p:nvPr/>
+        </p:nvSpPr>
+        <p:spPr>
+          <a:xfrm>
+            <a:off x="6675120" y="2478024"/>
+            <a:ext cx="4709160" cy="548640"/>
+          </a:xfrm>
+          <a:prstGeom prst="rect">
+            <a:avLst/>
+          </a:prstGeom>
+          <a:noFill/>
+          <a:ln/>
+        </p:spPr>
+        <p:txBody>
+          <a:bodyPr wrap="square" lIns="0" tIns="0" rIns="0" bIns="0" rtlCol="0" anchor="t"/>
+          <a:lstStyle/>
+          <a:p>
+            <a:pPr marL="342900" indent="-342900">
+              <a:buSzPct val="100000"/>
+              <a:buChar char="•"/>
+            </a:pPr>
+            <a:r>
+              <a:rPr lang="en-US" sz="1160" dirty="0">
+                <a:solidFill>
+                  <a:srgbClr val="122847"/>
+                </a:solidFill>
+                <a:latin typeface="Calibri" pitchFamily="34" charset="0"/>
+                <a:ea typeface="Calibri" pitchFamily="34" charset="-122"/>
+                <a:cs typeface="Calibri" pitchFamily="34" charset="-120"/>
+              </a:rPr>
+              <a:t>A specific lightweight combination, with attention depth reduced to suit the dataset size</a:t>
+            </a:r>
+            <a:endParaRPr lang="en-US" sz="1160" dirty="0"/>
+          </a:p>
+        </p:txBody>
+      </p:sp>
+      <p:sp>
+        <p:nvSpPr>
+          <p:cNvPr id="15" name="Text 13"/>
+          <p:cNvSpPr txBox="1"/>
+          <p:nvPr/>
+        </p:nvSpPr>
+        <p:spPr>
+          <a:xfrm>
+            <a:off x="6675120" y="3081528"/>
+            <a:ext cx="4709160" cy="548640"/>
+          </a:xfrm>
+          <a:prstGeom prst="rect">
+            <a:avLst/>
+          </a:prstGeom>
+          <a:noFill/>
+          <a:ln/>
+        </p:spPr>
+        <p:txBody>
+          <a:bodyPr wrap="square" lIns="0" tIns="0" rIns="0" bIns="0" rtlCol="0" anchor="t"/>
+          <a:lstStyle/>
+          <a:p>
+            <a:pPr marL="342900" indent="-342900">
+              <a:buSzPct val="100000"/>
+              <a:buChar char="•"/>
+            </a:pPr>
+            <a:r>
+              <a:rPr lang="en-US" sz="1160" dirty="0">
+                <a:solidFill>
+                  <a:srgbClr val="122847"/>
+                </a:solidFill>
+                <a:latin typeface="Calibri" pitchFamily="34" charset="0"/>
+                <a:ea typeface="Calibri" pitchFamily="34" charset="-122"/>
+                <a:cs typeface="Calibri" pitchFamily="34" charset="-120"/>
+              </a:rPr>
+              <a:t>A component-wise study showing what each part contributes to cross-subject accuracy</a:t>
+            </a:r>
+            <a:endParaRPr lang="en-US" sz="1160" dirty="0"/>
+          </a:p>
+        </p:txBody>
+      </p:sp>
+      <p:sp>
+        <p:nvSpPr>
+          <p:cNvPr id="16" name="Text 14"/>
+          <p:cNvSpPr txBox="1"/>
+          <p:nvPr/>
+        </p:nvSpPr>
+        <p:spPr>
+          <a:xfrm>
+            <a:off x="6675120" y="3685032"/>
+            <a:ext cx="4709160" cy="548640"/>
+          </a:xfrm>
+          <a:prstGeom prst="rect">
+            <a:avLst/>
+          </a:prstGeom>
+          <a:noFill/>
+          <a:ln/>
+        </p:spPr>
+        <p:txBody>
+          <a:bodyPr wrap="square" lIns="0" tIns="0" rIns="0" bIns="0" rtlCol="0" anchor="t"/>
+          <a:lstStyle/>
+          <a:p>
+            <a:pPr marL="342900" indent="-342900">
+              <a:buSzPct val="100000"/>
+              <a:buChar char="•"/>
+            </a:pPr>
+            <a:r>
+              <a:rPr lang="en-US" sz="1160" dirty="0">
+                <a:solidFill>
+                  <a:srgbClr val="122847"/>
+                </a:solidFill>
+                <a:latin typeface="Calibri" pitchFamily="34" charset="0"/>
+                <a:ea typeface="Calibri" pitchFamily="34" charset="-122"/>
+                <a:cs typeface="Calibri" pitchFamily="34" charset="-120"/>
+              </a:rPr>
+              <a:t>Accuracy measured against parameter count under a single protocol</a:t>
+            </a:r>
+            <a:endParaRPr lang="en-US" sz="1160" dirty="0"/>
+          </a:p>
+        </p:txBody>
+      </p:sp>
+      <p:sp>
+        <p:nvSpPr>
+          <p:cNvPr id="17" name="Shape 15"/>
+          <p:cNvSpPr/>
+          <p:nvPr/>
+        </p:nvSpPr>
+        <p:spPr>
+          <a:xfrm>
+            <a:off x="566928" y="4754880"/>
+            <a:ext cx="11027664" cy="1143000"/>
+          </a:xfrm>
+          <a:prstGeom prst="roundRect">
+            <a:avLst>
+              <a:gd name="adj" fmla="val 5600"/>
+            </a:avLst>
+          </a:prstGeom>
+          <a:solidFill>
+            <a:srgbClr val="122847"/>
+          </a:solidFill>
+          <a:ln w="12700">
+            <a:solidFill>
+              <a:srgbClr val="333333"/>
+            </a:solidFill>
+            <a:prstDash val="solid"/>
+          </a:ln>
+        </p:spPr>
+      </p:sp>
+      <p:sp>
+        <p:nvSpPr>
+          <p:cNvPr id="18" name="Text 16"/>
+          <p:cNvSpPr txBox="1"/>
+          <p:nvPr/>
+        </p:nvSpPr>
+        <p:spPr>
+          <a:xfrm>
+            <a:off x="886968" y="4901184"/>
+            <a:ext cx="10424160" cy="292608"/>
+          </a:xfrm>
+          <a:prstGeom prst="rect">
+            <a:avLst/>
+          </a:prstGeom>
+          <a:noFill/>
+          <a:ln/>
+        </p:spPr>
+        <p:txBody>
+          <a:bodyPr wrap="square" lIns="0" tIns="0" rIns="0" bIns="0" rtlCol="0" anchor="ctr"/>
+          <a:lstStyle/>
+          <a:p>
+            <a:pPr indent="0" marL="0">
+              <a:buNone/>
+            </a:pPr>
+            <a:r>
+              <a:rPr lang="en-US" sz="1300" b="1" dirty="0">
+                <a:solidFill>
+                  <a:srgbClr val="C9D6EC"/>
+                </a:solidFill>
+                <a:latin typeface="Calibri" pitchFamily="34" charset="0"/>
+                <a:ea typeface="Calibri" pitchFamily="34" charset="-122"/>
+                <a:cs typeface="Calibri" pitchFamily="34" charset="-120"/>
+              </a:rPr>
+              <a:t>These are expected outcomes, not results.</a:t>
+            </a:r>
+            <a:endParaRPr lang="en-US" sz="1300" dirty="0"/>
+          </a:p>
+        </p:txBody>
+      </p:sp>
+      <p:sp>
+        <p:nvSpPr>
+          <p:cNvPr id="19" name="Text 17"/>
+          <p:cNvSpPr txBox="1"/>
+          <p:nvPr/>
+        </p:nvSpPr>
+        <p:spPr>
+          <a:xfrm>
+            <a:off x="886968" y="5193792"/>
+            <a:ext cx="10424160" cy="566928"/>
+          </a:xfrm>
+          <a:prstGeom prst="rect">
+            <a:avLst/>
+          </a:prstGeom>
+          <a:noFill/>
+          <a:ln/>
+        </p:spPr>
+        <p:txBody>
+          <a:bodyPr wrap="square" lIns="0" tIns="0" rIns="0" bIns="0" rtlCol="0" anchor="t"/>
+          <a:lstStyle/>
+          <a:p>
+            <a:pPr indent="0" marL="0">
+              <a:buNone/>
+            </a:pPr>
+            <a:r>
+              <a:rPr lang="en-US" sz="1180" dirty="0">
+                <a:solidFill>
+                  <a:srgbClr val="FFFFFF"/>
+                </a:solidFill>
+                <a:latin typeface="Calibri" pitchFamily="34" charset="0"/>
+                <a:ea typeface="Calibri" pitchFamily="34" charset="-122"/>
+                <a:cs typeface="Calibri" pitchFamily="34" charset="-120"/>
+              </a:rPr>
+              <a:t>No experiments have been run at this stage. The individual components are all taken from published work; what is proposed is the particular combination, the subject-independent evaluation, and the study of what each component contributes.</a:t>
+            </a:r>
+            <a:endParaRPr lang="en-US" sz="1180" dirty="0"/>
+          </a:p>
+        </p:txBody>
+      </p:sp>
+    </p:spTree>
+  </p:cSld>
+  <p:clrMapOvr>
+    <a:masterClrMapping/>
+  </p:clrMapOvr>
+</p:sld>
+</file>
+
+<file path=ppt/slides/slide13.xml><?xml version="1.0" encoding="utf-8"?>
+<p:sld xmlns:a="http://schemas.openxmlformats.org/drawingml/2006/main" xmlns:r="http://schemas.openxmlformats.org/officeDocument/2006/relationships" xmlns:p="http://schemas.openxmlformats.org/presentationml/2006/main">
+  <p:cSld name="Slide 13">
+    <p:bg>
+      <p:bgPr>
+        <a:solidFill>
+          <a:srgbClr val="FFFFFF"/>
+        </a:solidFill>
+      </p:bgPr>
+    </p:bg>
+    <p:spTree>
+      <p:nvGrpSpPr>
+        <p:cNvPr id="1" name=""/>
+        <p:cNvGrpSpPr/>
+        <p:nvPr/>
+      </p:nvGrpSpPr>
+      <p:grpSpPr>
+        <a:xfrm>
+          <a:off x="0" y="0"/>
+          <a:ext cx="0" cy="0"/>
+          <a:chOff x="0" y="0"/>
+          <a:chExt cx="0" cy="0"/>
+        </a:xfrm>
+      </p:grpSpPr>
+      <p:sp>
+        <p:nvSpPr>
+          <p:cNvPr id="2" name="Text 0"/>
+          <p:cNvSpPr txBox="1"/>
+          <p:nvPr/>
+        </p:nvSpPr>
+        <p:spPr>
+          <a:xfrm>
+            <a:off x="566928" y="329184"/>
+            <a:ext cx="11027664" cy="219456"/>
+          </a:xfrm>
+          <a:prstGeom prst="rect">
+            <a:avLst/>
+          </a:prstGeom>
+          <a:noFill/>
+          <a:ln/>
+        </p:spPr>
+        <p:txBody>
+          <a:bodyPr wrap="square" lIns="0" tIns="0" rIns="0" bIns="0" rtlCol="0" anchor="ctr"/>
+          <a:lstStyle/>
+          <a:p>
+            <a:pPr indent="0" marL="0">
+              <a:buNone/>
+            </a:pPr>
+            <a:r>
+              <a:rPr lang="en-US" sz="1050" b="1" spc="160" kern="0" dirty="0">
+                <a:solidFill>
+                  <a:srgbClr val="5B3E96"/>
+                </a:solidFill>
+                <a:latin typeface="Calibri" pitchFamily="34" charset="0"/>
+                <a:ea typeface="Calibri" pitchFamily="34" charset="-122"/>
+                <a:cs typeface="Calibri" pitchFamily="34" charset="-120"/>
+              </a:rPr>
               <a:t>PHASE 3, 16 SEPTEMBER TO 3 OCTOBER</a:t>
             </a:r>
             <a:endParaRPr lang="en-US" sz="1050" dirty="0"/>
@@ -3892,7 +6987,7 @@
                 <a:ea typeface="Calibri" pitchFamily="34" charset="-122"/>
                 <a:cs typeface="Calibri" pitchFamily="34" charset="-120"/>
               </a:rPr>
-              <a:t>12</a:t>
+              <a:t>13</a:t>
             </a:r>
             <a:endParaRPr lang="en-US" sz="1000" dirty="0"/>
           </a:p>
@@ -12658,7 +15753,7 @@
                 <a:ea typeface="Calibri" pitchFamily="34" charset="-122"/>
                 <a:cs typeface="Calibri" pitchFamily="34" charset="-120"/>
               </a:rPr>
-              <a:t>Published accuracies are not shown side by side here because each paper used a different evaluation protocol, so the figures cannot be ranked against one another. Re-running all four under one leave-one-subject-out protocol is part of this project.</a:t>
+              <a:t>Published accuracies follow on the next slide, split by protocol: cross-subject results measured under one shared protocol, and within-subject figures that come from different protocols and cannot be ranked against each other.</a:t>
             </a:r>
             <a:endParaRPr lang="en-US" sz="1180" dirty="0"/>
           </a:p>

</xml_diff>